<commit_message>
fix(course): properly rewrite L004, add no-filler-sections rule
L004 "Numbers 0 to 10" completely rewritten:
- s1: Digits 0-5 (listen, repeat, room number scenarios)
- s2: Digits 6-10 (listen, repeat, floor/queue scenarios)
- s3: Chunks (เบอร์อะไร, age pattern with ปี, brief ขวบ mention)
- s4: Pronunciation beat (สี่ vs สี minimal pair)
- Removed filler section that only recycled review vocab
- Age uses ปี primarily (adult learners), ขวบ mentioned for awareness
- Roleplay uses adult age (30) not child age (8/10)

Skill & prompt rules added:
- "Every section's languageFocus must contain NEW blueprint items"
- "Do not create filler sections with review-only vocab as focus"
- Review vocab goes into drills/roleplay naturally, not as section focus

Co-Authored-By: Claude Opus 4.6 (1M context) <noreply@anthropic.com>

Former-commit-id: 7b6eefefd29c09149f5b715b5e25defd942cfc48
Former-commit-id: a47cc53986e6b221d22859239031a7608c402b5b
Former-commit-id: 9c511929c670a3b0ea02506dd058466d3fcd1b5e
</commit_message>
<xml_diff>
--- a/course/modules/M01/L004/M01-L004-canva-deck.pptx
+++ b/course/modules/M01/L004/M01-L004-canva-deck.pptx
@@ -14,7 +14,6 @@
     <p:sldId id="262" r:id="rId13"/>
     <p:sldId id="263" r:id="rId14"/>
     <p:sldId id="264" r:id="rId15"/>
-    <p:sldId id="265" r:id="rId16"/>
   </p:sldIdLst>
   <p:sldSz cx="12191695" cy="6858000" type="screen4x3"/>
   <p:notesSz cx="6858000" cy="9144000"/>
@@ -3334,290 +3333,6 @@
 </p:sld>
 </file>
 
-<file path=ppt/slides/slide10.xml><?xml version="1.0" encoding="utf-8"?>
-<p:sld xmlns:a="http://schemas.openxmlformats.org/drawingml/2006/main" xmlns:p="http://schemas.openxmlformats.org/presentationml/2006/main" xmlns:r="http://schemas.openxmlformats.org/officeDocument/2006/relationships">
-  <p:cSld>
-    <p:spTree>
-      <p:nvGrpSpPr>
-        <p:cNvPr id="1" name=""/>
-        <p:cNvGrpSpPr/>
-        <p:nvPr/>
-      </p:nvGrpSpPr>
-      <p:grpSpPr/>
-      <p:pic>
-        <p:nvPicPr>
-          <p:cNvPr id="2" name="Picture 1" descr="slide-01.png"/>
-          <p:cNvPicPr>
-            <a:picLocks noChangeAspect="1"/>
-          </p:cNvPicPr>
-          <p:nvPr/>
-        </p:nvPicPr>
-        <p:blipFill>
-          <a:blip r:embed="rId2"/>
-          <a:stretch>
-            <a:fillRect/>
-          </a:stretch>
-        </p:blipFill>
-        <p:spPr>
-          <a:xfrm>
-            <a:off x="0" y="0"/>
-            <a:ext cx="12191695" cy="6858000"/>
-          </a:xfrm>
-          <a:prstGeom prst="rect">
-            <a:avLst/>
-          </a:prstGeom>
-        </p:spPr>
-      </p:pic>
-      <p:sp>
-        <p:nvSpPr>
-          <p:cNvPr id="3" name="TextBox 2"/>
-          <p:cNvSpPr txBox="1"/>
-          <p:nvPr/>
-        </p:nvSpPr>
-        <p:spPr>
-          <a:xfrm>
-            <a:off x="731520" y="1371600"/>
-            <a:ext cx="6858000" cy="365760"/>
-          </a:xfrm>
-          <a:prstGeom prst="rect">
-            <a:avLst/>
-          </a:prstGeom>
-          <a:noFill/>
-        </p:spPr>
-        <p:txBody>
-          <a:bodyPr wrap="square" anchor="t">
-            <a:spAutoFit/>
-          </a:bodyPr>
-          <a:lstStyle/>
-          <a:p>
-            <a:pPr algn="l"/>
-            <a:r>
-              <a:rPr sz="1900" b="0" i="0" lang="en-US" altLang="en-US">
-                <a:solidFill>
-                  <a:srgbClr val="566873"/>
-                </a:solidFill>
-                <a:latin typeface="Sarabun"/>
-                <a:ea typeface="Sarabun"/>
-                <a:cs typeface="Sarabun"/>
-              </a:rPr>
-              <a:t>M01-L004</a:t>
-            </a:r>
-          </a:p>
-        </p:txBody>
-      </p:sp>
-      <p:sp>
-        <p:nvSpPr>
-          <p:cNvPr id="4" name="TextBox 3"/>
-          <p:cNvSpPr txBox="1"/>
-          <p:nvPr/>
-        </p:nvSpPr>
-        <p:spPr>
-          <a:xfrm>
-            <a:off x="731520" y="1920240"/>
-            <a:ext cx="6858000" cy="914400"/>
-          </a:xfrm>
-          <a:prstGeom prst="rect">
-            <a:avLst/>
-          </a:prstGeom>
-          <a:noFill/>
-        </p:spPr>
-        <p:txBody>
-          <a:bodyPr wrap="square" anchor="t">
-            <a:spAutoFit/>
-          </a:bodyPr>
-          <a:lstStyle/>
-          <a:p>
-            <a:pPr algn="l"/>
-            <a:r>
-              <a:rPr sz="3800" b="1" i="0" lang="en-US" altLang="en-US">
-                <a:solidFill>
-                  <a:srgbClr val="24333D"/>
-                </a:solidFill>
-                <a:latin typeface="Sarabun"/>
-                <a:ea typeface="Sarabun"/>
-                <a:cs typeface="Sarabun"/>
-              </a:rPr>
-              <a:t>Closing</a:t>
-            </a:r>
-          </a:p>
-        </p:txBody>
-      </p:sp>
-      <p:sp>
-        <p:nvSpPr>
-          <p:cNvPr id="5" name="TextBox 4"/>
-          <p:cNvSpPr txBox="1"/>
-          <p:nvPr/>
-        </p:nvSpPr>
-        <p:spPr>
-          <a:xfrm>
-            <a:off x="731520" y="3200400"/>
-            <a:ext cx="6858000" cy="411480"/>
-          </a:xfrm>
-          <a:prstGeom prst="rect">
-            <a:avLst/>
-          </a:prstGeom>
-          <a:noFill/>
-        </p:spPr>
-        <p:txBody>
-          <a:bodyPr wrap="square" anchor="t">
-            <a:spAutoFit/>
-          </a:bodyPr>
-          <a:lstStyle/>
-          <a:p>
-            <a:pPr algn="l"/>
-            <a:r>
-              <a:rPr sz="1600" b="0" i="0" lang="en-US" altLang="en-US">
-                <a:solidFill>
-                  <a:srgbClr val="24333D"/>
-                </a:solidFill>
-                <a:latin typeface="Sarabun"/>
-                <a:ea typeface="Sarabun"/>
-                <a:cs typeface="Sarabun"/>
-              </a:rPr>
-              <a:t>By the end, you can hear, repeat, and produce Thai digits 0-10 in room-number, counting, and simple age exchanges.</a:t>
-            </a:r>
-          </a:p>
-        </p:txBody>
-      </p:sp>
-      <p:sp>
-        <p:nvSpPr>
-          <p:cNvPr id="6" name="TextBox 5"/>
-          <p:cNvSpPr txBox="1"/>
-          <p:nvPr/>
-        </p:nvSpPr>
-        <p:spPr>
-          <a:xfrm>
-            <a:off x="731520" y="3657600"/>
-            <a:ext cx="6858000" cy="411480"/>
-          </a:xfrm>
-          <a:prstGeom prst="rect">
-            <a:avLst/>
-          </a:prstGeom>
-          <a:noFill/>
-        </p:spPr>
-        <p:txBody>
-          <a:bodyPr wrap="square" anchor="t">
-            <a:spAutoFit/>
-          </a:bodyPr>
-          <a:lstStyle/>
-          <a:p>
-            <a:pPr algn="l"/>
-            <a:r>
-              <a:rPr sz="1600" b="0" i="0" lang="en-US" altLang="en-US">
-                <a:solidFill>
-                  <a:srgbClr val="24333D"/>
-                </a:solidFill>
-                <a:latin typeface="Sarabun"/>
-                <a:ea typeface="Sarabun"/>
-                <a:cs typeface="Sarabun"/>
-              </a:rPr>
-              <a:t>Next: First Contact and Courtesy continues.</a:t>
-            </a:r>
-          </a:p>
-        </p:txBody>
-      </p:sp>
-      <p:sp>
-        <p:nvSpPr>
-          <p:cNvPr id="7" name="TextBox 6"/>
-          <p:cNvSpPr txBox="1"/>
-          <p:nvPr/>
-        </p:nvSpPr>
-        <p:spPr>
-          <a:xfrm>
-            <a:off x="731520" y="5303520"/>
-            <a:ext cx="6858000" cy="365760"/>
-          </a:xfrm>
-          <a:prstGeom prst="rect">
-            <a:avLst/>
-          </a:prstGeom>
-          <a:noFill/>
-        </p:spPr>
-        <p:txBody>
-          <a:bodyPr wrap="square" anchor="t">
-            <a:spAutoFit/>
-          </a:bodyPr>
-          <a:lstStyle/>
-          <a:p>
-            <a:pPr algn="l"/>
-            <a:r>
-              <a:rPr sz="1500" b="0" i="0" lang="en-US" altLang="en-US">
-                <a:solidFill>
-                  <a:srgbClr val="566873"/>
-                </a:solidFill>
-                <a:latin typeface="Sarabun"/>
-                <a:ea typeface="Sarabun"/>
-                <a:cs typeface="Sarabun"/>
-              </a:rPr>
-              <a:t>Immersion Thai with Nine</a:t>
-            </a:r>
-          </a:p>
-        </p:txBody>
-      </p:sp>
-      <p:sp>
-        <p:nvSpPr>
-          <p:cNvPr id="8" name="__pip_placeholder__"/>
-          <p:cNvSpPr/>
-          <p:nvPr/>
-        </p:nvSpPr>
-        <p:spPr>
-          <a:xfrm>
-            <a:off x="8351215" y="0"/>
-            <a:ext cx="3840480" cy="2880360"/>
-          </a:xfrm>
-          <a:prstGeom prst="rect">
-            <a:avLst/>
-          </a:prstGeom>
-          <a:solidFill>
-            <a:srgbClr val="DBE7EC">
-              <a:alpha val="30000"/>
-            </a:srgbClr>
-          </a:solidFill>
-          <a:ln w="19050">
-            <a:solidFill>
-              <a:srgbClr val="355C7D"/>
-            </a:solidFill>
-            <a:prstDash val="sysDash"/>
-          </a:ln>
-        </p:spPr>
-        <p:style>
-          <a:lnRef idx="1">
-            <a:schemeClr val="accent1"/>
-          </a:lnRef>
-          <a:fillRef idx="3">
-            <a:schemeClr val="accent1"/>
-          </a:fillRef>
-          <a:effectRef idx="2">
-            <a:schemeClr val="accent1"/>
-          </a:effectRef>
-          <a:fontRef idx="minor">
-            <a:schemeClr val="lt1"/>
-          </a:fontRef>
-        </p:style>
-        <p:txBody>
-          <a:bodyPr rtlCol="0" anchor="ctr" wrap="none"/>
-          <a:lstStyle/>
-          <a:p>
-            <a:pPr algn="ctr"/>
-            <a:r>
-              <a:rPr sz="1800" b="1">
-                <a:solidFill>
-                  <a:srgbClr val="355C7D"/>
-                </a:solidFill>
-                <a:latin typeface="Sarabun"/>
-              </a:rPr>
-              <a:t>Nine</a:t>
-            </a:r>
-          </a:p>
-        </p:txBody>
-      </p:sp>
-    </p:spTree>
-  </p:cSld>
-  <p:clrMapOvr>
-    <a:masterClrMapping/>
-  </p:clrMapOvr>
-</p:sld>
-</file>
-
 <file path=ppt/slides/slide2.xml><?xml version="1.0" encoding="utf-8"?>
 <p:sld xmlns:a="http://schemas.openxmlformats.org/drawingml/2006/main" xmlns:p="http://schemas.openxmlformats.org/presentationml/2006/main" xmlns:r="http://schemas.openxmlformats.org/officeDocument/2006/relationships">
   <p:cSld>
@@ -4005,7 +3720,7 @@
                 <a:ea typeface="Sarabun"/>
                 <a:cs typeface="Sarabun"/>
               </a:rPr>
-              <a:t>The first six digits: 0 to 5</a:t>
+              <a:t>Digits 0 to 5</a:t>
             </a:r>
           </a:p>
         </p:txBody>
@@ -4127,7 +3842,7 @@
                 <a:ea typeface="Sarabun"/>
                 <a:cs typeface="Sarabun"/>
               </a:rPr>
-              <a:t>ศูนย์ | sǔun | zero</a:t>
+              <a:t>ศูนย์ | sǔun | 0 — zero</a:t>
             </a:r>
           </a:p>
           <a:p>
@@ -4141,7 +3856,7 @@
                 <a:ea typeface="Sarabun"/>
                 <a:cs typeface="Sarabun"/>
               </a:rPr>
-              <a:t>หนึ่ง | nùeng | one</a:t>
+              <a:t>หนึ่ง | nùeng | 1 — one</a:t>
             </a:r>
           </a:p>
         </p:txBody>
@@ -4314,7 +4029,7 @@
                 <a:ea typeface="Sarabun"/>
                 <a:cs typeface="Sarabun"/>
               </a:rPr>
-              <a:t>Finish the set: 6 to 10</a:t>
+              <a:t>Digits 6 to 10</a:t>
             </a:r>
           </a:p>
         </p:txBody>
@@ -4436,7 +4151,7 @@
                 <a:ea typeface="Sarabun"/>
                 <a:cs typeface="Sarabun"/>
               </a:rPr>
-              <a:t>หก | hòk | six</a:t>
+              <a:t>หก | hòk | 6 — six</a:t>
             </a:r>
           </a:p>
           <a:p>
@@ -4450,7 +4165,7 @@
                 <a:ea typeface="Sarabun"/>
                 <a:cs typeface="Sarabun"/>
               </a:rPr>
-              <a:t>เจ็ด | jèt | seven</a:t>
+              <a:t>เจ็ด | jèt | 7 — seven</a:t>
             </a:r>
           </a:p>
         </p:txBody>
@@ -4562,7 +4277,7 @@
         </p:nvSpPr>
         <p:spPr>
           <a:xfrm>
-            <a:off x="731527" y="694913"/>
+            <a:off x="731527" y="642588"/>
             <a:ext cx="1210500" cy="320100"/>
           </a:xfrm>
           <a:prstGeom prst="rect">
@@ -4599,7 +4314,7 @@
         </p:nvSpPr>
         <p:spPr>
           <a:xfrm>
-            <a:off x="2063268" y="552443"/>
+            <a:off x="2063268" y="505418"/>
             <a:ext cx="5943600" cy="457200"/>
           </a:xfrm>
           <a:prstGeom prst="rect">
@@ -4636,7 +4351,7 @@
         </p:nvSpPr>
         <p:spPr>
           <a:xfrm>
-            <a:off x="731520" y="1051560"/>
+            <a:off x="731520" y="1075703"/>
             <a:ext cx="6858000" cy="365700"/>
           </a:xfrm>
           <a:prstGeom prst="rect">
@@ -4660,7 +4375,73 @@
                 <a:ea typeface="Sarabun"/>
                 <a:cs typeface="Sarabun"/>
               </a:rPr>
-              <a:t>Anchor digit use in a real-world number context and show the age pattern as a fill-in frame.</a:t>
+              <a:t>Show the two practical patterns: </a:t>
+            </a:r>
+            <a:r>
+              <a:rPr sz="1500" b="0" i="0" lang="th-TH" altLang="en-US">
+                <a:solidFill>
+                  <a:srgbClr val="566873"/>
+                </a:solidFill>
+                <a:latin typeface="Sarabun"/>
+                <a:ea typeface="Sarabun"/>
+                <a:cs typeface="Sarabun"/>
+              </a:rPr>
+              <a:t>เบอร์อะไร</a:t>
+            </a:r>
+            <a:r>
+              <a:rPr sz="1500" b="0" i="1" lang="en-US" altLang="en-US">
+                <a:solidFill>
+                  <a:srgbClr val="566873"/>
+                </a:solidFill>
+                <a:latin typeface="Sarabun"/>
+                <a:ea typeface="Sarabun"/>
+                <a:cs typeface="Sarabun"/>
+              </a:rPr>
+              <a:t> (ber à-rai)</a:t>
+            </a:r>
+            <a:r>
+              <a:rPr sz="1500" b="0" i="0" lang="en-US" altLang="en-US">
+                <a:solidFill>
+                  <a:srgbClr val="566873"/>
+                </a:solidFill>
+                <a:latin typeface="Sarabun"/>
+                <a:ea typeface="Sarabun"/>
+                <a:cs typeface="Sarabun"/>
+              </a:rPr>
+              <a:t> question and </a:t>
+            </a:r>
+            <a:r>
+              <a:rPr sz="1500" b="0" i="0" lang="th-TH" altLang="en-US">
+                <a:solidFill>
+                  <a:srgbClr val="566873"/>
+                </a:solidFill>
+                <a:latin typeface="Sarabun"/>
+                <a:ea typeface="Sarabun"/>
+                <a:cs typeface="Sarabun"/>
+              </a:rPr>
+              <a:t>อายุ...ปี</a:t>
+            </a:r>
+            <a:r>
+              <a:rPr sz="1500" b="0" i="1" lang="en-US" altLang="en-US">
+                <a:solidFill>
+                  <a:srgbClr val="566873"/>
+                </a:solidFill>
+                <a:latin typeface="Sarabun"/>
+                <a:ea typeface="Sarabun"/>
+                <a:cs typeface="Sarabun"/>
+              </a:rPr>
+              <a:t> (aa-yú ... bpii)</a:t>
+            </a:r>
+            <a:r>
+              <a:rPr sz="1500" b="0" i="0" lang="en-US" altLang="en-US">
+                <a:solidFill>
+                  <a:srgbClr val="566873"/>
+                </a:solidFill>
+                <a:latin typeface="Sarabun"/>
+                <a:ea typeface="Sarabun"/>
+                <a:cs typeface="Sarabun"/>
+              </a:rPr>
+              <a:t> answer frame.</a:t>
             </a:r>
           </a:p>
         </p:txBody>
@@ -4673,8 +4454,8 @@
         </p:nvSpPr>
         <p:spPr>
           <a:xfrm>
-            <a:off x="1097280" y="1659140"/>
-            <a:ext cx="5029200" cy="858203"/>
+            <a:off x="1188720" y="1627632"/>
+            <a:ext cx="3200400" cy="658368"/>
           </a:xfrm>
           <a:prstGeom prst="rect">
             <a:avLst/>
@@ -4689,7 +4470,7 @@
           <a:p>
             <a:pPr algn="l"/>
             <a:r>
-              <a:rPr sz="2700" b="1" i="0" lang="th-TH" altLang="en-US">
+              <a:rPr sz="2300" b="1" i="0" lang="th-TH" altLang="en-US">
                 <a:solidFill>
                   <a:srgbClr val="24333D"/>
                 </a:solidFill>
@@ -4697,10 +4478,10 @@
                 <a:ea typeface="Sarabun"/>
                 <a:cs typeface="Sarabun"/>
               </a:rPr>
-              <a:t>เบอร์อะไร</a:t>
-            </a:r>
-            <a:r>
-              <a:rPr sz="1670" b="0" i="1" lang="en-US" altLang="en-US">
+              <a:t>1. เบอร์อะไร</a:t>
+            </a:r>
+            <a:r>
+              <a:rPr sz="1500" b="0" i="1" lang="en-US" altLang="en-US">
                 <a:solidFill>
                   <a:srgbClr val="566873"/>
                 </a:solidFill>
@@ -4721,8 +4502,8 @@
         </p:nvSpPr>
         <p:spPr>
           <a:xfrm>
-            <a:off x="1097280" y="2475000"/>
-            <a:ext cx="5029200" cy="280000"/>
+            <a:off x="4846320" y="1737360"/>
+            <a:ext cx="2286000" cy="365760"/>
           </a:xfrm>
           <a:prstGeom prst="rect">
             <a:avLst/>
@@ -4737,15 +4518,37 @@
           <a:p>
             <a:pPr algn="l"/>
             <a:r>
-              <a:rPr sz="1500" b="0" i="0" lang="en-US" altLang="en-US">
-                <a:solidFill>
-                  <a:srgbClr val="82909A"/>
-                </a:solidFill>
-                <a:latin typeface="Sarabun"/>
-                <a:ea typeface="Sarabun"/>
-                <a:cs typeface="Sarabun"/>
-              </a:rPr>
-              <a:t>what number?</a:t>
+              <a:rPr sz="1300" b="1" i="0" lang="th-TH" altLang="en-US">
+                <a:solidFill>
+                  <a:srgbClr val="24333D"/>
+                </a:solidFill>
+                <a:latin typeface="Sarabun"/>
+                <a:ea typeface="Sarabun"/>
+                <a:cs typeface="Sarabun"/>
+              </a:rPr>
+              <a:t>เบอร์อะไร</a:t>
+            </a:r>
+            <a:r>
+              <a:rPr sz="1500" b="0" i="1" lang="en-US" altLang="en-US">
+                <a:solidFill>
+                  <a:srgbClr val="566873"/>
+                </a:solidFill>
+                <a:latin typeface="Sarabun"/>
+                <a:ea typeface="Sarabun"/>
+                <a:cs typeface="Sarabun"/>
+              </a:rPr>
+              <a:t> (ber à-rai)</a:t>
+            </a:r>
+            <a:r>
+              <a:rPr sz="1300" b="1" i="0" lang="en-US" altLang="en-US">
+                <a:solidFill>
+                  <a:srgbClr val="24333D"/>
+                </a:solidFill>
+                <a:latin typeface="Sarabun"/>
+                <a:ea typeface="Sarabun"/>
+                <a:cs typeface="Sarabun"/>
+              </a:rPr>
+              <a:t> | ber à-rai | what number?</a:t>
             </a:r>
           </a:p>
         </p:txBody>
@@ -4758,8 +4561,8 @@
         </p:nvSpPr>
         <p:spPr>
           <a:xfrm>
-            <a:off x="1097280" y="3063303"/>
-            <a:ext cx="5029200" cy="845740"/>
+            <a:off x="1188720" y="2478024"/>
+            <a:ext cx="3200400" cy="658368"/>
           </a:xfrm>
           <a:prstGeom prst="rect">
             <a:avLst/>
@@ -4774,7 +4577,7 @@
           <a:p>
             <a:pPr algn="l"/>
             <a:r>
-              <a:rPr sz="2700" b="1" i="0" lang="th-TH" altLang="en-US">
+              <a:rPr sz="2300" b="1" i="0" lang="th-TH" altLang="en-US">
                 <a:solidFill>
                   <a:srgbClr val="24333D"/>
                 </a:solidFill>
@@ -4782,10 +4585,10 @@
                 <a:ea typeface="Sarabun"/>
                 <a:cs typeface="Sarabun"/>
               </a:rPr>
-              <a:t>ฉันอายุ...ปี</a:t>
-            </a:r>
-            <a:r>
-              <a:rPr sz="1670" b="0" i="1" lang="en-US" altLang="en-US">
+              <a:t>2. อายุ</a:t>
+            </a:r>
+            <a:r>
+              <a:rPr sz="1500" b="0" i="1" lang="en-US" altLang="en-US">
                 <a:solidFill>
                   <a:srgbClr val="566873"/>
                 </a:solidFill>
@@ -4793,7 +4596,7 @@
                 <a:ea typeface="Sarabun"/>
                 <a:cs typeface="Sarabun"/>
               </a:rPr>
-              <a:t> (chǎn aa-yú ... bpii)</a:t>
+              <a:t> (aa-yú)</a:t>
             </a:r>
           </a:p>
         </p:txBody>
@@ -4806,8 +4609,8 @@
         </p:nvSpPr>
         <p:spPr>
           <a:xfrm>
-            <a:off x="1097280" y="3865000"/>
-            <a:ext cx="5029200" cy="280000"/>
+            <a:off x="4846320" y="2587752"/>
+            <a:ext cx="2286000" cy="365760"/>
           </a:xfrm>
           <a:prstGeom prst="rect">
             <a:avLst/>
@@ -4822,22 +4625,343 @@
           <a:p>
             <a:pPr algn="l"/>
             <a:r>
-              <a:rPr sz="1500" b="0" i="0" lang="en-US" altLang="en-US">
-                <a:solidFill>
-                  <a:srgbClr val="82909A"/>
-                </a:solidFill>
-                <a:latin typeface="Sarabun"/>
-                <a:ea typeface="Sarabun"/>
-                <a:cs typeface="Sarabun"/>
-              </a:rPr>
-              <a:t>I am ... years old</a:t>
-            </a:r>
-          </a:p>
-        </p:txBody>
-      </p:sp>
-      <p:sp>
-        <p:nvSpPr>
-          <p:cNvPr id="10" name="__pip_placeholder__"/>
+              <a:rPr sz="1300" b="1" i="0" lang="th-TH" altLang="en-US">
+                <a:solidFill>
+                  <a:srgbClr val="24333D"/>
+                </a:solidFill>
+                <a:latin typeface="Sarabun"/>
+                <a:ea typeface="Sarabun"/>
+                <a:cs typeface="Sarabun"/>
+              </a:rPr>
+              <a:t>อายุ...ปี</a:t>
+            </a:r>
+            <a:r>
+              <a:rPr sz="1500" b="0" i="1" lang="en-US" altLang="en-US">
+                <a:solidFill>
+                  <a:srgbClr val="566873"/>
+                </a:solidFill>
+                <a:latin typeface="Sarabun"/>
+                <a:ea typeface="Sarabun"/>
+                <a:cs typeface="Sarabun"/>
+              </a:rPr>
+              <a:t> (aa-yú ... bpii)</a:t>
+            </a:r>
+            <a:r>
+              <a:rPr sz="1300" b="1" i="0" lang="en-US" altLang="en-US">
+                <a:solidFill>
+                  <a:srgbClr val="24333D"/>
+                </a:solidFill>
+                <a:latin typeface="Sarabun"/>
+                <a:ea typeface="Sarabun"/>
+                <a:cs typeface="Sarabun"/>
+              </a:rPr>
+              <a:t> | aa-yú ... bpii | ... years old</a:t>
+            </a:r>
+          </a:p>
+        </p:txBody>
+      </p:sp>
+      <p:sp>
+        <p:nvSpPr>
+          <p:cNvPr id="10" name="TextBox 9"/>
+          <p:cNvSpPr txBox="1"/>
+          <p:nvPr/>
+        </p:nvSpPr>
+        <p:spPr>
+          <a:xfrm>
+            <a:off x="1188720" y="3328416"/>
+            <a:ext cx="3200400" cy="658368"/>
+          </a:xfrm>
+          <a:prstGeom prst="rect">
+            <a:avLst/>
+          </a:prstGeom>
+          <a:noFill/>
+        </p:spPr>
+        <p:txBody>
+          <a:bodyPr wrap="square" anchor="t">
+            <a:spAutoFit/>
+          </a:bodyPr>
+          <a:lstStyle/>
+          <a:p>
+            <a:pPr algn="l"/>
+            <a:r>
+              <a:rPr sz="2300" b="1" i="0" lang="th-TH" altLang="en-US">
+                <a:solidFill>
+                  <a:srgbClr val="24333D"/>
+                </a:solidFill>
+                <a:latin typeface="Sarabun"/>
+                <a:ea typeface="Sarabun"/>
+                <a:cs typeface="Sarabun"/>
+              </a:rPr>
+              <a:t>3. ปี</a:t>
+            </a:r>
+            <a:r>
+              <a:rPr sz="1500" b="0" i="1" lang="en-US" altLang="en-US">
+                <a:solidFill>
+                  <a:srgbClr val="566873"/>
+                </a:solidFill>
+                <a:latin typeface="Sarabun"/>
+                <a:ea typeface="Sarabun"/>
+                <a:cs typeface="Sarabun"/>
+              </a:rPr>
+              <a:t> (bpii)</a:t>
+            </a:r>
+          </a:p>
+        </p:txBody>
+      </p:sp>
+      <p:sp>
+        <p:nvSpPr>
+          <p:cNvPr id="11" name="TextBox 10"/>
+          <p:cNvSpPr txBox="1"/>
+          <p:nvPr/>
+        </p:nvSpPr>
+        <p:spPr>
+          <a:xfrm>
+            <a:off x="4846320" y="3438144"/>
+            <a:ext cx="2286000" cy="365760"/>
+          </a:xfrm>
+          <a:prstGeom prst="rect">
+            <a:avLst/>
+          </a:prstGeom>
+          <a:noFill/>
+        </p:spPr>
+        <p:txBody>
+          <a:bodyPr wrap="square" anchor="t">
+            <a:spAutoFit/>
+          </a:bodyPr>
+          <a:lstStyle/>
+          <a:p>
+            <a:pPr algn="l"/>
+            <a:r>
+              <a:rPr sz="1300" b="1" i="0" lang="th-TH" altLang="en-US">
+                <a:solidFill>
+                  <a:srgbClr val="24333D"/>
+                </a:solidFill>
+                <a:latin typeface="Sarabun"/>
+                <a:ea typeface="Sarabun"/>
+                <a:cs typeface="Sarabun"/>
+              </a:rPr>
+              <a:t>ผมอายุ...ปี</a:t>
+            </a:r>
+            <a:r>
+              <a:rPr sz="1500" b="0" i="1" lang="en-US" altLang="en-US">
+                <a:solidFill>
+                  <a:srgbClr val="566873"/>
+                </a:solidFill>
+                <a:latin typeface="Sarabun"/>
+                <a:ea typeface="Sarabun"/>
+                <a:cs typeface="Sarabun"/>
+              </a:rPr>
+              <a:t> (phǒm aa-yú ... bpii)</a:t>
+            </a:r>
+            <a:r>
+              <a:rPr sz="1300" b="1" i="0" lang="en-US" altLang="en-US">
+                <a:solidFill>
+                  <a:srgbClr val="24333D"/>
+                </a:solidFill>
+                <a:latin typeface="Sarabun"/>
+                <a:ea typeface="Sarabun"/>
+                <a:cs typeface="Sarabun"/>
+              </a:rPr>
+              <a:t> | phǒm aa-yú ... bpii | I am ... years old (male)</a:t>
+            </a:r>
+          </a:p>
+        </p:txBody>
+      </p:sp>
+      <p:sp>
+        <p:nvSpPr>
+          <p:cNvPr id="12" name="TextBox 11"/>
+          <p:cNvSpPr txBox="1"/>
+          <p:nvPr/>
+        </p:nvSpPr>
+        <p:spPr>
+          <a:xfrm>
+            <a:off x="1188720" y="4178808"/>
+            <a:ext cx="3200400" cy="658368"/>
+          </a:xfrm>
+          <a:prstGeom prst="rect">
+            <a:avLst/>
+          </a:prstGeom>
+          <a:noFill/>
+        </p:spPr>
+        <p:txBody>
+          <a:bodyPr wrap="square" anchor="t">
+            <a:spAutoFit/>
+          </a:bodyPr>
+          <a:lstStyle/>
+          <a:p>
+            <a:pPr algn="l"/>
+            <a:r>
+              <a:rPr sz="2300" b="1" i="0" lang="th-TH" altLang="en-US">
+                <a:solidFill>
+                  <a:srgbClr val="24333D"/>
+                </a:solidFill>
+                <a:latin typeface="Sarabun"/>
+                <a:ea typeface="Sarabun"/>
+                <a:cs typeface="Sarabun"/>
+              </a:rPr>
+              <a:t>4. สิบ</a:t>
+            </a:r>
+            <a:r>
+              <a:rPr sz="1500" b="0" i="1" lang="en-US" altLang="en-US">
+                <a:solidFill>
+                  <a:srgbClr val="566873"/>
+                </a:solidFill>
+                <a:latin typeface="Sarabun"/>
+                <a:ea typeface="Sarabun"/>
+                <a:cs typeface="Sarabun"/>
+              </a:rPr>
+              <a:t> (sìp)</a:t>
+            </a:r>
+          </a:p>
+        </p:txBody>
+      </p:sp>
+      <p:sp>
+        <p:nvSpPr>
+          <p:cNvPr id="13" name="TextBox 12"/>
+          <p:cNvSpPr txBox="1"/>
+          <p:nvPr/>
+        </p:nvSpPr>
+        <p:spPr>
+          <a:xfrm>
+            <a:off x="4846320" y="4288536"/>
+            <a:ext cx="2286000" cy="365760"/>
+          </a:xfrm>
+          <a:prstGeom prst="rect">
+            <a:avLst/>
+          </a:prstGeom>
+          <a:noFill/>
+        </p:spPr>
+        <p:txBody>
+          <a:bodyPr wrap="square" anchor="t">
+            <a:spAutoFit/>
+          </a:bodyPr>
+          <a:lstStyle/>
+          <a:p>
+            <a:pPr algn="l"/>
+            <a:r>
+              <a:rPr sz="1300" b="1" i="0" lang="th-TH" altLang="en-US">
+                <a:solidFill>
+                  <a:srgbClr val="24333D"/>
+                </a:solidFill>
+                <a:latin typeface="Sarabun"/>
+                <a:ea typeface="Sarabun"/>
+                <a:cs typeface="Sarabun"/>
+              </a:rPr>
+              <a:t>ฉันอายุ...ปี</a:t>
+            </a:r>
+            <a:r>
+              <a:rPr sz="1500" b="0" i="1" lang="en-US" altLang="en-US">
+                <a:solidFill>
+                  <a:srgbClr val="566873"/>
+                </a:solidFill>
+                <a:latin typeface="Sarabun"/>
+                <a:ea typeface="Sarabun"/>
+                <a:cs typeface="Sarabun"/>
+              </a:rPr>
+              <a:t> (chǎn aa-yú ... bpii)</a:t>
+            </a:r>
+            <a:r>
+              <a:rPr sz="1300" b="1" i="0" lang="en-US" altLang="en-US">
+                <a:solidFill>
+                  <a:srgbClr val="24333D"/>
+                </a:solidFill>
+                <a:latin typeface="Sarabun"/>
+                <a:ea typeface="Sarabun"/>
+                <a:cs typeface="Sarabun"/>
+              </a:rPr>
+              <a:t> | chǎn aa-yú ... bpii | I am ... years old (female)</a:t>
+            </a:r>
+          </a:p>
+        </p:txBody>
+      </p:sp>
+      <p:sp>
+        <p:nvSpPr>
+          <p:cNvPr id="14" name="TextBox 13"/>
+          <p:cNvSpPr txBox="1"/>
+          <p:nvPr/>
+        </p:nvSpPr>
+        <p:spPr>
+          <a:xfrm>
+            <a:off x="1188720" y="5029200"/>
+            <a:ext cx="3200400" cy="658368"/>
+          </a:xfrm>
+          <a:prstGeom prst="rect">
+            <a:avLst/>
+          </a:prstGeom>
+          <a:noFill/>
+        </p:spPr>
+        <p:txBody>
+          <a:bodyPr wrap="square" anchor="t">
+            <a:spAutoFit/>
+          </a:bodyPr>
+          <a:lstStyle/>
+          <a:p>
+            <a:pPr algn="l"/>
+            <a:r>
+              <a:rPr sz="2300" b="1" i="0" lang="th-TH" altLang="en-US">
+                <a:solidFill>
+                  <a:srgbClr val="24333D"/>
+                </a:solidFill>
+                <a:latin typeface="Sarabun"/>
+                <a:ea typeface="Sarabun"/>
+                <a:cs typeface="Sarabun"/>
+              </a:rPr>
+              <a:t>5. สวัสดี</a:t>
+            </a:r>
+            <a:r>
+              <a:rPr sz="1500" b="0" i="1" lang="en-US" altLang="en-US">
+                <a:solidFill>
+                  <a:srgbClr val="566873"/>
+                </a:solidFill>
+                <a:latin typeface="Sarabun"/>
+                <a:ea typeface="Sarabun"/>
+                <a:cs typeface="Sarabun"/>
+              </a:rPr>
+              <a:t> (sà-wàt-dii)</a:t>
+            </a:r>
+          </a:p>
+        </p:txBody>
+      </p:sp>
+      <p:sp>
+        <p:nvSpPr>
+          <p:cNvPr id="15" name="TextBox 14"/>
+          <p:cNvSpPr txBox="1"/>
+          <p:nvPr/>
+        </p:nvSpPr>
+        <p:spPr>
+          <a:xfrm>
+            <a:off x="4846320" y="5138928"/>
+            <a:ext cx="2286000" cy="365760"/>
+          </a:xfrm>
+          <a:prstGeom prst="rect">
+            <a:avLst/>
+          </a:prstGeom>
+          <a:noFill/>
+        </p:spPr>
+        <p:txBody>
+          <a:bodyPr wrap="square" anchor="t">
+            <a:spAutoFit/>
+          </a:bodyPr>
+          <a:lstStyle/>
+          <a:p>
+            <a:pPr algn="l"/>
+            <a:r>
+              <a:rPr sz="1300" b="1" i="0" lang="en-US" altLang="en-US">
+                <a:solidFill>
+                  <a:srgbClr val="24333D"/>
+                </a:solidFill>
+                <a:latin typeface="Sarabun"/>
+                <a:ea typeface="Sarabun"/>
+                <a:cs typeface="Sarabun"/>
+              </a:rPr>
+              <a:t>Practise aloud</a:t>
+            </a:r>
+          </a:p>
+        </p:txBody>
+      </p:sp>
+      <p:sp>
+        <p:nvSpPr>
+          <p:cNvPr id="16" name="__pip_placeholder__"/>
           <p:cNvSpPr/>
           <p:nvPr/>
         </p:nvSpPr>
@@ -4942,7 +5066,7 @@
         </p:nvSpPr>
         <p:spPr>
           <a:xfrm>
-            <a:off x="731527" y="642588"/>
+            <a:off x="731527" y="809138"/>
             <a:ext cx="1210500" cy="320100"/>
           </a:xfrm>
           <a:prstGeom prst="rect">
@@ -4979,8 +5103,8 @@
         </p:nvSpPr>
         <p:spPr>
           <a:xfrm>
-            <a:off x="2063268" y="505418"/>
-            <a:ext cx="5943600" cy="457200"/>
+            <a:off x="2029374" y="720278"/>
+            <a:ext cx="7030500" cy="621900"/>
           </a:xfrm>
           <a:prstGeom prst="rect">
             <a:avLst/>
@@ -5003,7 +5127,62 @@
                 <a:ea typeface="Sarabun"/>
                 <a:cs typeface="Sarabun"/>
               </a:rPr>
-              <a:t>Numbers in real exchanges</a:t>
+              <a:t>Pronunciation: </a:t>
+            </a:r>
+            <a:r>
+              <a:rPr sz="3000" b="1" i="0" lang="th-TH" altLang="en-US">
+                <a:solidFill>
+                  <a:srgbClr val="24333D"/>
+                </a:solidFill>
+                <a:latin typeface="Sarabun"/>
+                <a:ea typeface="Sarabun"/>
+                <a:cs typeface="Sarabun"/>
+              </a:rPr>
+              <a:t>สี่</a:t>
+            </a:r>
+            <a:r>
+              <a:rPr sz="1860" b="0" i="1" lang="en-US" altLang="en-US">
+                <a:solidFill>
+                  <a:srgbClr val="566873"/>
+                </a:solidFill>
+                <a:latin typeface="Sarabun"/>
+                <a:ea typeface="Sarabun"/>
+                <a:cs typeface="Sarabun"/>
+              </a:rPr>
+              <a:t> (sìi)</a:t>
+            </a:r>
+            <a:r>
+              <a:rPr sz="3000" b="1" i="0" lang="en-US" altLang="en-US">
+                <a:solidFill>
+                  <a:srgbClr val="24333D"/>
+                </a:solidFill>
+                <a:latin typeface="Sarabun"/>
+                <a:ea typeface="Sarabun"/>
+                <a:cs typeface="Sarabun"/>
+              </a:rPr>
+              <a:t> vs </a:t>
+            </a:r>
+            <a:r>
+              <a:rPr sz="3000" b="1" i="0" lang="th-TH" altLang="en-US">
+                <a:solidFill>
+                  <a:srgbClr val="24333D"/>
+                </a:solidFill>
+                <a:latin typeface="Sarabun"/>
+                <a:ea typeface="Sarabun"/>
+                <a:cs typeface="Sarabun"/>
+              </a:rPr>
+              <a:t>สี</a:t>
+            </a:r>
+            <a:r>
+              <a:rPr sz="1860" b="0" i="1" lang="en-US" altLang="en-US">
+                <a:solidFill>
+                  <a:srgbClr val="566873"/>
+                </a:solidFill>
+                <a:latin typeface="Sarabun"/>
+                <a:ea typeface="Sarabun"/>
+                <a:cs typeface="Sarabun"/>
+              </a:rPr>
+              <a:t> (sǐi)</a:t>
             </a:r>
           </a:p>
         </p:txBody>
@@ -5016,7 +5195,7 @@
         </p:nvSpPr>
         <p:spPr>
           <a:xfrm>
-            <a:off x="731520" y="1075703"/>
+            <a:off x="731520" y="1193328"/>
             <a:ext cx="6858000" cy="365700"/>
           </a:xfrm>
           <a:prstGeom prst="rect">
@@ -5040,7 +5219,40 @@
                 <a:ea typeface="Sarabun"/>
                 <a:cs typeface="Sarabun"/>
               </a:rPr>
-              <a:t>Show combined exchanges that use digits with pronouns and courtesy phrases as a unified system.</a:t>
+              <a:t>Contrast </a:t>
+            </a:r>
+            <a:r>
+              <a:rPr sz="1500" b="0" i="0" lang="th-TH" altLang="en-US">
+                <a:solidFill>
+                  <a:srgbClr val="566873"/>
+                </a:solidFill>
+                <a:latin typeface="Sarabun"/>
+                <a:ea typeface="Sarabun"/>
+                <a:cs typeface="Sarabun"/>
+              </a:rPr>
+              <a:t>สี</a:t>
+            </a:r>
+            <a:r>
+              <a:rPr sz="1500" b="0" i="1" lang="en-US" altLang="en-US">
+                <a:solidFill>
+                  <a:srgbClr val="566873"/>
+                </a:solidFill>
+                <a:latin typeface="Sarabun"/>
+                <a:ea typeface="Sarabun"/>
+                <a:cs typeface="Sarabun"/>
+              </a:rPr>
+              <a:t> (sǐi)</a:t>
+            </a:r>
+            <a:r>
+              <a:rPr sz="1500" b="0" i="0" lang="th-TH" altLang="en-US">
+                <a:solidFill>
+                  <a:srgbClr val="566873"/>
+                </a:solidFill>
+                <a:latin typeface="Sarabun"/>
+                <a:ea typeface="Sarabun"/>
+                <a:cs typeface="Sarabun"/>
+              </a:rPr>
+              <a:t>่ (four) and สี (colour) with tone direction arrows.</a:t>
             </a:r>
           </a:p>
         </p:txBody>
@@ -5053,8 +5265,8 @@
         </p:nvSpPr>
         <p:spPr>
           <a:xfrm>
-            <a:off x="1188720" y="1627632"/>
-            <a:ext cx="3200400" cy="658368"/>
+            <a:off x="731533" y="1623118"/>
+            <a:ext cx="1645800" cy="274200"/>
           </a:xfrm>
           <a:prstGeom prst="rect">
             <a:avLst/>
@@ -5069,7 +5281,7 @@
           <a:p>
             <a:pPr algn="l"/>
             <a:r>
-              <a:rPr sz="2300" b="1" i="0" lang="th-TH" altLang="en-US">
+              <a:rPr sz="1300" b="1" i="0" lang="en-US" altLang="en-US">
                 <a:solidFill>
                   <a:srgbClr val="24333D"/>
                 </a:solidFill>
@@ -5077,18 +5289,7 @@
                 <a:ea typeface="Sarabun"/>
                 <a:cs typeface="Sarabun"/>
               </a:rPr>
-              <a:t>1. ฉัน</a:t>
-            </a:r>
-            <a:r>
-              <a:rPr sz="1500" b="0" i="1" lang="en-US" altLang="en-US">
-                <a:solidFill>
-                  <a:srgbClr val="566873"/>
-                </a:solidFill>
-                <a:latin typeface="Sarabun"/>
-                <a:ea typeface="Sarabun"/>
-                <a:cs typeface="Sarabun"/>
-              </a:rPr>
-              <a:t> (chǎn)</a:t>
+              <a:t>Direct answers</a:t>
             </a:r>
           </a:p>
         </p:txBody>
@@ -5101,8 +5302,8 @@
         </p:nvSpPr>
         <p:spPr>
           <a:xfrm>
-            <a:off x="4846320" y="1737360"/>
-            <a:ext cx="2286000" cy="365760"/>
+            <a:off x="1051560" y="2057400"/>
+            <a:ext cx="2286000" cy="731520"/>
           </a:xfrm>
           <a:prstGeom prst="rect">
             <a:avLst/>
@@ -5117,7 +5318,7 @@
           <a:p>
             <a:pPr algn="l"/>
             <a:r>
-              <a:rPr sz="1300" b="1" i="0" lang="th-TH" altLang="en-US">
+              <a:rPr sz="2300" b="1" i="0" lang="th-TH" altLang="en-US">
                 <a:solidFill>
                   <a:srgbClr val="24333D"/>
                 </a:solidFill>
@@ -5125,7 +5326,7 @@
                 <a:ea typeface="Sarabun"/>
                 <a:cs typeface="Sarabun"/>
               </a:rPr>
-              <a:t>คุณอายุเท่าไหร่</a:t>
+              <a:t>สี่</a:t>
             </a:r>
             <a:r>
               <a:rPr sz="1500" b="0" i="1" lang="en-US" altLang="en-US">
@@ -5136,18 +5337,7 @@
                 <a:ea typeface="Sarabun"/>
                 <a:cs typeface="Sarabun"/>
               </a:rPr>
-              <a:t> (khun aa-yú thâo-rài)</a:t>
-            </a:r>
-            <a:r>
-              <a:rPr sz="1300" b="1" i="0" lang="en-US" altLang="en-US">
-                <a:solidFill>
-                  <a:srgbClr val="24333D"/>
-                </a:solidFill>
-                <a:latin typeface="Sarabun"/>
-                <a:ea typeface="Sarabun"/>
-                <a:cs typeface="Sarabun"/>
-              </a:rPr>
-              <a:t> | khun aa-yú thâo-rài | how old are you?</a:t>
+              <a:t> (sìi)</a:t>
             </a:r>
           </a:p>
         </p:txBody>
@@ -5160,8 +5350,8 @@
         </p:nvSpPr>
         <p:spPr>
           <a:xfrm>
-            <a:off x="1188720" y="2478024"/>
-            <a:ext cx="3200400" cy="658368"/>
+            <a:off x="3474720" y="2148840"/>
+            <a:ext cx="3657600" cy="365760"/>
           </a:xfrm>
           <a:prstGeom prst="rect">
             <a:avLst/>
@@ -5176,7 +5366,7 @@
           <a:p>
             <a:pPr algn="l"/>
             <a:r>
-              <a:rPr sz="2300" b="1" i="0" lang="th-TH" altLang="en-US">
+              <a:rPr sz="1300" b="1" i="0" lang="en-US" altLang="en-US">
                 <a:solidFill>
                   <a:srgbClr val="24333D"/>
                 </a:solidFill>
@@ -5184,18 +5374,7 @@
                 <a:ea typeface="Sarabun"/>
                 <a:cs typeface="Sarabun"/>
               </a:rPr>
-              <a:t>2. เขา</a:t>
-            </a:r>
-            <a:r>
-              <a:rPr sz="1500" b="0" i="1" lang="en-US" altLang="en-US">
-                <a:solidFill>
-                  <a:srgbClr val="566873"/>
-                </a:solidFill>
-                <a:latin typeface="Sarabun"/>
-                <a:ea typeface="Sarabun"/>
-                <a:cs typeface="Sarabun"/>
-              </a:rPr>
-              <a:t> (khǎo)</a:t>
+              <a:t>four (low tone)</a:t>
             </a:r>
           </a:p>
         </p:txBody>
@@ -5208,8 +5387,8 @@
         </p:nvSpPr>
         <p:spPr>
           <a:xfrm>
-            <a:off x="4846320" y="2587752"/>
-            <a:ext cx="2286000" cy="365760"/>
+            <a:off x="3474720" y="2514600"/>
+            <a:ext cx="3657600" cy="365760"/>
           </a:xfrm>
           <a:prstGeom prst="rect">
             <a:avLst/>
@@ -5224,15 +5403,15 @@
           <a:p>
             <a:pPr algn="l"/>
             <a:r>
-              <a:rPr sz="1300" b="1" i="0" lang="th-TH" altLang="en-US">
-                <a:solidFill>
-                  <a:srgbClr val="24333D"/>
-                </a:solidFill>
-                <a:latin typeface="Sarabun"/>
-                <a:ea typeface="Sarabun"/>
-                <a:cs typeface="Sarabun"/>
-              </a:rPr>
-              <a:t>ฉันอายุแปดปี</a:t>
+              <a:rPr sz="1500" b="0" i="0" lang="th-TH" altLang="en-US">
+                <a:solidFill>
+                  <a:srgbClr val="566873"/>
+                </a:solidFill>
+                <a:latin typeface="Sarabun"/>
+                <a:ea typeface="Sarabun"/>
+                <a:cs typeface="Sarabun"/>
+              </a:rPr>
+              <a:t>สี่</a:t>
             </a:r>
             <a:r>
               <a:rPr sz="1500" b="0" i="1" lang="en-US" altLang="en-US">
@@ -5243,18 +5422,18 @@
                 <a:ea typeface="Sarabun"/>
                 <a:cs typeface="Sarabun"/>
               </a:rPr>
-              <a:t> (chǎn aa-yú bpàet bpii)</a:t>
-            </a:r>
-            <a:r>
-              <a:rPr sz="1300" b="1" i="0" lang="en-US" altLang="en-US">
-                <a:solidFill>
-                  <a:srgbClr val="24333D"/>
-                </a:solidFill>
-                <a:latin typeface="Sarabun"/>
-                <a:ea typeface="Sarabun"/>
-                <a:cs typeface="Sarabun"/>
-              </a:rPr>
-              <a:t> | chǎn aa-yú bpàet bpii | I am eight years old</a:t>
+              <a:t> (sìi)</a:t>
+            </a:r>
+            <a:r>
+              <a:rPr sz="1500" b="0" i="0" lang="en-US" altLang="en-US">
+                <a:solidFill>
+                  <a:srgbClr val="566873"/>
+                </a:solidFill>
+                <a:latin typeface="Sarabun"/>
+                <a:ea typeface="Sarabun"/>
+                <a:cs typeface="Sarabun"/>
+              </a:rPr>
+              <a:t> | sìi | four — low tone (voice stays low)</a:t>
             </a:r>
           </a:p>
         </p:txBody>
@@ -5267,8 +5446,8 @@
         </p:nvSpPr>
         <p:spPr>
           <a:xfrm>
-            <a:off x="1188720" y="3328416"/>
-            <a:ext cx="3200400" cy="658368"/>
+            <a:off x="731520" y="4594866"/>
+            <a:ext cx="1828800" cy="274200"/>
           </a:xfrm>
           <a:prstGeom prst="rect">
             <a:avLst/>
@@ -5283,7 +5462,7 @@
           <a:p>
             <a:pPr algn="l"/>
             <a:r>
-              <a:rPr sz="2300" b="1" i="0" lang="th-TH" altLang="en-US">
+              <a:rPr sz="1300" b="1" i="0" lang="en-US" altLang="en-US">
                 <a:solidFill>
                   <a:srgbClr val="24333D"/>
                 </a:solidFill>
@@ -5291,169 +5470,14 @@
                 <a:ea typeface="Sarabun"/>
                 <a:cs typeface="Sarabun"/>
               </a:rPr>
-              <a:t>3. ขอโทษ</a:t>
-            </a:r>
-            <a:r>
-              <a:rPr sz="1500" b="0" i="1" lang="en-US" altLang="en-US">
-                <a:solidFill>
-                  <a:srgbClr val="566873"/>
-                </a:solidFill>
-                <a:latin typeface="Sarabun"/>
-                <a:ea typeface="Sarabun"/>
-                <a:cs typeface="Sarabun"/>
-              </a:rPr>
-              <a:t> (khǎaw-thôot)</a:t>
-            </a:r>
-          </a:p>
-        </p:txBody>
-      </p:sp>
-      <p:sp>
-        <p:nvSpPr>
-          <p:cNvPr id="11" name="TextBox 10"/>
-          <p:cNvSpPr txBox="1"/>
-          <p:nvPr/>
-        </p:nvSpPr>
-        <p:spPr>
-          <a:xfrm>
-            <a:off x="4846320" y="3438144"/>
-            <a:ext cx="2286000" cy="365760"/>
-          </a:xfrm>
-          <a:prstGeom prst="rect">
-            <a:avLst/>
-          </a:prstGeom>
-          <a:noFill/>
-        </p:spPr>
-        <p:txBody>
-          <a:bodyPr wrap="square" anchor="t">
-            <a:spAutoFit/>
-          </a:bodyPr>
-          <a:lstStyle/>
-          <a:p>
-            <a:pPr algn="l"/>
-            <a:r>
-              <a:rPr sz="1300" b="1" i="0" lang="th-TH" altLang="en-US">
-                <a:solidFill>
-                  <a:srgbClr val="24333D"/>
-                </a:solidFill>
-                <a:latin typeface="Sarabun"/>
-                <a:ea typeface="Sarabun"/>
-                <a:cs typeface="Sarabun"/>
-              </a:rPr>
-              <a:t>ขอโทษครับ / ค่ะ</a:t>
-            </a:r>
-            <a:r>
-              <a:rPr sz="1500" b="0" i="1" lang="en-US" altLang="en-US">
-                <a:solidFill>
-                  <a:srgbClr val="566873"/>
-                </a:solidFill>
-                <a:latin typeface="Sarabun"/>
-                <a:ea typeface="Sarabun"/>
-                <a:cs typeface="Sarabun"/>
-              </a:rPr>
-              <a:t> (khǎaw-thôot khráp / khâ)</a:t>
-            </a:r>
-            <a:r>
-              <a:rPr sz="1300" b="1" i="0" lang="en-US" altLang="en-US">
-                <a:solidFill>
-                  <a:srgbClr val="24333D"/>
-                </a:solidFill>
-                <a:latin typeface="Sarabun"/>
-                <a:ea typeface="Sarabun"/>
-                <a:cs typeface="Sarabun"/>
-              </a:rPr>
-              <a:t> | khǎaw-thôot khráp / khâ | excuse me (polite)</a:t>
-            </a:r>
-          </a:p>
-        </p:txBody>
-      </p:sp>
-      <p:sp>
-        <p:nvSpPr>
-          <p:cNvPr id="12" name="TextBox 11"/>
-          <p:cNvSpPr txBox="1"/>
-          <p:nvPr/>
-        </p:nvSpPr>
-        <p:spPr>
-          <a:xfrm>
-            <a:off x="1188720" y="4178808"/>
-            <a:ext cx="3200400" cy="658368"/>
-          </a:xfrm>
-          <a:prstGeom prst="rect">
-            <a:avLst/>
-          </a:prstGeom>
-          <a:noFill/>
-        </p:spPr>
-        <p:txBody>
-          <a:bodyPr wrap="square" anchor="t">
-            <a:spAutoFit/>
-          </a:bodyPr>
-          <a:lstStyle/>
-          <a:p>
-            <a:pPr algn="l"/>
-            <a:r>
-              <a:rPr sz="2300" b="1" i="0" lang="th-TH" altLang="en-US">
-                <a:solidFill>
-                  <a:srgbClr val="24333D"/>
-                </a:solidFill>
-                <a:latin typeface="Sarabun"/>
-                <a:ea typeface="Sarabun"/>
-                <a:cs typeface="Sarabun"/>
-              </a:rPr>
-              <a:t>4. ขอบคุณ</a:t>
-            </a:r>
-            <a:r>
-              <a:rPr sz="1500" b="0" i="1" lang="en-US" altLang="en-US">
-                <a:solidFill>
-                  <a:srgbClr val="566873"/>
-                </a:solidFill>
-                <a:latin typeface="Sarabun"/>
-                <a:ea typeface="Sarabun"/>
-                <a:cs typeface="Sarabun"/>
-              </a:rPr>
-              <a:t> (khàawp-khun)</a:t>
-            </a:r>
-          </a:p>
-        </p:txBody>
-      </p:sp>
-      <p:sp>
-        <p:nvSpPr>
-          <p:cNvPr id="13" name="TextBox 12"/>
-          <p:cNvSpPr txBox="1"/>
-          <p:nvPr/>
-        </p:nvSpPr>
-        <p:spPr>
-          <a:xfrm>
-            <a:off x="4846320" y="4288536"/>
-            <a:ext cx="2286000" cy="365760"/>
-          </a:xfrm>
-          <a:prstGeom prst="rect">
-            <a:avLst/>
-          </a:prstGeom>
-          <a:noFill/>
-        </p:spPr>
-        <p:txBody>
-          <a:bodyPr wrap="square" anchor="t">
-            <a:spAutoFit/>
-          </a:bodyPr>
-          <a:lstStyle/>
-          <a:p>
-            <a:pPr algn="l"/>
-            <a:r>
-              <a:rPr sz="1300" b="1" i="0" lang="en-US" altLang="en-US">
-                <a:solidFill>
-                  <a:srgbClr val="24333D"/>
-                </a:solidFill>
-                <a:latin typeface="Sarabun"/>
-                <a:ea typeface="Sarabun"/>
-                <a:cs typeface="Sarabun"/>
-              </a:rPr>
-              <a:t>Practise aloud</a:t>
-            </a:r>
-          </a:p>
-        </p:txBody>
-      </p:sp>
-      <p:sp>
-        <p:nvSpPr>
-          <p:cNvPr id="14" name="__pip_placeholder__"/>
+              <a:t>Softener</a:t>
+            </a:r>
+          </a:p>
+        </p:txBody>
+      </p:sp>
+      <p:sp>
+        <p:nvSpPr>
+          <p:cNvPr id="11" name="__pip_placeholder__"/>
           <p:cNvSpPr/>
           <p:nvPr/>
         </p:nvSpPr>
@@ -5528,7 +5552,7 @@
       <p:grpSpPr/>
       <p:pic>
         <p:nvPicPr>
-          <p:cNvPr id="2" name="Picture 1" descr="slide-03.png"/>
+          <p:cNvPr id="2" name="Picture 1" descr="slide-07.png"/>
           <p:cNvPicPr>
             <a:picLocks noChangeAspect="1"/>
           </p:cNvPicPr>
@@ -5558,8 +5582,8 @@
         </p:nvSpPr>
         <p:spPr>
           <a:xfrm>
-            <a:off x="731527" y="1719200"/>
-            <a:ext cx="1210500" cy="320100"/>
+            <a:off x="731520" y="429768"/>
+            <a:ext cx="6858000" cy="457200"/>
           </a:xfrm>
           <a:prstGeom prst="rect">
             <a:avLst/>
@@ -5572,17 +5596,17 @@
           </a:bodyPr>
           <a:lstStyle/>
           <a:p>
-            <a:pPr algn="ctr"/>
-            <a:r>
-              <a:rPr sz="1200" b="1" i="0" lang="en-US" altLang="en-US">
-                <a:solidFill>
-                  <a:srgbClr val="FFFFFF"/>
-                </a:solidFill>
-                <a:latin typeface="Sarabun"/>
-                <a:ea typeface="Sarabun"/>
-                <a:cs typeface="Sarabun"/>
-              </a:rPr>
-              <a:t>Section 5</a:t>
+            <a:pPr algn="l"/>
+            <a:r>
+              <a:rPr sz="3000" b="1" i="0" lang="en-US" altLang="en-US">
+                <a:solidFill>
+                  <a:srgbClr val="24333D"/>
+                </a:solidFill>
+                <a:latin typeface="Sarabun"/>
+                <a:ea typeface="Sarabun"/>
+                <a:cs typeface="Sarabun"/>
+              </a:rPr>
+              <a:t>Roleplay</a:t>
             </a:r>
           </a:p>
         </p:txBody>
@@ -5595,8 +5619,8 @@
         </p:nvSpPr>
         <p:spPr>
           <a:xfrm>
-            <a:off x="2063268" y="1582106"/>
-            <a:ext cx="5943600" cy="457200"/>
+            <a:off x="731520" y="992138"/>
+            <a:ext cx="6858000" cy="365700"/>
           </a:xfrm>
           <a:prstGeom prst="rect">
             <a:avLst/>
@@ -5611,15 +5635,15 @@
           <a:p>
             <a:pPr algn="l"/>
             <a:r>
-              <a:rPr sz="3000" b="1" i="0" lang="en-US" altLang="en-US">
-                <a:solidFill>
-                  <a:srgbClr val="24333D"/>
-                </a:solidFill>
-                <a:latin typeface="Sarabun"/>
-                <a:ea typeface="Sarabun"/>
-                <a:cs typeface="Sarabun"/>
-              </a:rPr>
-              <a:t>Pronunciation beat: low tone vs rising tone</a:t>
+              <a:rPr sz="1500" b="0" i="0" lang="en-US" altLang="en-US">
+                <a:solidFill>
+                  <a:srgbClr val="566873"/>
+                </a:solidFill>
+                <a:latin typeface="Sarabun"/>
+                <a:ea typeface="Sarabun"/>
+                <a:cs typeface="Sarabun"/>
+              </a:rPr>
+              <a:t>Support the roleplay recording with clean turn-taking.</a:t>
             </a:r>
           </a:p>
         </p:txBody>
@@ -5632,8 +5656,8 @@
         </p:nvSpPr>
         <p:spPr>
           <a:xfrm>
-            <a:off x="1142988" y="2332605"/>
-            <a:ext cx="5303400" cy="1042060"/>
+            <a:off x="731520" y="1463040"/>
+            <a:ext cx="1097280" cy="292608"/>
           </a:xfrm>
           <a:prstGeom prst="rect">
             <a:avLst/>
@@ -5646,28 +5670,17 @@
           </a:bodyPr>
           <a:lstStyle/>
           <a:p>
-            <a:pPr algn="l"/>
-            <a:r>
-              <a:rPr sz="3200" b="1" i="0" lang="th-TH" altLang="en-US">
-                <a:solidFill>
-                  <a:srgbClr val="24333D"/>
-                </a:solidFill>
-                <a:latin typeface="Sarabun"/>
-                <a:ea typeface="Sarabun"/>
-                <a:cs typeface="Sarabun"/>
-              </a:rPr>
-              <a:t>สี่</a:t>
-            </a:r>
-            <a:r>
-              <a:rPr sz="1980" b="0" i="1" lang="en-US" altLang="en-US">
-                <a:solidFill>
-                  <a:srgbClr val="566873"/>
-                </a:solidFill>
-                <a:latin typeface="Sarabun"/>
-                <a:ea typeface="Sarabun"/>
-                <a:cs typeface="Sarabun"/>
-              </a:rPr>
-              <a:t> (sìi)</a:t>
+            <a:pPr algn="ctr"/>
+            <a:r>
+              <a:rPr sz="1200" b="1" i="0" lang="en-US" altLang="en-US">
+                <a:solidFill>
+                  <a:srgbClr val="FFFFFF"/>
+                </a:solidFill>
+                <a:latin typeface="Sarabun"/>
+                <a:ea typeface="Sarabun"/>
+                <a:cs typeface="Sarabun"/>
+              </a:rPr>
+              <a:t>You</a:t>
             </a:r>
           </a:p>
         </p:txBody>
@@ -5680,8 +5693,8 @@
         </p:nvSpPr>
         <p:spPr>
           <a:xfrm>
-            <a:off x="1143000" y="3374675"/>
-            <a:ext cx="5303400" cy="365700"/>
+            <a:off x="2011680" y="1339583"/>
+            <a:ext cx="5303400" cy="411600"/>
           </a:xfrm>
           <a:prstGeom prst="rect">
             <a:avLst/>
@@ -5696,15 +5709,26 @@
           <a:p>
             <a:pPr algn="l"/>
             <a:r>
-              <a:rPr sz="1500" b="0" i="0" lang="en-US" altLang="en-US">
-                <a:solidFill>
-                  <a:srgbClr val="82909A"/>
-                </a:solidFill>
-                <a:latin typeface="Sarabun"/>
-                <a:ea typeface="Sarabun"/>
-                <a:cs typeface="Sarabun"/>
-              </a:rPr>
-              <a:t>four (low tone)</a:t>
+              <a:rPr sz="2300" b="1" i="0" lang="th-TH" altLang="en-US">
+                <a:solidFill>
+                  <a:srgbClr val="24333D"/>
+                </a:solidFill>
+                <a:latin typeface="Sarabun"/>
+                <a:ea typeface="Sarabun"/>
+                <a:cs typeface="Sarabun"/>
+              </a:rPr>
+              <a:t>สวัสดีครับ</a:t>
+            </a:r>
+            <a:r>
+              <a:rPr sz="1500" b="0" i="1" lang="en-US" altLang="en-US">
+                <a:solidFill>
+                  <a:srgbClr val="566873"/>
+                </a:solidFill>
+                <a:latin typeface="Sarabun"/>
+                <a:ea typeface="Sarabun"/>
+                <a:cs typeface="Sarabun"/>
+              </a:rPr>
+              <a:t> (sà-wàt-dii khráp)</a:t>
             </a:r>
           </a:p>
         </p:txBody>
@@ -5717,8 +5741,8 @@
         </p:nvSpPr>
         <p:spPr>
           <a:xfrm>
-            <a:off x="731520" y="4142240"/>
-            <a:ext cx="6858000" cy="914400"/>
+            <a:off x="2011693" y="1721362"/>
+            <a:ext cx="5303400" cy="320100"/>
           </a:xfrm>
           <a:prstGeom prst="rect">
             <a:avLst/>
@@ -5733,7 +5757,81 @@
           <a:p>
             <a:pPr algn="l"/>
             <a:r>
-              <a:rPr sz="1600" b="0" i="0" lang="th-TH" altLang="en-US">
+              <a:rPr sz="1500" b="0" i="0" lang="en-US" altLang="en-US">
+                <a:solidFill>
+                  <a:srgbClr val="566873"/>
+                </a:solidFill>
+                <a:latin typeface="Sarabun"/>
+                <a:ea typeface="Sarabun"/>
+                <a:cs typeface="Sarabun"/>
+              </a:rPr>
+              <a:t>Hello.</a:t>
+            </a:r>
+          </a:p>
+        </p:txBody>
+      </p:sp>
+      <p:sp>
+        <p:nvSpPr>
+          <p:cNvPr id="8" name="TextBox 7"/>
+          <p:cNvSpPr txBox="1"/>
+          <p:nvPr/>
+        </p:nvSpPr>
+        <p:spPr>
+          <a:xfrm>
+            <a:off x="731520" y="2199095"/>
+            <a:ext cx="1097400" cy="292500"/>
+          </a:xfrm>
+          <a:prstGeom prst="rect">
+            <a:avLst/>
+          </a:prstGeom>
+          <a:noFill/>
+        </p:spPr>
+        <p:txBody>
+          <a:bodyPr wrap="square" anchor="t">
+            <a:spAutoFit/>
+          </a:bodyPr>
+          <a:lstStyle/>
+          <a:p>
+            <a:pPr algn="ctr"/>
+            <a:r>
+              <a:rPr sz="1200" b="1" i="0" lang="en-US" altLang="en-US">
+                <a:solidFill>
+                  <a:srgbClr val="FFFFFF"/>
+                </a:solidFill>
+                <a:latin typeface="Sarabun"/>
+                <a:ea typeface="Sarabun"/>
+                <a:cs typeface="Sarabun"/>
+              </a:rPr>
+              <a:t>Staff</a:t>
+            </a:r>
+          </a:p>
+        </p:txBody>
+      </p:sp>
+      <p:sp>
+        <p:nvSpPr>
+          <p:cNvPr id="9" name="TextBox 8"/>
+          <p:cNvSpPr txBox="1"/>
+          <p:nvPr/>
+        </p:nvSpPr>
+        <p:spPr>
+          <a:xfrm>
+            <a:off x="2011743" y="2048200"/>
+            <a:ext cx="5303400" cy="411600"/>
+          </a:xfrm>
+          <a:prstGeom prst="rect">
+            <a:avLst/>
+          </a:prstGeom>
+          <a:noFill/>
+        </p:spPr>
+        <p:txBody>
+          <a:bodyPr wrap="square" anchor="t">
+            <a:spAutoFit/>
+          </a:bodyPr>
+          <a:lstStyle/>
+          <a:p>
+            <a:pPr algn="l"/>
+            <a:r>
+              <a:rPr sz="2300" b="1" i="0" lang="th-TH" altLang="en-US">
                 <a:solidFill>
                   <a:srgbClr val="24333D"/>
                 </a:solidFill>
@@ -5741,13 +5839,121 @@
                 <a:ea typeface="Sarabun"/>
                 <a:cs typeface="Sarabun"/>
               </a:rPr>
-              <a:t>สี่ | sìi | four (low tone — voice stays low and flat)</a:t>
-            </a:r>
-          </a:p>
+              <a:t>สวัสดีค่ะ เบอร์ห้องอะไรคะ</a:t>
+            </a:r>
+            <a:r>
+              <a:rPr sz="1500" b="0" i="1" lang="en-US" altLang="en-US">
+                <a:solidFill>
+                  <a:srgbClr val="566873"/>
+                </a:solidFill>
+                <a:latin typeface="Sarabun"/>
+                <a:ea typeface="Sarabun"/>
+                <a:cs typeface="Sarabun"/>
+              </a:rPr>
+              <a:t> (sà-wàt-dii khâ ber hâwng à-rai khá)</a:t>
+            </a:r>
+          </a:p>
+        </p:txBody>
+      </p:sp>
+      <p:sp>
+        <p:nvSpPr>
+          <p:cNvPr id="10" name="TextBox 9"/>
+          <p:cNvSpPr txBox="1"/>
+          <p:nvPr/>
+        </p:nvSpPr>
+        <p:spPr>
+          <a:xfrm>
+            <a:off x="2011693" y="2482592"/>
+            <a:ext cx="5303400" cy="320100"/>
+          </a:xfrm>
+          <a:prstGeom prst="rect">
+            <a:avLst/>
+          </a:prstGeom>
+          <a:noFill/>
+        </p:spPr>
+        <p:txBody>
+          <a:bodyPr wrap="square" anchor="t">
+            <a:spAutoFit/>
+          </a:bodyPr>
+          <a:lstStyle/>
           <a:p>
             <a:pPr algn="l"/>
             <a:r>
-              <a:rPr sz="1600" b="0" i="0" lang="th-TH" altLang="en-US">
+              <a:rPr sz="1500" b="0" i="0" lang="en-US" altLang="en-US">
+                <a:solidFill>
+                  <a:srgbClr val="566873"/>
+                </a:solidFill>
+                <a:latin typeface="Sarabun"/>
+                <a:ea typeface="Sarabun"/>
+                <a:cs typeface="Sarabun"/>
+              </a:rPr>
+              <a:t>Hello. What is the room number?</a:t>
+            </a:r>
+          </a:p>
+        </p:txBody>
+      </p:sp>
+      <p:sp>
+        <p:nvSpPr>
+          <p:cNvPr id="11" name="TextBox 10"/>
+          <p:cNvSpPr txBox="1"/>
+          <p:nvPr/>
+        </p:nvSpPr>
+        <p:spPr>
+          <a:xfrm>
+            <a:off x="731583" y="2962650"/>
+            <a:ext cx="1097400" cy="292500"/>
+          </a:xfrm>
+          <a:prstGeom prst="rect">
+            <a:avLst/>
+          </a:prstGeom>
+          <a:noFill/>
+        </p:spPr>
+        <p:txBody>
+          <a:bodyPr wrap="square" anchor="t">
+            <a:spAutoFit/>
+          </a:bodyPr>
+          <a:lstStyle/>
+          <a:p>
+            <a:pPr algn="ctr"/>
+            <a:r>
+              <a:rPr sz="1200" b="1" i="0" lang="en-US" altLang="en-US">
+                <a:solidFill>
+                  <a:srgbClr val="FFFFFF"/>
+                </a:solidFill>
+                <a:latin typeface="Sarabun"/>
+                <a:ea typeface="Sarabun"/>
+                <a:cs typeface="Sarabun"/>
+              </a:rPr>
+              <a:t>You</a:t>
+            </a:r>
+          </a:p>
+        </p:txBody>
+      </p:sp>
+      <p:sp>
+        <p:nvSpPr>
+          <p:cNvPr id="12" name="TextBox 11"/>
+          <p:cNvSpPr txBox="1"/>
+          <p:nvPr/>
+        </p:nvSpPr>
+        <p:spPr>
+          <a:xfrm>
+            <a:off x="2011693" y="2878130"/>
+            <a:ext cx="5303400" cy="411600"/>
+          </a:xfrm>
+          <a:prstGeom prst="rect">
+            <a:avLst/>
+          </a:prstGeom>
+          <a:noFill/>
+        </p:spPr>
+        <p:txBody>
+          <a:bodyPr wrap="square" anchor="t">
+            <a:spAutoFit/>
+          </a:bodyPr>
+          <a:lstStyle/>
+          <a:p>
+            <a:pPr algn="l"/>
+            <a:r>
+              <a:rPr sz="2300" b="1" i="0" lang="th-TH" altLang="en-US">
                 <a:solidFill>
                   <a:srgbClr val="24333D"/>
                 </a:solidFill>
@@ -5755,14 +5961,428 @@
                 <a:ea typeface="Sarabun"/>
                 <a:cs typeface="Sarabun"/>
               </a:rPr>
-              <a:t>สี | sǐi | colour (rising tone — voice lifts up)</a:t>
-            </a:r>
-          </a:p>
-        </p:txBody>
-      </p:sp>
-      <p:sp>
-        <p:nvSpPr>
-          <p:cNvPr id="8" name="__pip_placeholder__"/>
+              <a:t>ห้า-ศูนย์-สองครับ</a:t>
+            </a:r>
+            <a:r>
+              <a:rPr sz="1500" b="0" i="1" lang="en-US" altLang="en-US">
+                <a:solidFill>
+                  <a:srgbClr val="566873"/>
+                </a:solidFill>
+                <a:latin typeface="Sarabun"/>
+                <a:ea typeface="Sarabun"/>
+                <a:cs typeface="Sarabun"/>
+              </a:rPr>
+              <a:t> (hâa-sǔun-sǎawng khráp)</a:t>
+            </a:r>
+          </a:p>
+        </p:txBody>
+      </p:sp>
+      <p:sp>
+        <p:nvSpPr>
+          <p:cNvPr id="13" name="TextBox 12"/>
+          <p:cNvSpPr txBox="1"/>
+          <p:nvPr/>
+        </p:nvSpPr>
+        <p:spPr>
+          <a:xfrm>
+            <a:off x="2011693" y="3253010"/>
+            <a:ext cx="5303400" cy="320100"/>
+          </a:xfrm>
+          <a:prstGeom prst="rect">
+            <a:avLst/>
+          </a:prstGeom>
+          <a:noFill/>
+        </p:spPr>
+        <p:txBody>
+          <a:bodyPr wrap="square" anchor="t">
+            <a:spAutoFit/>
+          </a:bodyPr>
+          <a:lstStyle/>
+          <a:p>
+            <a:pPr algn="l"/>
+            <a:r>
+              <a:rPr sz="1500" b="0" i="0" lang="en-US" altLang="en-US">
+                <a:solidFill>
+                  <a:srgbClr val="566873"/>
+                </a:solidFill>
+                <a:latin typeface="Sarabun"/>
+                <a:ea typeface="Sarabun"/>
+                <a:cs typeface="Sarabun"/>
+              </a:rPr>
+              <a:t>Five-zero-two.</a:t>
+            </a:r>
+          </a:p>
+        </p:txBody>
+      </p:sp>
+      <p:sp>
+        <p:nvSpPr>
+          <p:cNvPr id="14" name="TextBox 13"/>
+          <p:cNvSpPr txBox="1"/>
+          <p:nvPr/>
+        </p:nvSpPr>
+        <p:spPr>
+          <a:xfrm>
+            <a:off x="731583" y="3726205"/>
+            <a:ext cx="1097400" cy="292500"/>
+          </a:xfrm>
+          <a:prstGeom prst="rect">
+            <a:avLst/>
+          </a:prstGeom>
+          <a:noFill/>
+        </p:spPr>
+        <p:txBody>
+          <a:bodyPr wrap="square" anchor="t">
+            <a:spAutoFit/>
+          </a:bodyPr>
+          <a:lstStyle/>
+          <a:p>
+            <a:pPr algn="ctr"/>
+            <a:r>
+              <a:rPr sz="1200" b="1" i="0" lang="en-US" altLang="en-US">
+                <a:solidFill>
+                  <a:srgbClr val="FFFFFF"/>
+                </a:solidFill>
+                <a:latin typeface="Sarabun"/>
+                <a:ea typeface="Sarabun"/>
+                <a:cs typeface="Sarabun"/>
+              </a:rPr>
+              <a:t>Staff</a:t>
+            </a:r>
+          </a:p>
+        </p:txBody>
+      </p:sp>
+      <p:sp>
+        <p:nvSpPr>
+          <p:cNvPr id="15" name="TextBox 14"/>
+          <p:cNvSpPr txBox="1"/>
+          <p:nvPr/>
+        </p:nvSpPr>
+        <p:spPr>
+          <a:xfrm>
+            <a:off x="2011693" y="3666773"/>
+            <a:ext cx="5303400" cy="411600"/>
+          </a:xfrm>
+          <a:prstGeom prst="rect">
+            <a:avLst/>
+          </a:prstGeom>
+          <a:noFill/>
+        </p:spPr>
+        <p:txBody>
+          <a:bodyPr wrap="square" anchor="t">
+            <a:spAutoFit/>
+          </a:bodyPr>
+          <a:lstStyle/>
+          <a:p>
+            <a:pPr algn="l"/>
+            <a:r>
+              <a:rPr sz="2300" b="1" i="0" lang="th-TH" altLang="en-US">
+                <a:solidFill>
+                  <a:srgbClr val="24333D"/>
+                </a:solidFill>
+                <a:latin typeface="Sarabun"/>
+                <a:ea typeface="Sarabun"/>
+                <a:cs typeface="Sarabun"/>
+              </a:rPr>
+              <a:t>ค่ะ คุณอายุเท่าไหร่คะ</a:t>
+            </a:r>
+            <a:r>
+              <a:rPr sz="1500" b="0" i="1" lang="en-US" altLang="en-US">
+                <a:solidFill>
+                  <a:srgbClr val="566873"/>
+                </a:solidFill>
+                <a:latin typeface="Sarabun"/>
+                <a:ea typeface="Sarabun"/>
+                <a:cs typeface="Sarabun"/>
+              </a:rPr>
+              <a:t> (khâ khun aa-yú thâo-rài khá)</a:t>
+            </a:r>
+          </a:p>
+        </p:txBody>
+      </p:sp>
+      <p:sp>
+        <p:nvSpPr>
+          <p:cNvPr id="16" name="TextBox 15"/>
+          <p:cNvSpPr txBox="1"/>
+          <p:nvPr/>
+        </p:nvSpPr>
+        <p:spPr>
+          <a:xfrm>
+            <a:off x="2011680" y="4072527"/>
+            <a:ext cx="5303400" cy="320100"/>
+          </a:xfrm>
+          <a:prstGeom prst="rect">
+            <a:avLst/>
+          </a:prstGeom>
+          <a:noFill/>
+        </p:spPr>
+        <p:txBody>
+          <a:bodyPr wrap="square" anchor="t">
+            <a:spAutoFit/>
+          </a:bodyPr>
+          <a:lstStyle/>
+          <a:p>
+            <a:pPr algn="l"/>
+            <a:r>
+              <a:rPr sz="1500" b="0" i="0" lang="en-US" altLang="en-US">
+                <a:solidFill>
+                  <a:srgbClr val="566873"/>
+                </a:solidFill>
+                <a:latin typeface="Sarabun"/>
+                <a:ea typeface="Sarabun"/>
+                <a:cs typeface="Sarabun"/>
+              </a:rPr>
+              <a:t>Okay. How old are you?</a:t>
+            </a:r>
+          </a:p>
+        </p:txBody>
+      </p:sp>
+      <p:sp>
+        <p:nvSpPr>
+          <p:cNvPr id="17" name="TextBox 16"/>
+          <p:cNvSpPr txBox="1"/>
+          <p:nvPr/>
+        </p:nvSpPr>
+        <p:spPr>
+          <a:xfrm>
+            <a:off x="791795" y="4489760"/>
+            <a:ext cx="1097400" cy="292500"/>
+          </a:xfrm>
+          <a:prstGeom prst="rect">
+            <a:avLst/>
+          </a:prstGeom>
+          <a:noFill/>
+        </p:spPr>
+        <p:txBody>
+          <a:bodyPr wrap="square" anchor="t">
+            <a:spAutoFit/>
+          </a:bodyPr>
+          <a:lstStyle/>
+          <a:p>
+            <a:pPr algn="ctr"/>
+            <a:r>
+              <a:rPr sz="1200" b="1" i="0" lang="en-US" altLang="en-US">
+                <a:solidFill>
+                  <a:srgbClr val="FFFFFF"/>
+                </a:solidFill>
+                <a:latin typeface="Sarabun"/>
+                <a:ea typeface="Sarabun"/>
+                <a:cs typeface="Sarabun"/>
+              </a:rPr>
+              <a:t>You</a:t>
+            </a:r>
+          </a:p>
+        </p:txBody>
+      </p:sp>
+      <p:sp>
+        <p:nvSpPr>
+          <p:cNvPr id="18" name="TextBox 17"/>
+          <p:cNvSpPr txBox="1"/>
+          <p:nvPr/>
+        </p:nvSpPr>
+        <p:spPr>
+          <a:xfrm>
+            <a:off x="2011755" y="4366290"/>
+            <a:ext cx="5303400" cy="411600"/>
+          </a:xfrm>
+          <a:prstGeom prst="rect">
+            <a:avLst/>
+          </a:prstGeom>
+          <a:noFill/>
+        </p:spPr>
+        <p:txBody>
+          <a:bodyPr wrap="square" anchor="t">
+            <a:spAutoFit/>
+          </a:bodyPr>
+          <a:lstStyle/>
+          <a:p>
+            <a:pPr algn="l"/>
+            <a:r>
+              <a:rPr sz="2300" b="1" i="0" lang="th-TH" altLang="en-US">
+                <a:solidFill>
+                  <a:srgbClr val="24333D"/>
+                </a:solidFill>
+                <a:latin typeface="Sarabun"/>
+                <a:ea typeface="Sarabun"/>
+                <a:cs typeface="Sarabun"/>
+              </a:rPr>
+              <a:t>ผมอายุสามสิบปีครับ</a:t>
+            </a:r>
+            <a:r>
+              <a:rPr sz="1500" b="0" i="1" lang="en-US" altLang="en-US">
+                <a:solidFill>
+                  <a:srgbClr val="566873"/>
+                </a:solidFill>
+                <a:latin typeface="Sarabun"/>
+                <a:ea typeface="Sarabun"/>
+                <a:cs typeface="Sarabun"/>
+              </a:rPr>
+              <a:t> (phǒm aa-yú sǎam-sìp bpii khráp)</a:t>
+            </a:r>
+          </a:p>
+        </p:txBody>
+      </p:sp>
+      <p:sp>
+        <p:nvSpPr>
+          <p:cNvPr id="19" name="TextBox 18"/>
+          <p:cNvSpPr txBox="1"/>
+          <p:nvPr/>
+        </p:nvSpPr>
+        <p:spPr>
+          <a:xfrm>
+            <a:off x="2011693" y="4759532"/>
+            <a:ext cx="5303400" cy="320100"/>
+          </a:xfrm>
+          <a:prstGeom prst="rect">
+            <a:avLst/>
+          </a:prstGeom>
+          <a:noFill/>
+        </p:spPr>
+        <p:txBody>
+          <a:bodyPr wrap="square" anchor="t">
+            <a:spAutoFit/>
+          </a:bodyPr>
+          <a:lstStyle/>
+          <a:p>
+            <a:pPr algn="l"/>
+            <a:r>
+              <a:rPr sz="1500" b="0" i="0" lang="en-US" altLang="en-US">
+                <a:solidFill>
+                  <a:srgbClr val="566873"/>
+                </a:solidFill>
+                <a:latin typeface="Sarabun"/>
+                <a:ea typeface="Sarabun"/>
+                <a:cs typeface="Sarabun"/>
+              </a:rPr>
+              <a:t>I am thirty years old.</a:t>
+            </a:r>
+          </a:p>
+        </p:txBody>
+      </p:sp>
+      <p:sp>
+        <p:nvSpPr>
+          <p:cNvPr id="20" name="TextBox 19"/>
+          <p:cNvSpPr txBox="1"/>
+          <p:nvPr/>
+        </p:nvSpPr>
+        <p:spPr>
+          <a:xfrm>
+            <a:off x="731633" y="5253290"/>
+            <a:ext cx="1097400" cy="292500"/>
+          </a:xfrm>
+          <a:prstGeom prst="rect">
+            <a:avLst/>
+          </a:prstGeom>
+          <a:noFill/>
+        </p:spPr>
+        <p:txBody>
+          <a:bodyPr wrap="square" anchor="t">
+            <a:spAutoFit/>
+          </a:bodyPr>
+          <a:lstStyle/>
+          <a:p>
+            <a:pPr algn="ctr"/>
+            <a:r>
+              <a:rPr sz="1200" b="1" i="0" lang="en-US" altLang="en-US">
+                <a:solidFill>
+                  <a:srgbClr val="FFFFFF"/>
+                </a:solidFill>
+                <a:latin typeface="Sarabun"/>
+                <a:ea typeface="Sarabun"/>
+                <a:cs typeface="Sarabun"/>
+              </a:rPr>
+              <a:t>Staff</a:t>
+            </a:r>
+          </a:p>
+        </p:txBody>
+      </p:sp>
+      <p:sp>
+        <p:nvSpPr>
+          <p:cNvPr id="21" name="TextBox 20"/>
+          <p:cNvSpPr txBox="1"/>
+          <p:nvPr/>
+        </p:nvSpPr>
+        <p:spPr>
+          <a:xfrm>
+            <a:off x="2011680" y="5175433"/>
+            <a:ext cx="5303400" cy="411600"/>
+          </a:xfrm>
+          <a:prstGeom prst="rect">
+            <a:avLst/>
+          </a:prstGeom>
+          <a:noFill/>
+        </p:spPr>
+        <p:txBody>
+          <a:bodyPr wrap="square" anchor="t">
+            <a:spAutoFit/>
+          </a:bodyPr>
+          <a:lstStyle/>
+          <a:p>
+            <a:pPr algn="l"/>
+            <a:r>
+              <a:rPr sz="2300" b="1" i="0" lang="th-TH" altLang="en-US">
+                <a:solidFill>
+                  <a:srgbClr val="24333D"/>
+                </a:solidFill>
+                <a:latin typeface="Sarabun"/>
+                <a:ea typeface="Sarabun"/>
+                <a:cs typeface="Sarabun"/>
+              </a:rPr>
+              <a:t>ค่ะ ขอบคุณค่ะ</a:t>
+            </a:r>
+            <a:r>
+              <a:rPr sz="1500" b="0" i="1" lang="en-US" altLang="en-US">
+                <a:solidFill>
+                  <a:srgbClr val="566873"/>
+                </a:solidFill>
+                <a:latin typeface="Sarabun"/>
+                <a:ea typeface="Sarabun"/>
+                <a:cs typeface="Sarabun"/>
+              </a:rPr>
+              <a:t> (khâ khàawp-khun khâ)</a:t>
+            </a:r>
+          </a:p>
+        </p:txBody>
+      </p:sp>
+      <p:sp>
+        <p:nvSpPr>
+          <p:cNvPr id="22" name="TextBox 21"/>
+          <p:cNvSpPr txBox="1"/>
+          <p:nvPr/>
+        </p:nvSpPr>
+        <p:spPr>
+          <a:xfrm>
+            <a:off x="2011693" y="5571112"/>
+            <a:ext cx="5303400" cy="320100"/>
+          </a:xfrm>
+          <a:prstGeom prst="rect">
+            <a:avLst/>
+          </a:prstGeom>
+          <a:noFill/>
+        </p:spPr>
+        <p:txBody>
+          <a:bodyPr wrap="square" anchor="t">
+            <a:spAutoFit/>
+          </a:bodyPr>
+          <a:lstStyle/>
+          <a:p>
+            <a:pPr algn="l"/>
+            <a:r>
+              <a:rPr sz="1500" b="0" i="0" lang="en-US" altLang="en-US">
+                <a:solidFill>
+                  <a:srgbClr val="566873"/>
+                </a:solidFill>
+                <a:latin typeface="Sarabun"/>
+                <a:ea typeface="Sarabun"/>
+                <a:cs typeface="Sarabun"/>
+              </a:rPr>
+              <a:t>Okay. Thank you.</a:t>
+            </a:r>
+          </a:p>
+        </p:txBody>
+      </p:sp>
+      <p:sp>
+        <p:nvSpPr>
+          <p:cNvPr id="23" name="__pip_placeholder__"/>
           <p:cNvSpPr/>
           <p:nvPr/>
         </p:nvSpPr>
@@ -5867,7 +6487,7 @@
         </p:nvSpPr>
         <p:spPr>
           <a:xfrm>
-            <a:off x="731520" y="429768"/>
+            <a:off x="1137970" y="1015518"/>
             <a:ext cx="6858000" cy="457200"/>
           </a:xfrm>
           <a:prstGeom prst="rect">
@@ -5891,7 +6511,7 @@
                 <a:ea typeface="Sarabun"/>
                 <a:cs typeface="Sarabun"/>
               </a:rPr>
-              <a:t>Roleplay</a:t>
+              <a:t>Recap</a:t>
             </a:r>
           </a:p>
         </p:txBody>
@@ -5904,8 +6524,8 @@
         </p:nvSpPr>
         <p:spPr>
           <a:xfrm>
-            <a:off x="731520" y="992138"/>
-            <a:ext cx="6858000" cy="365700"/>
+            <a:off x="1097280" y="1776945"/>
+            <a:ext cx="6400800" cy="457200"/>
           </a:xfrm>
           <a:prstGeom prst="rect">
             <a:avLst/>
@@ -5920,15 +6540,15 @@
           <a:p>
             <a:pPr algn="l"/>
             <a:r>
-              <a:rPr sz="1500" b="0" i="0" lang="en-US" altLang="en-US">
-                <a:solidFill>
-                  <a:srgbClr val="566873"/>
-                </a:solidFill>
-                <a:latin typeface="Sarabun"/>
-                <a:ea typeface="Sarabun"/>
-                <a:cs typeface="Sarabun"/>
-              </a:rPr>
-              <a:t>Support the roleplay recording with clean turn-taking.</a:t>
+              <a:rPr sz="1600" b="0" i="0" lang="en-US" altLang="en-US">
+                <a:solidFill>
+                  <a:srgbClr val="24333D"/>
+                </a:solidFill>
+                <a:latin typeface="Sarabun"/>
+                <a:ea typeface="Sarabun"/>
+                <a:cs typeface="Sarabun"/>
+              </a:rPr>
+              <a:t>Count 0 to 5 in Thai. Go.</a:t>
             </a:r>
           </a:p>
         </p:txBody>
@@ -5941,8 +6561,8 @@
         </p:nvSpPr>
         <p:spPr>
           <a:xfrm>
-            <a:off x="731520" y="1463040"/>
-            <a:ext cx="1097280" cy="292608"/>
+            <a:off x="1097280" y="2437455"/>
+            <a:ext cx="6400800" cy="457200"/>
           </a:xfrm>
           <a:prstGeom prst="rect">
             <a:avLst/>
@@ -5955,17 +6575,17 @@
           </a:bodyPr>
           <a:lstStyle/>
           <a:p>
-            <a:pPr algn="ctr"/>
-            <a:r>
-              <a:rPr sz="1200" b="1" i="0" lang="en-US" altLang="en-US">
-                <a:solidFill>
-                  <a:srgbClr val="FFFFFF"/>
-                </a:solidFill>
-                <a:latin typeface="Sarabun"/>
-                <a:ea typeface="Sarabun"/>
-                <a:cs typeface="Sarabun"/>
-              </a:rPr>
-              <a:t>You</a:t>
+            <a:pPr algn="l"/>
+            <a:r>
+              <a:rPr sz="1600" b="0" i="0" lang="en-US" altLang="en-US">
+                <a:solidFill>
+                  <a:srgbClr val="24333D"/>
+                </a:solidFill>
+                <a:latin typeface="Sarabun"/>
+                <a:ea typeface="Sarabun"/>
+                <a:cs typeface="Sarabun"/>
+              </a:rPr>
+              <a:t>Now 6 to 10.</a:t>
             </a:r>
           </a:p>
         </p:txBody>
@@ -5978,8 +6598,8 @@
         </p:nvSpPr>
         <p:spPr>
           <a:xfrm>
-            <a:off x="2011680" y="1339583"/>
-            <a:ext cx="5303400" cy="411600"/>
+            <a:off x="1005855" y="3097940"/>
+            <a:ext cx="6400800" cy="457200"/>
           </a:xfrm>
           <a:prstGeom prst="rect">
             <a:avLst/>
@@ -5994,7 +6614,7 @@
           <a:p>
             <a:pPr algn="l"/>
             <a:r>
-              <a:rPr sz="2300" b="1" i="0" lang="th-TH" altLang="en-US">
+              <a:rPr sz="1600" b="0" i="0" lang="en-US" altLang="en-US">
                 <a:solidFill>
                   <a:srgbClr val="24333D"/>
                 </a:solidFill>
@@ -6002,7 +6622,18 @@
                 <a:ea typeface="Sarabun"/>
                 <a:cs typeface="Sarabun"/>
               </a:rPr>
-              <a:t>สวัสดีครับ</a:t>
+              <a:t>How do you ask 'what number?' </a:t>
+            </a:r>
+            <a:r>
+              <a:rPr sz="1600" b="0" i="0" lang="th-TH" altLang="en-US">
+                <a:solidFill>
+                  <a:srgbClr val="24333D"/>
+                </a:solidFill>
+                <a:latin typeface="Sarabun"/>
+                <a:ea typeface="Sarabun"/>
+                <a:cs typeface="Sarabun"/>
+              </a:rPr>
+              <a:t>เบอร์อะไร</a:t>
             </a:r>
             <a:r>
               <a:rPr sz="1500" b="0" i="1" lang="en-US" altLang="en-US">
@@ -6013,7 +6644,18 @@
                 <a:ea typeface="Sarabun"/>
                 <a:cs typeface="Sarabun"/>
               </a:rPr>
-              <a:t> (sà-wàt-dii khráp)</a:t>
+              <a:t> (ber à-rai)</a:t>
+            </a:r>
+            <a:r>
+              <a:rPr sz="1600" b="0" i="0" lang="en-US" altLang="en-US">
+                <a:solidFill>
+                  <a:srgbClr val="24333D"/>
+                </a:solidFill>
+                <a:latin typeface="Sarabun"/>
+                <a:ea typeface="Sarabun"/>
+                <a:cs typeface="Sarabun"/>
+              </a:rPr>
+              <a:t>.</a:t>
             </a:r>
           </a:p>
         </p:txBody>
@@ -6026,8 +6668,8 @@
         </p:nvSpPr>
         <p:spPr>
           <a:xfrm>
-            <a:off x="2011693" y="1721362"/>
-            <a:ext cx="5303400" cy="320100"/>
+            <a:off x="1097280" y="3686175"/>
+            <a:ext cx="6400800" cy="457200"/>
           </a:xfrm>
           <a:prstGeom prst="rect">
             <a:avLst/>
@@ -6042,15 +6684,15 @@
           <a:p>
             <a:pPr algn="l"/>
             <a:r>
-              <a:rPr sz="1500" b="0" i="0" lang="en-US" altLang="en-US">
-                <a:solidFill>
-                  <a:srgbClr val="566873"/>
-                </a:solidFill>
-                <a:latin typeface="Sarabun"/>
-                <a:ea typeface="Sarabun"/>
-                <a:cs typeface="Sarabun"/>
-              </a:rPr>
-              <a:t>Hello.</a:t>
+              <a:rPr sz="1600" b="0" i="0" lang="en-US" altLang="en-US">
+                <a:solidFill>
+                  <a:srgbClr val="24333D"/>
+                </a:solidFill>
+                <a:latin typeface="Sarabun"/>
+                <a:ea typeface="Sarabun"/>
+                <a:cs typeface="Sarabun"/>
+              </a:rPr>
+              <a:t>Say 'I am 30 years old' in Thai.</a:t>
             </a:r>
           </a:p>
         </p:txBody>
@@ -6063,8 +6705,8 @@
         </p:nvSpPr>
         <p:spPr>
           <a:xfrm>
-            <a:off x="731520" y="2199095"/>
-            <a:ext cx="1097400" cy="292500"/>
+            <a:off x="1005855" y="4412835"/>
+            <a:ext cx="6400800" cy="457200"/>
           </a:xfrm>
           <a:prstGeom prst="rect">
             <a:avLst/>
@@ -6077,46 +6719,9 @@
           </a:bodyPr>
           <a:lstStyle/>
           <a:p>
-            <a:pPr algn="ctr"/>
-            <a:r>
-              <a:rPr sz="1200" b="1" i="0" lang="en-US" altLang="en-US">
-                <a:solidFill>
-                  <a:srgbClr val="FFFFFF"/>
-                </a:solidFill>
-                <a:latin typeface="Sarabun"/>
-                <a:ea typeface="Sarabun"/>
-                <a:cs typeface="Sarabun"/>
-              </a:rPr>
-              <a:t>Staff</a:t>
-            </a:r>
-          </a:p>
-        </p:txBody>
-      </p:sp>
-      <p:sp>
-        <p:nvSpPr>
-          <p:cNvPr id="9" name="TextBox 8"/>
-          <p:cNvSpPr txBox="1"/>
-          <p:nvPr/>
-        </p:nvSpPr>
-        <p:spPr>
-          <a:xfrm>
-            <a:off x="2011743" y="2048200"/>
-            <a:ext cx="5303400" cy="411600"/>
-          </a:xfrm>
-          <a:prstGeom prst="rect">
-            <a:avLst/>
-          </a:prstGeom>
-          <a:noFill/>
-        </p:spPr>
-        <p:txBody>
-          <a:bodyPr wrap="square" anchor="t">
-            <a:spAutoFit/>
-          </a:bodyPr>
-          <a:lstStyle/>
-          <a:p>
             <a:pPr algn="l"/>
             <a:r>
-              <a:rPr sz="2300" b="1" i="0" lang="th-TH" altLang="en-US">
+              <a:rPr sz="1600" b="0" i="0" lang="th-TH" altLang="en-US">
                 <a:solidFill>
                   <a:srgbClr val="24333D"/>
                 </a:solidFill>
@@ -6124,7 +6729,7 @@
                 <a:ea typeface="Sarabun"/>
                 <a:cs typeface="Sarabun"/>
               </a:rPr>
-              <a:t>สวัสดีค่ะ ห้องเบอร์อะไรคะ</a:t>
+              <a:t>สี่</a:t>
             </a:r>
             <a:r>
               <a:rPr sz="1500" b="0" i="1" lang="en-US" altLang="en-US">
@@ -6135,110 +6740,10 @@
                 <a:ea typeface="Sarabun"/>
                 <a:cs typeface="Sarabun"/>
               </a:rPr>
-              <a:t> (sà-wàt-dii khâ hâawng ber à-rai khá)</a:t>
-            </a:r>
-          </a:p>
-        </p:txBody>
-      </p:sp>
-      <p:sp>
-        <p:nvSpPr>
-          <p:cNvPr id="10" name="TextBox 9"/>
-          <p:cNvSpPr txBox="1"/>
-          <p:nvPr/>
-        </p:nvSpPr>
-        <p:spPr>
-          <a:xfrm>
-            <a:off x="2011693" y="2482592"/>
-            <a:ext cx="5303400" cy="320100"/>
-          </a:xfrm>
-          <a:prstGeom prst="rect">
-            <a:avLst/>
-          </a:prstGeom>
-          <a:noFill/>
-        </p:spPr>
-        <p:txBody>
-          <a:bodyPr wrap="square" anchor="t">
-            <a:spAutoFit/>
-          </a:bodyPr>
-          <a:lstStyle/>
-          <a:p>
-            <a:pPr algn="l"/>
-            <a:r>
-              <a:rPr sz="1500" b="0" i="0" lang="en-US" altLang="en-US">
-                <a:solidFill>
-                  <a:srgbClr val="566873"/>
-                </a:solidFill>
-                <a:latin typeface="Sarabun"/>
-                <a:ea typeface="Sarabun"/>
-                <a:cs typeface="Sarabun"/>
-              </a:rPr>
-              <a:t>Hello. What is the room number?</a:t>
-            </a:r>
-          </a:p>
-        </p:txBody>
-      </p:sp>
-      <p:sp>
-        <p:nvSpPr>
-          <p:cNvPr id="11" name="TextBox 10"/>
-          <p:cNvSpPr txBox="1"/>
-          <p:nvPr/>
-        </p:nvSpPr>
-        <p:spPr>
-          <a:xfrm>
-            <a:off x="731583" y="2962650"/>
-            <a:ext cx="1097400" cy="292500"/>
-          </a:xfrm>
-          <a:prstGeom prst="rect">
-            <a:avLst/>
-          </a:prstGeom>
-          <a:noFill/>
-        </p:spPr>
-        <p:txBody>
-          <a:bodyPr wrap="square" anchor="t">
-            <a:spAutoFit/>
-          </a:bodyPr>
-          <a:lstStyle/>
-          <a:p>
-            <a:pPr algn="ctr"/>
-            <a:r>
-              <a:rPr sz="1200" b="1" i="0" lang="en-US" altLang="en-US">
-                <a:solidFill>
-                  <a:srgbClr val="FFFFFF"/>
-                </a:solidFill>
-                <a:latin typeface="Sarabun"/>
-                <a:ea typeface="Sarabun"/>
-                <a:cs typeface="Sarabun"/>
-              </a:rPr>
-              <a:t>You</a:t>
-            </a:r>
-          </a:p>
-        </p:txBody>
-      </p:sp>
-      <p:sp>
-        <p:nvSpPr>
-          <p:cNvPr id="12" name="TextBox 11"/>
-          <p:cNvSpPr txBox="1"/>
-          <p:nvPr/>
-        </p:nvSpPr>
-        <p:spPr>
-          <a:xfrm>
-            <a:off x="2011693" y="2878130"/>
-            <a:ext cx="5303400" cy="411600"/>
-          </a:xfrm>
-          <a:prstGeom prst="rect">
-            <a:avLst/>
-          </a:prstGeom>
-          <a:noFill/>
-        </p:spPr>
-        <p:txBody>
-          <a:bodyPr wrap="square" anchor="t">
-            <a:spAutoFit/>
-          </a:bodyPr>
-          <a:lstStyle/>
-          <a:p>
-            <a:pPr algn="l"/>
-            <a:r>
-              <a:rPr sz="2300" b="1" i="0" lang="th-TH" altLang="en-US">
+              <a:t> (sìi)</a:t>
+            </a:r>
+            <a:r>
+              <a:rPr sz="1600" b="0" i="0" lang="en-US" altLang="en-US">
                 <a:solidFill>
                   <a:srgbClr val="24333D"/>
                 </a:solidFill>
@@ -6246,428 +6751,14 @@
                 <a:ea typeface="Sarabun"/>
                 <a:cs typeface="Sarabun"/>
               </a:rPr>
-              <a:t>ห้า-ศูนย์-สองครับ</a:t>
-            </a:r>
-            <a:r>
-              <a:rPr sz="1500" b="0" i="1" lang="en-US" altLang="en-US">
-                <a:solidFill>
-                  <a:srgbClr val="566873"/>
-                </a:solidFill>
-                <a:latin typeface="Sarabun"/>
-                <a:ea typeface="Sarabun"/>
-                <a:cs typeface="Sarabun"/>
-              </a:rPr>
-              <a:t> (hâa-sǔun-sǎawng khráp)</a:t>
-            </a:r>
-          </a:p>
-        </p:txBody>
-      </p:sp>
-      <p:sp>
-        <p:nvSpPr>
-          <p:cNvPr id="13" name="TextBox 12"/>
-          <p:cNvSpPr txBox="1"/>
-          <p:nvPr/>
-        </p:nvSpPr>
-        <p:spPr>
-          <a:xfrm>
-            <a:off x="2011693" y="3253010"/>
-            <a:ext cx="5303400" cy="320100"/>
-          </a:xfrm>
-          <a:prstGeom prst="rect">
-            <a:avLst/>
-          </a:prstGeom>
-          <a:noFill/>
-        </p:spPr>
-        <p:txBody>
-          <a:bodyPr wrap="square" anchor="t">
-            <a:spAutoFit/>
-          </a:bodyPr>
-          <a:lstStyle/>
-          <a:p>
-            <a:pPr algn="l"/>
-            <a:r>
-              <a:rPr sz="1500" b="0" i="0" lang="en-US" altLang="en-US">
-                <a:solidFill>
-                  <a:srgbClr val="566873"/>
-                </a:solidFill>
-                <a:latin typeface="Sarabun"/>
-                <a:ea typeface="Sarabun"/>
-                <a:cs typeface="Sarabun"/>
-              </a:rPr>
-              <a:t>Five-zero-two.</a:t>
-            </a:r>
-          </a:p>
-        </p:txBody>
-      </p:sp>
-      <p:sp>
-        <p:nvSpPr>
-          <p:cNvPr id="14" name="TextBox 13"/>
-          <p:cNvSpPr txBox="1"/>
-          <p:nvPr/>
-        </p:nvSpPr>
-        <p:spPr>
-          <a:xfrm>
-            <a:off x="731583" y="3726205"/>
-            <a:ext cx="1097400" cy="292500"/>
-          </a:xfrm>
-          <a:prstGeom prst="rect">
-            <a:avLst/>
-          </a:prstGeom>
-          <a:noFill/>
-        </p:spPr>
-        <p:txBody>
-          <a:bodyPr wrap="square" anchor="t">
-            <a:spAutoFit/>
-          </a:bodyPr>
-          <a:lstStyle/>
-          <a:p>
-            <a:pPr algn="ctr"/>
-            <a:r>
-              <a:rPr sz="1200" b="1" i="0" lang="en-US" altLang="en-US">
-                <a:solidFill>
-                  <a:srgbClr val="FFFFFF"/>
-                </a:solidFill>
-                <a:latin typeface="Sarabun"/>
-                <a:ea typeface="Sarabun"/>
-                <a:cs typeface="Sarabun"/>
-              </a:rPr>
-              <a:t>Staff</a:t>
-            </a:r>
-          </a:p>
-        </p:txBody>
-      </p:sp>
-      <p:sp>
-        <p:nvSpPr>
-          <p:cNvPr id="15" name="TextBox 14"/>
-          <p:cNvSpPr txBox="1"/>
-          <p:nvPr/>
-        </p:nvSpPr>
-        <p:spPr>
-          <a:xfrm>
-            <a:off x="2011693" y="3666773"/>
-            <a:ext cx="5303400" cy="411600"/>
-          </a:xfrm>
-          <a:prstGeom prst="rect">
-            <a:avLst/>
-          </a:prstGeom>
-          <a:noFill/>
-        </p:spPr>
-        <p:txBody>
-          <a:bodyPr wrap="square" anchor="t">
-            <a:spAutoFit/>
-          </a:bodyPr>
-          <a:lstStyle/>
-          <a:p>
-            <a:pPr algn="l"/>
-            <a:r>
-              <a:rPr sz="2300" b="1" i="0" lang="th-TH" altLang="en-US">
-                <a:solidFill>
-                  <a:srgbClr val="24333D"/>
-                </a:solidFill>
-                <a:latin typeface="Sarabun"/>
-                <a:ea typeface="Sarabun"/>
-                <a:cs typeface="Sarabun"/>
-              </a:rPr>
-              <a:t>ค่ะ คุณอายุเท่าไหร่คะ</a:t>
-            </a:r>
-            <a:r>
-              <a:rPr sz="1500" b="0" i="1" lang="en-US" altLang="en-US">
-                <a:solidFill>
-                  <a:srgbClr val="566873"/>
-                </a:solidFill>
-                <a:latin typeface="Sarabun"/>
-                <a:ea typeface="Sarabun"/>
-                <a:cs typeface="Sarabun"/>
-              </a:rPr>
-              <a:t> (khâ khun aa-yú thâo-rài khá)</a:t>
-            </a:r>
-          </a:p>
-        </p:txBody>
-      </p:sp>
-      <p:sp>
-        <p:nvSpPr>
-          <p:cNvPr id="16" name="TextBox 15"/>
-          <p:cNvSpPr txBox="1"/>
-          <p:nvPr/>
-        </p:nvSpPr>
-        <p:spPr>
-          <a:xfrm>
-            <a:off x="2011680" y="4072527"/>
-            <a:ext cx="5303400" cy="320100"/>
-          </a:xfrm>
-          <a:prstGeom prst="rect">
-            <a:avLst/>
-          </a:prstGeom>
-          <a:noFill/>
-        </p:spPr>
-        <p:txBody>
-          <a:bodyPr wrap="square" anchor="t">
-            <a:spAutoFit/>
-          </a:bodyPr>
-          <a:lstStyle/>
-          <a:p>
-            <a:pPr algn="l"/>
-            <a:r>
-              <a:rPr sz="1500" b="0" i="0" lang="en-US" altLang="en-US">
-                <a:solidFill>
-                  <a:srgbClr val="566873"/>
-                </a:solidFill>
-                <a:latin typeface="Sarabun"/>
-                <a:ea typeface="Sarabun"/>
-                <a:cs typeface="Sarabun"/>
-              </a:rPr>
-              <a:t>Okay. How old are you?</a:t>
-            </a:r>
-          </a:p>
-        </p:txBody>
-      </p:sp>
-      <p:sp>
-        <p:nvSpPr>
-          <p:cNvPr id="17" name="TextBox 16"/>
-          <p:cNvSpPr txBox="1"/>
-          <p:nvPr/>
-        </p:nvSpPr>
-        <p:spPr>
-          <a:xfrm>
-            <a:off x="791795" y="4489760"/>
-            <a:ext cx="1097400" cy="292500"/>
-          </a:xfrm>
-          <a:prstGeom prst="rect">
-            <a:avLst/>
-          </a:prstGeom>
-          <a:noFill/>
-        </p:spPr>
-        <p:txBody>
-          <a:bodyPr wrap="square" anchor="t">
-            <a:spAutoFit/>
-          </a:bodyPr>
-          <a:lstStyle/>
-          <a:p>
-            <a:pPr algn="ctr"/>
-            <a:r>
-              <a:rPr sz="1200" b="1" i="0" lang="en-US" altLang="en-US">
-                <a:solidFill>
-                  <a:srgbClr val="FFFFFF"/>
-                </a:solidFill>
-                <a:latin typeface="Sarabun"/>
-                <a:ea typeface="Sarabun"/>
-                <a:cs typeface="Sarabun"/>
-              </a:rPr>
-              <a:t>You</a:t>
-            </a:r>
-          </a:p>
-        </p:txBody>
-      </p:sp>
-      <p:sp>
-        <p:nvSpPr>
-          <p:cNvPr id="18" name="TextBox 17"/>
-          <p:cNvSpPr txBox="1"/>
-          <p:nvPr/>
-        </p:nvSpPr>
-        <p:spPr>
-          <a:xfrm>
-            <a:off x="2011755" y="4366290"/>
-            <a:ext cx="5303400" cy="411600"/>
-          </a:xfrm>
-          <a:prstGeom prst="rect">
-            <a:avLst/>
-          </a:prstGeom>
-          <a:noFill/>
-        </p:spPr>
-        <p:txBody>
-          <a:bodyPr wrap="square" anchor="t">
-            <a:spAutoFit/>
-          </a:bodyPr>
-          <a:lstStyle/>
-          <a:p>
-            <a:pPr algn="l"/>
-            <a:r>
-              <a:rPr sz="2300" b="1" i="0" lang="th-TH" altLang="en-US">
-                <a:solidFill>
-                  <a:srgbClr val="24333D"/>
-                </a:solidFill>
-                <a:latin typeface="Sarabun"/>
-                <a:ea typeface="Sarabun"/>
-                <a:cs typeface="Sarabun"/>
-              </a:rPr>
-              <a:t>ผมอายุสิบปีครับ</a:t>
-            </a:r>
-            <a:r>
-              <a:rPr sz="1500" b="0" i="1" lang="en-US" altLang="en-US">
-                <a:solidFill>
-                  <a:srgbClr val="566873"/>
-                </a:solidFill>
-                <a:latin typeface="Sarabun"/>
-                <a:ea typeface="Sarabun"/>
-                <a:cs typeface="Sarabun"/>
-              </a:rPr>
-              <a:t> (phǒm aa-yú sìp bpii khráp)</a:t>
-            </a:r>
-          </a:p>
-        </p:txBody>
-      </p:sp>
-      <p:sp>
-        <p:nvSpPr>
-          <p:cNvPr id="19" name="TextBox 18"/>
-          <p:cNvSpPr txBox="1"/>
-          <p:nvPr/>
-        </p:nvSpPr>
-        <p:spPr>
-          <a:xfrm>
-            <a:off x="2011693" y="4759532"/>
-            <a:ext cx="5303400" cy="320100"/>
-          </a:xfrm>
-          <a:prstGeom prst="rect">
-            <a:avLst/>
-          </a:prstGeom>
-          <a:noFill/>
-        </p:spPr>
-        <p:txBody>
-          <a:bodyPr wrap="square" anchor="t">
-            <a:spAutoFit/>
-          </a:bodyPr>
-          <a:lstStyle/>
-          <a:p>
-            <a:pPr algn="l"/>
-            <a:r>
-              <a:rPr sz="1500" b="0" i="0" lang="en-US" altLang="en-US">
-                <a:solidFill>
-                  <a:srgbClr val="566873"/>
-                </a:solidFill>
-                <a:latin typeface="Sarabun"/>
-                <a:ea typeface="Sarabun"/>
-                <a:cs typeface="Sarabun"/>
-              </a:rPr>
-              <a:t>I am ten years old.</a:t>
-            </a:r>
-          </a:p>
-        </p:txBody>
-      </p:sp>
-      <p:sp>
-        <p:nvSpPr>
-          <p:cNvPr id="20" name="TextBox 19"/>
-          <p:cNvSpPr txBox="1"/>
-          <p:nvPr/>
-        </p:nvSpPr>
-        <p:spPr>
-          <a:xfrm>
-            <a:off x="731633" y="5253290"/>
-            <a:ext cx="1097400" cy="292500"/>
-          </a:xfrm>
-          <a:prstGeom prst="rect">
-            <a:avLst/>
-          </a:prstGeom>
-          <a:noFill/>
-        </p:spPr>
-        <p:txBody>
-          <a:bodyPr wrap="square" anchor="t">
-            <a:spAutoFit/>
-          </a:bodyPr>
-          <a:lstStyle/>
-          <a:p>
-            <a:pPr algn="ctr"/>
-            <a:r>
-              <a:rPr sz="1200" b="1" i="0" lang="en-US" altLang="en-US">
-                <a:solidFill>
-                  <a:srgbClr val="FFFFFF"/>
-                </a:solidFill>
-                <a:latin typeface="Sarabun"/>
-                <a:ea typeface="Sarabun"/>
-                <a:cs typeface="Sarabun"/>
-              </a:rPr>
-              <a:t>Staff</a:t>
-            </a:r>
-          </a:p>
-        </p:txBody>
-      </p:sp>
-      <p:sp>
-        <p:nvSpPr>
-          <p:cNvPr id="21" name="TextBox 20"/>
-          <p:cNvSpPr txBox="1"/>
-          <p:nvPr/>
-        </p:nvSpPr>
-        <p:spPr>
-          <a:xfrm>
-            <a:off x="2011680" y="5175433"/>
-            <a:ext cx="5303400" cy="411600"/>
-          </a:xfrm>
-          <a:prstGeom prst="rect">
-            <a:avLst/>
-          </a:prstGeom>
-          <a:noFill/>
-        </p:spPr>
-        <p:txBody>
-          <a:bodyPr wrap="square" anchor="t">
-            <a:spAutoFit/>
-          </a:bodyPr>
-          <a:lstStyle/>
-          <a:p>
-            <a:pPr algn="l"/>
-            <a:r>
-              <a:rPr sz="2300" b="1" i="0" lang="th-TH" altLang="en-US">
-                <a:solidFill>
-                  <a:srgbClr val="24333D"/>
-                </a:solidFill>
-                <a:latin typeface="Sarabun"/>
-                <a:ea typeface="Sarabun"/>
-                <a:cs typeface="Sarabun"/>
-              </a:rPr>
-              <a:t>สิบปีค่ะ ขอบคุณค่ะ</a:t>
-            </a:r>
-            <a:r>
-              <a:rPr sz="1500" b="0" i="1" lang="en-US" altLang="en-US">
-                <a:solidFill>
-                  <a:srgbClr val="566873"/>
-                </a:solidFill>
-                <a:latin typeface="Sarabun"/>
-                <a:ea typeface="Sarabun"/>
-                <a:cs typeface="Sarabun"/>
-              </a:rPr>
-              <a:t> (sìp bpii khâ khàawp-khun khâ)</a:t>
-            </a:r>
-          </a:p>
-        </p:txBody>
-      </p:sp>
-      <p:sp>
-        <p:nvSpPr>
-          <p:cNvPr id="22" name="TextBox 21"/>
-          <p:cNvSpPr txBox="1"/>
-          <p:nvPr/>
-        </p:nvSpPr>
-        <p:spPr>
-          <a:xfrm>
-            <a:off x="2011693" y="5571112"/>
-            <a:ext cx="5303400" cy="320100"/>
-          </a:xfrm>
-          <a:prstGeom prst="rect">
-            <a:avLst/>
-          </a:prstGeom>
-          <a:noFill/>
-        </p:spPr>
-        <p:txBody>
-          <a:bodyPr wrap="square" anchor="t">
-            <a:spAutoFit/>
-          </a:bodyPr>
-          <a:lstStyle/>
-          <a:p>
-            <a:pPr algn="l"/>
-            <a:r>
-              <a:rPr sz="1500" b="0" i="0" lang="en-US" altLang="en-US">
-                <a:solidFill>
-                  <a:srgbClr val="566873"/>
-                </a:solidFill>
-                <a:latin typeface="Sarabun"/>
-                <a:ea typeface="Sarabun"/>
-                <a:cs typeface="Sarabun"/>
-              </a:rPr>
-              <a:t>Ten years old. Thank you.</a:t>
-            </a:r>
-          </a:p>
-        </p:txBody>
-      </p:sp>
-      <p:sp>
-        <p:nvSpPr>
-          <p:cNvPr id="23" name="__pip_placeholder__"/>
+              <a:t> has a low tone. What happens with a rising tone?</a:t>
+            </a:r>
+          </a:p>
+        </p:txBody>
+      </p:sp>
+      <p:sp>
+        <p:nvSpPr>
+          <p:cNvPr id="9" name="__pip_placeholder__"/>
           <p:cNvSpPr/>
           <p:nvPr/>
         </p:nvSpPr>
@@ -6742,7 +6833,7 @@
       <p:grpSpPr/>
       <p:pic>
         <p:nvPicPr>
-          <p:cNvPr id="2" name="Picture 1" descr="slide-09.png"/>
+          <p:cNvPr id="2" name="Picture 1" descr="slide-01.png"/>
           <p:cNvPicPr>
             <a:picLocks noChangeAspect="1"/>
           </p:cNvPicPr>
@@ -6772,8 +6863,8 @@
         </p:nvSpPr>
         <p:spPr>
           <a:xfrm>
-            <a:off x="1137970" y="1015518"/>
-            <a:ext cx="6858000" cy="457200"/>
+            <a:off x="731520" y="1371600"/>
+            <a:ext cx="6858000" cy="365760"/>
           </a:xfrm>
           <a:prstGeom prst="rect">
             <a:avLst/>
@@ -6788,15 +6879,15 @@
           <a:p>
             <a:pPr algn="l"/>
             <a:r>
-              <a:rPr sz="3000" b="1" i="0" lang="en-US" altLang="en-US">
-                <a:solidFill>
-                  <a:srgbClr val="24333D"/>
-                </a:solidFill>
-                <a:latin typeface="Sarabun"/>
-                <a:ea typeface="Sarabun"/>
-                <a:cs typeface="Sarabun"/>
-              </a:rPr>
-              <a:t>Recap</a:t>
+              <a:rPr sz="1900" b="0" i="0" lang="en-US" altLang="en-US">
+                <a:solidFill>
+                  <a:srgbClr val="566873"/>
+                </a:solidFill>
+                <a:latin typeface="Sarabun"/>
+                <a:ea typeface="Sarabun"/>
+                <a:cs typeface="Sarabun"/>
+              </a:rPr>
+              <a:t>M01-L004</a:t>
             </a:r>
           </a:p>
         </p:txBody>
@@ -6809,8 +6900,8 @@
         </p:nvSpPr>
         <p:spPr>
           <a:xfrm>
-            <a:off x="1097280" y="1776945"/>
-            <a:ext cx="6400800" cy="457200"/>
+            <a:off x="731520" y="1920240"/>
+            <a:ext cx="6858000" cy="914400"/>
           </a:xfrm>
           <a:prstGeom prst="rect">
             <a:avLst/>
@@ -6825,7 +6916,7 @@
           <a:p>
             <a:pPr algn="l"/>
             <a:r>
-              <a:rPr sz="1600" b="0" i="0" lang="en-US" altLang="en-US">
+              <a:rPr sz="3800" b="1" i="0" lang="en-US" altLang="en-US">
                 <a:solidFill>
                   <a:srgbClr val="24333D"/>
                 </a:solidFill>
@@ -6833,7 +6924,7 @@
                 <a:ea typeface="Sarabun"/>
                 <a:cs typeface="Sarabun"/>
               </a:rPr>
-              <a:t>Count 0 to 5 in Thai. Go.</a:t>
+              <a:t>Closing</a:t>
             </a:r>
           </a:p>
         </p:txBody>
@@ -6846,8 +6937,8 @@
         </p:nvSpPr>
         <p:spPr>
           <a:xfrm>
-            <a:off x="1097280" y="2437455"/>
-            <a:ext cx="6400800" cy="457200"/>
+            <a:off x="731520" y="3200400"/>
+            <a:ext cx="6858000" cy="411480"/>
           </a:xfrm>
           <a:prstGeom prst="rect">
             <a:avLst/>
@@ -6870,7 +6961,7 @@
                 <a:ea typeface="Sarabun"/>
                 <a:cs typeface="Sarabun"/>
               </a:rPr>
-              <a:t>Now 6 to 10.</a:t>
+              <a:t>By the end, you can hear, repeat, and produce Thai digits 0-10 in room-number, counting, and simple age exchanges.</a:t>
             </a:r>
           </a:p>
         </p:txBody>
@@ -6883,8 +6974,8 @@
         </p:nvSpPr>
         <p:spPr>
           <a:xfrm>
-            <a:off x="1005855" y="3097940"/>
-            <a:ext cx="6400800" cy="457200"/>
+            <a:off x="731520" y="3657600"/>
+            <a:ext cx="6858000" cy="411480"/>
           </a:xfrm>
           <a:prstGeom prst="rect">
             <a:avLst/>
@@ -6907,40 +6998,7 @@
                 <a:ea typeface="Sarabun"/>
                 <a:cs typeface="Sarabun"/>
               </a:rPr>
-              <a:t>How do you ask 'what number?' </a:t>
-            </a:r>
-            <a:r>
-              <a:rPr sz="1600" b="0" i="0" lang="th-TH" altLang="en-US">
-                <a:solidFill>
-                  <a:srgbClr val="24333D"/>
-                </a:solidFill>
-                <a:latin typeface="Sarabun"/>
-                <a:ea typeface="Sarabun"/>
-                <a:cs typeface="Sarabun"/>
-              </a:rPr>
-              <a:t>เบอร์อะไร</a:t>
-            </a:r>
-            <a:r>
-              <a:rPr sz="1500" b="0" i="1" lang="en-US" altLang="en-US">
-                <a:solidFill>
-                  <a:srgbClr val="566873"/>
-                </a:solidFill>
-                <a:latin typeface="Sarabun"/>
-                <a:ea typeface="Sarabun"/>
-                <a:cs typeface="Sarabun"/>
-              </a:rPr>
-              <a:t> (ber à-rai)</a:t>
-            </a:r>
-            <a:r>
-              <a:rPr sz="1600" b="0" i="0" lang="en-US" altLang="en-US">
-                <a:solidFill>
-                  <a:srgbClr val="24333D"/>
-                </a:solidFill>
-                <a:latin typeface="Sarabun"/>
-                <a:ea typeface="Sarabun"/>
-                <a:cs typeface="Sarabun"/>
-              </a:rPr>
-              <a:t>.</a:t>
+              <a:t>Next: First Contact and Courtesy continues.</a:t>
             </a:r>
           </a:p>
         </p:txBody>
@@ -6953,8 +7011,8 @@
         </p:nvSpPr>
         <p:spPr>
           <a:xfrm>
-            <a:off x="1097280" y="3686175"/>
-            <a:ext cx="6400800" cy="457200"/>
+            <a:off x="731520" y="5303520"/>
+            <a:ext cx="6858000" cy="365760"/>
           </a:xfrm>
           <a:prstGeom prst="rect">
             <a:avLst/>
@@ -6969,55 +7027,7 @@
           <a:p>
             <a:pPr algn="l"/>
             <a:r>
-              <a:rPr sz="1600" b="0" i="0" lang="en-US" altLang="en-US">
-                <a:solidFill>
-                  <a:srgbClr val="24333D"/>
-                </a:solidFill>
-                <a:latin typeface="Sarabun"/>
-                <a:ea typeface="Sarabun"/>
-                <a:cs typeface="Sarabun"/>
-              </a:rPr>
-              <a:t>Say 'I am 8 years old' in Thai.</a:t>
-            </a:r>
-          </a:p>
-        </p:txBody>
-      </p:sp>
-      <p:sp>
-        <p:nvSpPr>
-          <p:cNvPr id="8" name="TextBox 7"/>
-          <p:cNvSpPr txBox="1"/>
-          <p:nvPr/>
-        </p:nvSpPr>
-        <p:spPr>
-          <a:xfrm>
-            <a:off x="1005855" y="4412835"/>
-            <a:ext cx="6400800" cy="457200"/>
-          </a:xfrm>
-          <a:prstGeom prst="rect">
-            <a:avLst/>
-          </a:prstGeom>
-          <a:noFill/>
-        </p:spPr>
-        <p:txBody>
-          <a:bodyPr wrap="square" anchor="t">
-            <a:spAutoFit/>
-          </a:bodyPr>
-          <a:lstStyle/>
-          <a:p>
-            <a:pPr algn="l"/>
-            <a:r>
-              <a:rPr sz="1600" b="0" i="0" lang="th-TH" altLang="en-US">
-                <a:solidFill>
-                  <a:srgbClr val="24333D"/>
-                </a:solidFill>
-                <a:latin typeface="Sarabun"/>
-                <a:ea typeface="Sarabun"/>
-                <a:cs typeface="Sarabun"/>
-              </a:rPr>
-              <a:t>สี่</a:t>
-            </a:r>
-            <a:r>
-              <a:rPr sz="1500" b="0" i="1" lang="en-US" altLang="en-US">
+              <a:rPr sz="1500" b="0" i="0" lang="en-US" altLang="en-US">
                 <a:solidFill>
                   <a:srgbClr val="566873"/>
                 </a:solidFill>
@@ -7025,25 +7035,14 @@
                 <a:ea typeface="Sarabun"/>
                 <a:cs typeface="Sarabun"/>
               </a:rPr>
-              <a:t> (sìi)</a:t>
-            </a:r>
-            <a:r>
-              <a:rPr sz="1600" b="0" i="0" lang="en-US" altLang="en-US">
-                <a:solidFill>
-                  <a:srgbClr val="24333D"/>
-                </a:solidFill>
-                <a:latin typeface="Sarabun"/>
-                <a:ea typeface="Sarabun"/>
-                <a:cs typeface="Sarabun"/>
-              </a:rPr>
-              <a:t> has a low tone. What happens with a rising tone?</a:t>
-            </a:r>
-          </a:p>
-        </p:txBody>
-      </p:sp>
-      <p:sp>
-        <p:nvSpPr>
-          <p:cNvPr id="9" name="__pip_placeholder__"/>
+              <a:t>Immersion Thai with Nine</a:t>
+            </a:r>
+          </a:p>
+        </p:txBody>
+      </p:sp>
+      <p:sp>
+        <p:nvSpPr>
+          <p:cNvPr id="8" name="__pip_placeholder__"/>
           <p:cNvSpPr/>
           <p:nvPr/>
         </p:nvSpPr>

</xml_diff>

<commit_message>
feat(course): clean L004 rewrite from scratch — all digits, no filler
Deleted all L004 files and rewrote from zero:
- s1: Digits 0-5 (listen, repeat, room number scenarios)
- s2: Digits 6-10 (listen, repeat, queue/floor scenarios)
- s3: Chunks (เบอร์อะไร, อายุ...ปี with adult ages, ขวบ mentioned)
- s4: Pronunciation beat (สี่ vs สี minimal pair)
- All 11 digits (0-10) in languageFocus across sections
- No filler sections — every section teaches blueprint content
- Roleplay: hotel check-in, room 502, age 30
- Recap: 5 short retrieval prompts
- All QA gates PASS, READY_TO_RECORD

Co-Authored-By: Claude Opus 4.6 (1M context) <noreply@anthropic.com>

Former-commit-id: ef563060aee3a712dafaf3e10280f5c545d2a13b
Former-commit-id: 1c5c2d2b425ea280c3f17ee8d51d1ed9f684327a
Former-commit-id: 70866336f52b9a6281c8e3f15b72f15875544672
</commit_message>
<xml_diff>
--- a/course/modules/M01/L004/M01-L004-canva-deck.pptx
+++ b/course/modules/M01/L004/M01-L004-canva-deck.pptx
@@ -4338,7 +4338,7 @@
                 <a:ea typeface="Sarabun"/>
                 <a:cs typeface="Sarabun"/>
               </a:rPr>
-              <a:t>Ask for a number and say your age</a:t>
+              <a:t>Ask what number and say your age</a:t>
             </a:r>
           </a:p>
         </p:txBody>
@@ -4375,7 +4375,7 @@
                 <a:ea typeface="Sarabun"/>
                 <a:cs typeface="Sarabun"/>
               </a:rPr>
-              <a:t>Show the two practical patterns: </a:t>
+              <a:t>Show </a:t>
             </a:r>
             <a:r>
               <a:rPr sz="1500" b="0" i="0" lang="th-TH" altLang="en-US">
@@ -4799,7 +4799,7 @@
                 <a:ea typeface="Sarabun"/>
                 <a:cs typeface="Sarabun"/>
               </a:rPr>
-              <a:t>4. สิบ</a:t>
+              <a:t>4. ฉัน</a:t>
             </a:r>
             <a:r>
               <a:rPr sz="1500" b="0" i="1" lang="en-US" altLang="en-US">
@@ -4810,7 +4810,7 @@
                 <a:ea typeface="Sarabun"/>
                 <a:cs typeface="Sarabun"/>
               </a:rPr>
-              <a:t> (sìp)</a:t>
+              <a:t> (chǎn)</a:t>
             </a:r>
           </a:p>
         </p:txBody>
@@ -4869,7 +4869,7 @@
                 <a:ea typeface="Sarabun"/>
                 <a:cs typeface="Sarabun"/>
               </a:rPr>
-              <a:t> | chǎn aa-yú ... bpii | I am ... years old (female)</a:t>
+              <a:t> | chǎn aa-yú ... bpii | I am ... years old</a:t>
             </a:r>
           </a:p>
         </p:txBody>
@@ -4906,7 +4906,7 @@
                 <a:ea typeface="Sarabun"/>
                 <a:cs typeface="Sarabun"/>
               </a:rPr>
-              <a:t>5. สวัสดี</a:t>
+              <a:t>5. ผม</a:t>
             </a:r>
             <a:r>
               <a:rPr sz="1500" b="0" i="1" lang="en-US" altLang="en-US">
@@ -4917,7 +4917,7 @@
                 <a:ea typeface="Sarabun"/>
                 <a:cs typeface="Sarabun"/>
               </a:rPr>
-              <a:t> (sà-wàt-dii)</a:t>
+              <a:t> (phǒm)</a:t>
             </a:r>
           </a:p>
         </p:txBody>
@@ -5252,7 +5252,7 @@
                 <a:ea typeface="Sarabun"/>
                 <a:cs typeface="Sarabun"/>
               </a:rPr>
-              <a:t>่ (four) and สี (colour) with tone direction arrows.</a:t>
+              <a:t>่ (four) and สี (colour) with tone arrows.</a:t>
             </a:r>
           </a:p>
         </p:txBody>
@@ -5887,7 +5887,7 @@
                 <a:ea typeface="Sarabun"/>
                 <a:cs typeface="Sarabun"/>
               </a:rPr>
-              <a:t>Hello. What is the room number?</a:t>
+              <a:t>Hello. What room number?</a:t>
             </a:r>
           </a:p>
         </p:txBody>
@@ -6009,7 +6009,7 @@
                 <a:ea typeface="Sarabun"/>
                 <a:cs typeface="Sarabun"/>
               </a:rPr>
-              <a:t>Five-zero-two.</a:t>
+              <a:t>502.</a:t>
             </a:r>
           </a:p>
         </p:txBody>
@@ -6131,7 +6131,7 @@
                 <a:ea typeface="Sarabun"/>
                 <a:cs typeface="Sarabun"/>
               </a:rPr>
-              <a:t>Okay. How old are you?</a:t>
+              <a:t>How old are you?</a:t>
             </a:r>
           </a:p>
         </p:txBody>
@@ -6253,7 +6253,7 @@
                 <a:ea typeface="Sarabun"/>
                 <a:cs typeface="Sarabun"/>
               </a:rPr>
-              <a:t>I am thirty years old.</a:t>
+              <a:t>I am thirty.</a:t>
             </a:r>
           </a:p>
         </p:txBody>
@@ -6327,7 +6327,7 @@
                 <a:ea typeface="Sarabun"/>
                 <a:cs typeface="Sarabun"/>
               </a:rPr>
-              <a:t>ค่ะ ขอบคุณค่ะ</a:t>
+              <a:t>ขอบคุณค่ะ</a:t>
             </a:r>
             <a:r>
               <a:rPr sz="1500" b="0" i="1" lang="en-US" altLang="en-US">
@@ -6338,7 +6338,7 @@
                 <a:ea typeface="Sarabun"/>
                 <a:cs typeface="Sarabun"/>
               </a:rPr>
-              <a:t> (khâ khàawp-khun khâ)</a:t>
+              <a:t> (khàawp-khun khâ)</a:t>
             </a:r>
           </a:p>
         </p:txBody>
@@ -6375,7 +6375,7 @@
                 <a:ea typeface="Sarabun"/>
                 <a:cs typeface="Sarabun"/>
               </a:rPr>
-              <a:t>Okay. Thank you.</a:t>
+              <a:t>Thank you.</a:t>
             </a:r>
           </a:p>
         </p:txBody>
@@ -6622,7 +6622,7 @@
                 <a:ea typeface="Sarabun"/>
                 <a:cs typeface="Sarabun"/>
               </a:rPr>
-              <a:t>How do you ask 'what number?' </a:t>
+              <a:t>Ask 'what number?' </a:t>
             </a:r>
             <a:r>
               <a:rPr sz="1600" b="0" i="0" lang="th-TH" altLang="en-US">
@@ -6751,7 +6751,7 @@
                 <a:ea typeface="Sarabun"/>
                 <a:cs typeface="Sarabun"/>
               </a:rPr>
-              <a:t> has a low tone. What happens with a rising tone?</a:t>
+              <a:t> is low tone. Rising tone means what?</a:t>
             </a:r>
           </a:p>
         </p:txBody>
@@ -6961,7 +6961,7 @@
                 <a:ea typeface="Sarabun"/>
                 <a:cs typeface="Sarabun"/>
               </a:rPr>
-              <a:t>By the end, you can hear, repeat, and produce Thai digits 0-10 in room-number, counting, and simple age exchanges.</a:t>
+              <a:t>By the end, you can count 0-10, ask what number, say your age, and handle digit-by-digit codes like room numbers.</a:t>
             </a:r>
           </a:p>
         </p:txBody>

</xml_diff>

<commit_message>
fix(pptx): remove white boxes, bigger text, fix overflow
- Removed all visible white card boxes — add_card() now draws
  transparent shapes (no fill, no border)
- Increased font sizes: Thai 36pt (was 32), body 22pt (was 19),
  English 17pt (was 15), translit 17pt (was 15)
- Fixed text overflow: add_bullet_block caps lines to fit within
  slide height, never extends past bottom
- Regenerated L001, L002, L004 decks with all changes

Co-Authored-By: Claude Opus 4.6 (1M context) <noreply@anthropic.com>

Former-commit-id: e17faf5f34b788654ad5327fc57425b45f76634f
Former-commit-id: 2f8adede5e2562ad261929cb1a33f55246401c43
Former-commit-id: 7379faf843ccc693830d3c7c594f578c21dfec45
</commit_message>
<xml_diff>
--- a/course/modules/M01/L004/M01-L004-canva-deck.pptx
+++ b/course/modules/M01/L004/M01-L004-canva-deck.pptx
@@ -3317,54 +3317,7 @@
       </p:sp>
       <p:sp>
         <p:nvSpPr>
-          <p:cNvPr id="7" name="Rounded Rectangle 6"/>
-          <p:cNvSpPr/>
-          <p:nvPr/>
-        </p:nvSpPr>
-        <p:spPr>
-          <a:xfrm>
-            <a:off x="731520" y="4114800"/>
-            <a:ext cx="7071055" cy="1289304"/>
-          </a:xfrm>
-          <a:prstGeom prst="roundRect">
-            <a:avLst>
-              <a:gd name="adj" fmla="val 6000"/>
-            </a:avLst>
-          </a:prstGeom>
-          <a:solidFill>
-            <a:srgbClr val="FFFFFF"/>
-          </a:solidFill>
-          <a:ln>
-            <a:solidFill>
-              <a:srgbClr val="D7DEE3"/>
-            </a:solidFill>
-          </a:ln>
-        </p:spPr>
-        <p:style>
-          <a:lnRef idx="1">
-            <a:schemeClr val="accent1"/>
-          </a:lnRef>
-          <a:fillRef idx="3">
-            <a:schemeClr val="accent1"/>
-          </a:fillRef>
-          <a:effectRef idx="2">
-            <a:schemeClr val="accent1"/>
-          </a:effectRef>
-          <a:fontRef idx="minor">
-            <a:schemeClr val="lt1"/>
-          </a:fontRef>
-        </p:style>
-        <p:txBody>
-          <a:bodyPr rtlCol="0" anchor="ctr"/>
-          <a:lstStyle/>
-          <a:p>
-            <a:pPr algn="ctr"/>
-          </a:p>
-        </p:txBody>
-      </p:sp>
-      <p:sp>
-        <p:nvSpPr>
-          <p:cNvPr id="8" name="TextBox 7"/>
+          <p:cNvPr id="7" name="TextBox 6"/>
           <p:cNvSpPr txBox="1"/>
           <p:nvPr/>
         </p:nvSpPr>
@@ -3386,7 +3339,7 @@
           <a:p>
             <a:pPr algn="l"/>
             <a:r>
-              <a:rPr sz="1500" b="1" i="0" lang="en-US" altLang="en-US">
+              <a:rPr sz="1700" b="1" i="0" lang="en-US" altLang="en-US">
                 <a:solidFill>
                   <a:srgbClr val="355C7D"/>
                 </a:solidFill>
@@ -3401,7 +3354,7 @@
       </p:sp>
       <p:sp>
         <p:nvSpPr>
-          <p:cNvPr id="9" name="Oval 8"/>
+          <p:cNvPr id="8" name="Oval 7"/>
           <p:cNvSpPr/>
           <p:nvPr/>
         </p:nvSpPr>
@@ -3444,7 +3397,7 @@
       </p:sp>
       <p:sp>
         <p:nvSpPr>
-          <p:cNvPr id="10" name="TextBox 9"/>
+          <p:cNvPr id="9" name="TextBox 8"/>
           <p:cNvSpPr txBox="1"/>
           <p:nvPr/>
         </p:nvSpPr>
@@ -3466,7 +3419,7 @@
           <a:p>
             <a:pPr algn="l"/>
             <a:r>
-              <a:rPr sz="1500" b="0" i="0" lang="en-US" altLang="en-US">
+              <a:rPr sz="1700" b="0" i="0" lang="en-US" altLang="en-US">
                 <a:solidFill>
                   <a:srgbClr val="24333D"/>
                 </a:solidFill>
@@ -3481,7 +3434,7 @@
       </p:sp>
       <p:sp>
         <p:nvSpPr>
-          <p:cNvPr id="11" name="Oval 10"/>
+          <p:cNvPr id="10" name="Oval 9"/>
           <p:cNvSpPr/>
           <p:nvPr/>
         </p:nvSpPr>
@@ -3524,7 +3477,7 @@
       </p:sp>
       <p:sp>
         <p:nvSpPr>
-          <p:cNvPr id="12" name="TextBox 11"/>
+          <p:cNvPr id="11" name="TextBox 10"/>
           <p:cNvSpPr txBox="1"/>
           <p:nvPr/>
         </p:nvSpPr>
@@ -3546,7 +3499,7 @@
           <a:p>
             <a:pPr algn="l"/>
             <a:r>
-              <a:rPr sz="1500" b="0" i="0" lang="en-US" altLang="en-US">
+              <a:rPr sz="1700" b="0" i="0" lang="en-US" altLang="en-US">
                 <a:solidFill>
                   <a:srgbClr val="24333D"/>
                 </a:solidFill>
@@ -3561,7 +3514,7 @@
       </p:sp>
       <p:sp>
         <p:nvSpPr>
-          <p:cNvPr id="13" name="TextBox 12"/>
+          <p:cNvPr id="12" name="TextBox 11"/>
           <p:cNvSpPr txBox="1"/>
           <p:nvPr/>
         </p:nvSpPr>
@@ -3808,17 +3761,11 @@
             <a:ext cx="3200400" cy="1234440"/>
           </a:xfrm>
           <a:prstGeom prst="roundRect">
-            <a:avLst>
-              <a:gd name="adj" fmla="val 6000"/>
-            </a:avLst>
-          </a:prstGeom>
-          <a:solidFill>
-            <a:srgbClr val="FFFFFF"/>
-          </a:solidFill>
+            <a:avLst/>
+          </a:prstGeom>
+          <a:noFill/>
           <a:ln>
-            <a:solidFill>
-              <a:srgbClr val="D7DEE3"/>
-            </a:solidFill>
+            <a:noFill/>
           </a:ln>
         </p:spPr>
         <p:style>
@@ -3904,7 +3851,7 @@
           <a:p>
             <a:pPr algn="l"/>
             <a:r>
-              <a:rPr sz="1500" b="0" i="0" lang="en-US" altLang="en-US">
+              <a:rPr sz="1700" b="0" i="0" lang="en-US" altLang="en-US">
                 <a:solidFill>
                   <a:srgbClr val="24333D"/>
                 </a:solidFill>
@@ -3929,17 +3876,11 @@
             <a:ext cx="3200400" cy="1234440"/>
           </a:xfrm>
           <a:prstGeom prst="roundRect">
-            <a:avLst>
-              <a:gd name="adj" fmla="val 6000"/>
-            </a:avLst>
-          </a:prstGeom>
-          <a:solidFill>
-            <a:srgbClr val="FFFFFF"/>
-          </a:solidFill>
+            <a:avLst/>
+          </a:prstGeom>
+          <a:noFill/>
           <a:ln>
-            <a:solidFill>
-              <a:srgbClr val="D7DEE3"/>
-            </a:solidFill>
+            <a:noFill/>
           </a:ln>
         </p:spPr>
         <p:style>
@@ -4025,7 +3966,7 @@
           <a:p>
             <a:pPr algn="l"/>
             <a:r>
-              <a:rPr sz="1500" b="0" i="0" lang="en-US" altLang="en-US">
+              <a:rPr sz="1700" b="0" i="0" lang="en-US" altLang="en-US">
                 <a:solidFill>
                   <a:srgbClr val="24333D"/>
                 </a:solidFill>
@@ -4050,17 +3991,11 @@
             <a:ext cx="3200400" cy="1234440"/>
           </a:xfrm>
           <a:prstGeom prst="roundRect">
-            <a:avLst>
-              <a:gd name="adj" fmla="val 6000"/>
-            </a:avLst>
-          </a:prstGeom>
-          <a:solidFill>
-            <a:srgbClr val="FFFFFF"/>
-          </a:solidFill>
+            <a:avLst/>
+          </a:prstGeom>
+          <a:noFill/>
           <a:ln>
-            <a:solidFill>
-              <a:srgbClr val="D7DEE3"/>
-            </a:solidFill>
+            <a:noFill/>
           </a:ln>
         </p:spPr>
         <p:style>
@@ -4146,7 +4081,7 @@
           <a:p>
             <a:pPr algn="l"/>
             <a:r>
-              <a:rPr sz="1500" b="0" i="0" lang="en-US" altLang="en-US">
+              <a:rPr sz="1700" b="0" i="0" lang="en-US" altLang="en-US">
                 <a:solidFill>
                   <a:srgbClr val="24333D"/>
                 </a:solidFill>
@@ -4171,17 +4106,11 @@
             <a:ext cx="3200400" cy="1234440"/>
           </a:xfrm>
           <a:prstGeom prst="roundRect">
-            <a:avLst>
-              <a:gd name="adj" fmla="val 6000"/>
-            </a:avLst>
-          </a:prstGeom>
-          <a:solidFill>
-            <a:srgbClr val="FFFFFF"/>
-          </a:solidFill>
+            <a:avLst/>
+          </a:prstGeom>
+          <a:noFill/>
           <a:ln>
-            <a:solidFill>
-              <a:srgbClr val="D7DEE3"/>
-            </a:solidFill>
+            <a:noFill/>
           </a:ln>
         </p:spPr>
         <p:style>
@@ -4267,7 +4196,7 @@
           <a:p>
             <a:pPr algn="l"/>
             <a:r>
-              <a:rPr sz="1500" b="0" i="0" lang="en-US" altLang="en-US">
+              <a:rPr sz="1700" b="0" i="0" lang="en-US" altLang="en-US">
                 <a:solidFill>
                   <a:srgbClr val="24333D"/>
                 </a:solidFill>
@@ -4492,17 +4421,11 @@
             <a:ext cx="2828422" cy="2240280"/>
           </a:xfrm>
           <a:prstGeom prst="roundRect">
-            <a:avLst>
-              <a:gd name="adj" fmla="val 6000"/>
-            </a:avLst>
-          </a:prstGeom>
-          <a:solidFill>
-            <a:srgbClr val="FFFFFF"/>
-          </a:solidFill>
+            <a:avLst/>
+          </a:prstGeom>
+          <a:noFill/>
           <a:ln>
-            <a:solidFill>
-              <a:srgbClr val="D7DEE3"/>
-            </a:solidFill>
+            <a:noFill/>
           </a:ln>
         </p:spPr>
         <p:style>
@@ -4553,54 +4476,7 @@
       </p:pic>
       <p:sp>
         <p:nvSpPr>
-          <p:cNvPr id="8" name="Rounded Rectangle 7"/>
-          <p:cNvSpPr/>
-          <p:nvPr/>
-        </p:nvSpPr>
-        <p:spPr>
-          <a:xfrm>
-            <a:off x="4832731" y="3703320"/>
-            <a:ext cx="2828422" cy="1289304"/>
-          </a:xfrm>
-          <a:prstGeom prst="roundRect">
-            <a:avLst>
-              <a:gd name="adj" fmla="val 6000"/>
-            </a:avLst>
-          </a:prstGeom>
-          <a:solidFill>
-            <a:srgbClr val="FFFFFF"/>
-          </a:solidFill>
-          <a:ln>
-            <a:solidFill>
-              <a:srgbClr val="D7DEE3"/>
-            </a:solidFill>
-          </a:ln>
-        </p:spPr>
-        <p:style>
-          <a:lnRef idx="1">
-            <a:schemeClr val="accent1"/>
-          </a:lnRef>
-          <a:fillRef idx="3">
-            <a:schemeClr val="accent1"/>
-          </a:fillRef>
-          <a:effectRef idx="2">
-            <a:schemeClr val="accent1"/>
-          </a:effectRef>
-          <a:fontRef idx="minor">
-            <a:schemeClr val="lt1"/>
-          </a:fontRef>
-        </p:style>
-        <p:txBody>
-          <a:bodyPr rtlCol="0" anchor="ctr"/>
-          <a:lstStyle/>
-          <a:p>
-            <a:pPr algn="ctr"/>
-          </a:p>
-        </p:txBody>
-      </p:sp>
-      <p:sp>
-        <p:nvSpPr>
-          <p:cNvPr id="9" name="TextBox 8"/>
+          <p:cNvPr id="8" name="TextBox 7"/>
           <p:cNvSpPr txBox="1"/>
           <p:nvPr/>
         </p:nvSpPr>
@@ -4622,7 +4498,7 @@
           <a:p>
             <a:pPr algn="l"/>
             <a:r>
-              <a:rPr sz="1500" b="1" i="0" lang="en-US" altLang="en-US">
+              <a:rPr sz="1700" b="1" i="0" lang="en-US" altLang="en-US">
                 <a:solidFill>
                   <a:srgbClr val="7A8F54"/>
                 </a:solidFill>
@@ -4637,7 +4513,7 @@
       </p:sp>
       <p:sp>
         <p:nvSpPr>
-          <p:cNvPr id="10" name="Oval 9"/>
+          <p:cNvPr id="9" name="Oval 8"/>
           <p:cNvSpPr/>
           <p:nvPr/>
         </p:nvSpPr>
@@ -4680,7 +4556,7 @@
       </p:sp>
       <p:sp>
         <p:nvSpPr>
-          <p:cNvPr id="11" name="TextBox 10"/>
+          <p:cNvPr id="10" name="TextBox 9"/>
           <p:cNvSpPr txBox="1"/>
           <p:nvPr/>
         </p:nvSpPr>
@@ -4702,7 +4578,7 @@
           <a:p>
             <a:pPr algn="l"/>
             <a:r>
-              <a:rPr sz="1500" b="0" i="0" lang="en-US" altLang="en-US">
+              <a:rPr sz="1700" b="0" i="0" lang="en-US" altLang="en-US">
                 <a:solidFill>
                   <a:srgbClr val="24333D"/>
                 </a:solidFill>
@@ -4717,7 +4593,7 @@
       </p:sp>
       <p:sp>
         <p:nvSpPr>
-          <p:cNvPr id="12" name="Rounded Rectangle 11"/>
+          <p:cNvPr id="11" name="Rounded Rectangle 10"/>
           <p:cNvSpPr/>
           <p:nvPr/>
         </p:nvSpPr>
@@ -4727,17 +4603,11 @@
             <a:ext cx="3889080" cy="685800"/>
           </a:xfrm>
           <a:prstGeom prst="roundRect">
-            <a:avLst>
-              <a:gd name="adj" fmla="val 6000"/>
-            </a:avLst>
-          </a:prstGeom>
-          <a:solidFill>
-            <a:srgbClr val="FFFFFF"/>
-          </a:solidFill>
+            <a:avLst/>
+          </a:prstGeom>
+          <a:noFill/>
           <a:ln>
-            <a:solidFill>
-              <a:srgbClr val="D7DEE3"/>
-            </a:solidFill>
+            <a:noFill/>
           </a:ln>
         </p:spPr>
         <p:style>
@@ -4764,7 +4634,7 @@
       </p:sp>
       <p:sp>
         <p:nvSpPr>
-          <p:cNvPr id="13" name="Rectangle 12"/>
+          <p:cNvPr id="12" name="Rectangle 11"/>
           <p:cNvSpPr/>
           <p:nvPr/>
         </p:nvSpPr>
@@ -4807,7 +4677,7 @@
       </p:sp>
       <p:sp>
         <p:nvSpPr>
-          <p:cNvPr id="14" name="TextBox 13"/>
+          <p:cNvPr id="13" name="TextBox 12"/>
           <p:cNvSpPr txBox="1"/>
           <p:nvPr/>
         </p:nvSpPr>
@@ -4829,7 +4699,7 @@
           <a:p>
             <a:pPr algn="l"/>
             <a:r>
-              <a:rPr sz="2200" b="1" i="0" lang="th-TH" altLang="en-US">
+              <a:rPr sz="2600" b="1" i="0" lang="th-TH" altLang="en-US">
                 <a:solidFill>
                   <a:srgbClr val="24333D"/>
                 </a:solidFill>
@@ -4840,7 +4710,7 @@
               <a:t>ศูนย์</a:t>
             </a:r>
             <a:r>
-              <a:rPr sz="1500" b="0" i="1" lang="en-US" altLang="en-US">
+              <a:rPr sz="1700" b="0" i="1" lang="en-US" altLang="en-US">
                 <a:solidFill>
                   <a:srgbClr val="566873"/>
                 </a:solidFill>
@@ -4855,7 +4725,7 @@
       </p:sp>
       <p:sp>
         <p:nvSpPr>
-          <p:cNvPr id="15" name="TextBox 14"/>
+          <p:cNvPr id="14" name="TextBox 13"/>
           <p:cNvSpPr txBox="1"/>
           <p:nvPr/>
         </p:nvSpPr>
@@ -4892,7 +4762,7 @@
       </p:sp>
       <p:sp>
         <p:nvSpPr>
-          <p:cNvPr id="16" name="Rounded Rectangle 15"/>
+          <p:cNvPr id="15" name="Rounded Rectangle 14"/>
           <p:cNvSpPr/>
           <p:nvPr/>
         </p:nvSpPr>
@@ -4902,17 +4772,11 @@
             <a:ext cx="3889080" cy="685800"/>
           </a:xfrm>
           <a:prstGeom prst="roundRect">
-            <a:avLst>
-              <a:gd name="adj" fmla="val 6000"/>
-            </a:avLst>
-          </a:prstGeom>
-          <a:solidFill>
-            <a:srgbClr val="FFFFFF"/>
-          </a:solidFill>
+            <a:avLst/>
+          </a:prstGeom>
+          <a:noFill/>
           <a:ln>
-            <a:solidFill>
-              <a:srgbClr val="D7DEE3"/>
-            </a:solidFill>
+            <a:noFill/>
           </a:ln>
         </p:spPr>
         <p:style>
@@ -4939,7 +4803,7 @@
       </p:sp>
       <p:sp>
         <p:nvSpPr>
-          <p:cNvPr id="17" name="Rectangle 16"/>
+          <p:cNvPr id="16" name="Rectangle 15"/>
           <p:cNvSpPr/>
           <p:nvPr/>
         </p:nvSpPr>
@@ -4982,7 +4846,7 @@
       </p:sp>
       <p:sp>
         <p:nvSpPr>
-          <p:cNvPr id="18" name="TextBox 17"/>
+          <p:cNvPr id="17" name="TextBox 16"/>
           <p:cNvSpPr txBox="1"/>
           <p:nvPr/>
         </p:nvSpPr>
@@ -5004,7 +4868,7 @@
           <a:p>
             <a:pPr algn="l"/>
             <a:r>
-              <a:rPr sz="2200" b="1" i="0" lang="th-TH" altLang="en-US">
+              <a:rPr sz="2600" b="1" i="0" lang="th-TH" altLang="en-US">
                 <a:solidFill>
                   <a:srgbClr val="24333D"/>
                 </a:solidFill>
@@ -5015,7 +4879,7 @@
               <a:t>หนึ่ง</a:t>
             </a:r>
             <a:r>
-              <a:rPr sz="1500" b="0" i="1" lang="en-US" altLang="en-US">
+              <a:rPr sz="1700" b="0" i="1" lang="en-US" altLang="en-US">
                 <a:solidFill>
                   <a:srgbClr val="566873"/>
                 </a:solidFill>
@@ -5030,7 +4894,7 @@
       </p:sp>
       <p:sp>
         <p:nvSpPr>
-          <p:cNvPr id="19" name="TextBox 18"/>
+          <p:cNvPr id="18" name="TextBox 17"/>
           <p:cNvSpPr txBox="1"/>
           <p:nvPr/>
         </p:nvSpPr>
@@ -5067,7 +4931,7 @@
       </p:sp>
       <p:sp>
         <p:nvSpPr>
-          <p:cNvPr id="20" name="Rounded Rectangle 19"/>
+          <p:cNvPr id="19" name="Rounded Rectangle 18"/>
           <p:cNvSpPr/>
           <p:nvPr/>
         </p:nvSpPr>
@@ -5077,17 +4941,11 @@
             <a:ext cx="3889080" cy="685800"/>
           </a:xfrm>
           <a:prstGeom prst="roundRect">
-            <a:avLst>
-              <a:gd name="adj" fmla="val 6000"/>
-            </a:avLst>
-          </a:prstGeom>
-          <a:solidFill>
-            <a:srgbClr val="FFFFFF"/>
-          </a:solidFill>
+            <a:avLst/>
+          </a:prstGeom>
+          <a:noFill/>
           <a:ln>
-            <a:solidFill>
-              <a:srgbClr val="D7DEE3"/>
-            </a:solidFill>
+            <a:noFill/>
           </a:ln>
         </p:spPr>
         <p:style>
@@ -5114,7 +4972,7 @@
       </p:sp>
       <p:sp>
         <p:nvSpPr>
-          <p:cNvPr id="21" name="Rectangle 20"/>
+          <p:cNvPr id="20" name="Rectangle 19"/>
           <p:cNvSpPr/>
           <p:nvPr/>
         </p:nvSpPr>
@@ -5157,7 +5015,7 @@
       </p:sp>
       <p:sp>
         <p:nvSpPr>
-          <p:cNvPr id="22" name="TextBox 21"/>
+          <p:cNvPr id="21" name="TextBox 20"/>
           <p:cNvSpPr txBox="1"/>
           <p:nvPr/>
         </p:nvSpPr>
@@ -5179,7 +5037,7 @@
           <a:p>
             <a:pPr algn="l"/>
             <a:r>
-              <a:rPr sz="2200" b="1" i="0" lang="th-TH" altLang="en-US">
+              <a:rPr sz="2600" b="1" i="0" lang="th-TH" altLang="en-US">
                 <a:solidFill>
                   <a:srgbClr val="24333D"/>
                 </a:solidFill>
@@ -5190,7 +5048,7 @@
               <a:t>สอง</a:t>
             </a:r>
             <a:r>
-              <a:rPr sz="1500" b="0" i="1" lang="en-US" altLang="en-US">
+              <a:rPr sz="1700" b="0" i="1" lang="en-US" altLang="en-US">
                 <a:solidFill>
                   <a:srgbClr val="566873"/>
                 </a:solidFill>
@@ -5205,7 +5063,7 @@
       </p:sp>
       <p:sp>
         <p:nvSpPr>
-          <p:cNvPr id="23" name="TextBox 22"/>
+          <p:cNvPr id="22" name="TextBox 21"/>
           <p:cNvSpPr txBox="1"/>
           <p:nvPr/>
         </p:nvSpPr>
@@ -5242,7 +5100,7 @@
       </p:sp>
       <p:sp>
         <p:nvSpPr>
-          <p:cNvPr id="24" name="Rounded Rectangle 23"/>
+          <p:cNvPr id="23" name="Rounded Rectangle 22"/>
           <p:cNvSpPr/>
           <p:nvPr/>
         </p:nvSpPr>
@@ -5252,17 +5110,11 @@
             <a:ext cx="3889080" cy="685800"/>
           </a:xfrm>
           <a:prstGeom prst="roundRect">
-            <a:avLst>
-              <a:gd name="adj" fmla="val 6000"/>
-            </a:avLst>
-          </a:prstGeom>
-          <a:solidFill>
-            <a:srgbClr val="FFFFFF"/>
-          </a:solidFill>
+            <a:avLst/>
+          </a:prstGeom>
+          <a:noFill/>
           <a:ln>
-            <a:solidFill>
-              <a:srgbClr val="D7DEE3"/>
-            </a:solidFill>
+            <a:noFill/>
           </a:ln>
         </p:spPr>
         <p:style>
@@ -5289,7 +5141,7 @@
       </p:sp>
       <p:sp>
         <p:nvSpPr>
-          <p:cNvPr id="25" name="Rectangle 24"/>
+          <p:cNvPr id="24" name="Rectangle 23"/>
           <p:cNvSpPr/>
           <p:nvPr/>
         </p:nvSpPr>
@@ -5332,7 +5184,7 @@
       </p:sp>
       <p:sp>
         <p:nvSpPr>
-          <p:cNvPr id="26" name="TextBox 25"/>
+          <p:cNvPr id="25" name="TextBox 24"/>
           <p:cNvSpPr txBox="1"/>
           <p:nvPr/>
         </p:nvSpPr>
@@ -5354,7 +5206,7 @@
           <a:p>
             <a:pPr algn="l"/>
             <a:r>
-              <a:rPr sz="2200" b="1" i="0" lang="th-TH" altLang="en-US">
+              <a:rPr sz="2600" b="1" i="0" lang="th-TH" altLang="en-US">
                 <a:solidFill>
                   <a:srgbClr val="24333D"/>
                 </a:solidFill>
@@ -5365,7 +5217,7 @@
               <a:t>สาม</a:t>
             </a:r>
             <a:r>
-              <a:rPr sz="1500" b="0" i="1" lang="en-US" altLang="en-US">
+              <a:rPr sz="1700" b="0" i="1" lang="en-US" altLang="en-US">
                 <a:solidFill>
                   <a:srgbClr val="566873"/>
                 </a:solidFill>
@@ -5380,7 +5232,7 @@
       </p:sp>
       <p:sp>
         <p:nvSpPr>
-          <p:cNvPr id="27" name="TextBox 26"/>
+          <p:cNvPr id="26" name="TextBox 25"/>
           <p:cNvSpPr txBox="1"/>
           <p:nvPr/>
         </p:nvSpPr>
@@ -5417,7 +5269,7 @@
       </p:sp>
       <p:sp>
         <p:nvSpPr>
-          <p:cNvPr id="28" name="Rounded Rectangle 27"/>
+          <p:cNvPr id="27" name="Rounded Rectangle 26"/>
           <p:cNvSpPr/>
           <p:nvPr/>
         </p:nvSpPr>
@@ -5427,17 +5279,11 @@
             <a:ext cx="3889080" cy="685800"/>
           </a:xfrm>
           <a:prstGeom prst="roundRect">
-            <a:avLst>
-              <a:gd name="adj" fmla="val 6000"/>
-            </a:avLst>
-          </a:prstGeom>
-          <a:solidFill>
-            <a:srgbClr val="FFFFFF"/>
-          </a:solidFill>
+            <a:avLst/>
+          </a:prstGeom>
+          <a:noFill/>
           <a:ln>
-            <a:solidFill>
-              <a:srgbClr val="D7DEE3"/>
-            </a:solidFill>
+            <a:noFill/>
           </a:ln>
         </p:spPr>
         <p:style>
@@ -5464,7 +5310,7 @@
       </p:sp>
       <p:sp>
         <p:nvSpPr>
-          <p:cNvPr id="29" name="Rectangle 28"/>
+          <p:cNvPr id="28" name="Rectangle 27"/>
           <p:cNvSpPr/>
           <p:nvPr/>
         </p:nvSpPr>
@@ -5507,7 +5353,7 @@
       </p:sp>
       <p:sp>
         <p:nvSpPr>
-          <p:cNvPr id="30" name="TextBox 29"/>
+          <p:cNvPr id="29" name="TextBox 28"/>
           <p:cNvSpPr txBox="1"/>
           <p:nvPr/>
         </p:nvSpPr>
@@ -5529,7 +5375,7 @@
           <a:p>
             <a:pPr algn="l"/>
             <a:r>
-              <a:rPr sz="2200" b="1" i="0" lang="th-TH" altLang="en-US">
+              <a:rPr sz="2600" b="1" i="0" lang="th-TH" altLang="en-US">
                 <a:solidFill>
                   <a:srgbClr val="24333D"/>
                 </a:solidFill>
@@ -5540,7 +5386,7 @@
               <a:t>สี่</a:t>
             </a:r>
             <a:r>
-              <a:rPr sz="1500" b="0" i="1" lang="en-US" altLang="en-US">
+              <a:rPr sz="1700" b="0" i="1" lang="en-US" altLang="en-US">
                 <a:solidFill>
                   <a:srgbClr val="566873"/>
                 </a:solidFill>
@@ -5555,7 +5401,7 @@
       </p:sp>
       <p:sp>
         <p:nvSpPr>
-          <p:cNvPr id="31" name="TextBox 30"/>
+          <p:cNvPr id="30" name="TextBox 29"/>
           <p:cNvSpPr txBox="1"/>
           <p:nvPr/>
         </p:nvSpPr>
@@ -5592,7 +5438,7 @@
       </p:sp>
       <p:sp>
         <p:nvSpPr>
-          <p:cNvPr id="32" name="Rounded Rectangle 31"/>
+          <p:cNvPr id="31" name="Rounded Rectangle 30"/>
           <p:cNvSpPr/>
           <p:nvPr/>
         </p:nvSpPr>
@@ -5602,17 +5448,11 @@
             <a:ext cx="3889080" cy="685800"/>
           </a:xfrm>
           <a:prstGeom prst="roundRect">
-            <a:avLst>
-              <a:gd name="adj" fmla="val 6000"/>
-            </a:avLst>
-          </a:prstGeom>
-          <a:solidFill>
-            <a:srgbClr val="FFFFFF"/>
-          </a:solidFill>
+            <a:avLst/>
+          </a:prstGeom>
+          <a:noFill/>
           <a:ln>
-            <a:solidFill>
-              <a:srgbClr val="D7DEE3"/>
-            </a:solidFill>
+            <a:noFill/>
           </a:ln>
         </p:spPr>
         <p:style>
@@ -5639,7 +5479,7 @@
       </p:sp>
       <p:sp>
         <p:nvSpPr>
-          <p:cNvPr id="33" name="Rectangle 32"/>
+          <p:cNvPr id="32" name="Rectangle 31"/>
           <p:cNvSpPr/>
           <p:nvPr/>
         </p:nvSpPr>
@@ -5682,7 +5522,7 @@
       </p:sp>
       <p:sp>
         <p:nvSpPr>
-          <p:cNvPr id="34" name="TextBox 33"/>
+          <p:cNvPr id="33" name="TextBox 32"/>
           <p:cNvSpPr txBox="1"/>
           <p:nvPr/>
         </p:nvSpPr>
@@ -5704,7 +5544,7 @@
           <a:p>
             <a:pPr algn="l"/>
             <a:r>
-              <a:rPr sz="2200" b="1" i="0" lang="th-TH" altLang="en-US">
+              <a:rPr sz="2600" b="1" i="0" lang="th-TH" altLang="en-US">
                 <a:solidFill>
                   <a:srgbClr val="24333D"/>
                 </a:solidFill>
@@ -5715,7 +5555,7 @@
               <a:t>ห้า</a:t>
             </a:r>
             <a:r>
-              <a:rPr sz="1500" b="0" i="1" lang="en-US" altLang="en-US">
+              <a:rPr sz="1700" b="0" i="1" lang="en-US" altLang="en-US">
                 <a:solidFill>
                   <a:srgbClr val="566873"/>
                 </a:solidFill>
@@ -5730,7 +5570,7 @@
       </p:sp>
       <p:sp>
         <p:nvSpPr>
-          <p:cNvPr id="35" name="TextBox 34"/>
+          <p:cNvPr id="34" name="TextBox 33"/>
           <p:cNvSpPr txBox="1"/>
           <p:nvPr/>
         </p:nvSpPr>
@@ -5767,54 +5607,7 @@
       </p:sp>
       <p:sp>
         <p:nvSpPr>
-          <p:cNvPr id="36" name="Rounded Rectangle 35"/>
-          <p:cNvSpPr/>
-          <p:nvPr/>
-        </p:nvSpPr>
-        <p:spPr>
-          <a:xfrm>
-            <a:off x="731520" y="6336792"/>
-            <a:ext cx="10058400" cy="1636776"/>
-          </a:xfrm>
-          <a:prstGeom prst="roundRect">
-            <a:avLst>
-              <a:gd name="adj" fmla="val 6000"/>
-            </a:avLst>
-          </a:prstGeom>
-          <a:solidFill>
-            <a:srgbClr val="FFFFFF"/>
-          </a:solidFill>
-          <a:ln>
-            <a:solidFill>
-              <a:srgbClr val="D7DEE3"/>
-            </a:solidFill>
-          </a:ln>
-        </p:spPr>
-        <p:style>
-          <a:lnRef idx="1">
-            <a:schemeClr val="accent1"/>
-          </a:lnRef>
-          <a:fillRef idx="3">
-            <a:schemeClr val="accent1"/>
-          </a:fillRef>
-          <a:effectRef idx="2">
-            <a:schemeClr val="accent1"/>
-          </a:effectRef>
-          <a:fontRef idx="minor">
-            <a:schemeClr val="lt1"/>
-          </a:fontRef>
-        </p:style>
-        <p:txBody>
-          <a:bodyPr rtlCol="0" anchor="ctr"/>
-          <a:lstStyle/>
-          <a:p>
-            <a:pPr algn="ctr"/>
-          </a:p>
-        </p:txBody>
-      </p:sp>
-      <p:sp>
-        <p:nvSpPr>
-          <p:cNvPr id="37" name="TextBox 36"/>
+          <p:cNvPr id="35" name="TextBox 34"/>
           <p:cNvSpPr txBox="1"/>
           <p:nvPr/>
         </p:nvSpPr>
@@ -5836,7 +5629,7 @@
           <a:p>
             <a:pPr algn="l"/>
             <a:r>
-              <a:rPr sz="1500" b="1" i="0" lang="en-US" altLang="en-US">
+              <a:rPr sz="1700" b="1" i="0" lang="en-US" altLang="en-US">
                 <a:solidFill>
                   <a:srgbClr val="C96F4A"/>
                 </a:solidFill>
@@ -5851,7 +5644,7 @@
       </p:sp>
       <p:sp>
         <p:nvSpPr>
-          <p:cNvPr id="38" name="Oval 37"/>
+          <p:cNvPr id="36" name="Oval 35"/>
           <p:cNvSpPr/>
           <p:nvPr/>
         </p:nvSpPr>
@@ -5894,7 +5687,7 @@
       </p:sp>
       <p:sp>
         <p:nvSpPr>
-          <p:cNvPr id="39" name="TextBox 38"/>
+          <p:cNvPr id="37" name="TextBox 36"/>
           <p:cNvSpPr txBox="1"/>
           <p:nvPr/>
         </p:nvSpPr>
@@ -5916,7 +5709,7 @@
           <a:p>
             <a:pPr algn="l"/>
             <a:r>
-              <a:rPr sz="1500" b="0" i="0" lang="en-US" altLang="en-US">
+              <a:rPr sz="1700" b="0" i="0" lang="en-US" altLang="en-US">
                 <a:solidFill>
                   <a:srgbClr val="24333D"/>
                 </a:solidFill>
@@ -5927,7 +5720,7 @@
               <a:t>Listen and repeat: </a:t>
             </a:r>
             <a:r>
-              <a:rPr sz="1500" b="0" i="0" lang="th-TH" altLang="en-US">
+              <a:rPr sz="1700" b="0" i="0" lang="th-TH" altLang="en-US">
                 <a:solidFill>
                   <a:srgbClr val="24333D"/>
                 </a:solidFill>
@@ -5938,7 +5731,7 @@
               <a:t>ศูนย์</a:t>
             </a:r>
             <a:r>
-              <a:rPr sz="1500" b="0" i="1" lang="en-US" altLang="en-US">
+              <a:rPr sz="1700" b="0" i="1" lang="en-US" altLang="en-US">
                 <a:solidFill>
                   <a:srgbClr val="566873"/>
                 </a:solidFill>
@@ -5949,7 +5742,7 @@
               <a:t> (sǔun)</a:t>
             </a:r>
             <a:r>
-              <a:rPr sz="1500" b="0" i="0" lang="en-US" altLang="en-US">
+              <a:rPr sz="1700" b="0" i="0" lang="en-US" altLang="en-US">
                 <a:solidFill>
                   <a:srgbClr val="24333D"/>
                 </a:solidFill>
@@ -5960,7 +5753,7 @@
               <a:t>, </a:t>
             </a:r>
             <a:r>
-              <a:rPr sz="1500" b="0" i="0" lang="th-TH" altLang="en-US">
+              <a:rPr sz="1700" b="0" i="0" lang="th-TH" altLang="en-US">
                 <a:solidFill>
                   <a:srgbClr val="24333D"/>
                 </a:solidFill>
@@ -5971,7 +5764,7 @@
               <a:t>หนึ่ง</a:t>
             </a:r>
             <a:r>
-              <a:rPr sz="1500" b="0" i="1" lang="en-US" altLang="en-US">
+              <a:rPr sz="1700" b="0" i="1" lang="en-US" altLang="en-US">
                 <a:solidFill>
                   <a:srgbClr val="566873"/>
                 </a:solidFill>
@@ -5982,7 +5775,7 @@
               <a:t> (nùeng)</a:t>
             </a:r>
             <a:r>
-              <a:rPr sz="1500" b="0" i="0" lang="en-US" altLang="en-US">
+              <a:rPr sz="1700" b="0" i="0" lang="en-US" altLang="en-US">
                 <a:solidFill>
                   <a:srgbClr val="24333D"/>
                 </a:solidFill>
@@ -5993,7 +5786,7 @@
               <a:t>, </a:t>
             </a:r>
             <a:r>
-              <a:rPr sz="1500" b="0" i="0" lang="th-TH" altLang="en-US">
+              <a:rPr sz="1700" b="0" i="0" lang="th-TH" altLang="en-US">
                 <a:solidFill>
                   <a:srgbClr val="24333D"/>
                 </a:solidFill>
@@ -6004,7 +5797,7 @@
               <a:t>สอง</a:t>
             </a:r>
             <a:r>
-              <a:rPr sz="1500" b="0" i="1" lang="en-US" altLang="en-US">
+              <a:rPr sz="1700" b="0" i="1" lang="en-US" altLang="en-US">
                 <a:solidFill>
                   <a:srgbClr val="566873"/>
                 </a:solidFill>
@@ -6015,7 +5808,7 @@
               <a:t> (sǎawng)</a:t>
             </a:r>
             <a:r>
-              <a:rPr sz="1500" b="0" i="0" lang="en-US" altLang="en-US">
+              <a:rPr sz="1700" b="0" i="0" lang="en-US" altLang="en-US">
                 <a:solidFill>
                   <a:srgbClr val="24333D"/>
                 </a:solidFill>
@@ -6026,7 +5819,7 @@
               <a:t>, </a:t>
             </a:r>
             <a:r>
-              <a:rPr sz="1500" b="0" i="0" lang="th-TH" altLang="en-US">
+              <a:rPr sz="1700" b="0" i="0" lang="th-TH" altLang="en-US">
                 <a:solidFill>
                   <a:srgbClr val="24333D"/>
                 </a:solidFill>
@@ -6037,7 +5830,7 @@
               <a:t>สาม</a:t>
             </a:r>
             <a:r>
-              <a:rPr sz="1500" b="0" i="1" lang="en-US" altLang="en-US">
+              <a:rPr sz="1700" b="0" i="1" lang="en-US" altLang="en-US">
                 <a:solidFill>
                   <a:srgbClr val="566873"/>
                 </a:solidFill>
@@ -6048,7 +5841,7 @@
               <a:t> (sǎam)</a:t>
             </a:r>
             <a:r>
-              <a:rPr sz="1500" b="0" i="0" lang="en-US" altLang="en-US">
+              <a:rPr sz="1700" b="0" i="0" lang="en-US" altLang="en-US">
                 <a:solidFill>
                   <a:srgbClr val="24333D"/>
                 </a:solidFill>
@@ -6059,7 +5852,7 @@
               <a:t>, </a:t>
             </a:r>
             <a:r>
-              <a:rPr sz="1500" b="0" i="0" lang="th-TH" altLang="en-US">
+              <a:rPr sz="1700" b="0" i="0" lang="th-TH" altLang="en-US">
                 <a:solidFill>
                   <a:srgbClr val="24333D"/>
                 </a:solidFill>
@@ -6070,7 +5863,7 @@
               <a:t>สี่</a:t>
             </a:r>
             <a:r>
-              <a:rPr sz="1500" b="0" i="1" lang="en-US" altLang="en-US">
+              <a:rPr sz="1700" b="0" i="1" lang="en-US" altLang="en-US">
                 <a:solidFill>
                   <a:srgbClr val="566873"/>
                 </a:solidFill>
@@ -6081,7 +5874,7 @@
               <a:t> (sìi)</a:t>
             </a:r>
             <a:r>
-              <a:rPr sz="1500" b="0" i="0" lang="en-US" altLang="en-US">
+              <a:rPr sz="1700" b="0" i="0" lang="en-US" altLang="en-US">
                 <a:solidFill>
                   <a:srgbClr val="24333D"/>
                 </a:solidFill>
@@ -6092,7 +5885,7 @@
               <a:t>, </a:t>
             </a:r>
             <a:r>
-              <a:rPr sz="1500" b="0" i="0" lang="th-TH" altLang="en-US">
+              <a:rPr sz="1700" b="0" i="0" lang="th-TH" altLang="en-US">
                 <a:solidFill>
                   <a:srgbClr val="24333D"/>
                 </a:solidFill>
@@ -6103,7 +5896,7 @@
               <a:t>ห้า</a:t>
             </a:r>
             <a:r>
-              <a:rPr sz="1500" b="0" i="1" lang="en-US" altLang="en-US">
+              <a:rPr sz="1700" b="0" i="1" lang="en-US" altLang="en-US">
                 <a:solidFill>
                   <a:srgbClr val="566873"/>
                 </a:solidFill>
@@ -6114,7 +5907,7 @@
               <a:t> (hâa)</a:t>
             </a:r>
             <a:r>
-              <a:rPr sz="1500" b="0" i="0" lang="en-US" altLang="en-US">
+              <a:rPr sz="1700" b="0" i="0" lang="en-US" altLang="en-US">
                 <a:solidFill>
                   <a:srgbClr val="24333D"/>
                 </a:solidFill>
@@ -6123,364 +5916,6 @@
                 <a:cs typeface="Sarabun"/>
               </a:rPr>
               <a:t>. Now backwards.</a:t>
-            </a:r>
-          </a:p>
-        </p:txBody>
-      </p:sp>
-      <p:sp>
-        <p:nvSpPr>
-          <p:cNvPr id="40" name="Oval 39"/>
-          <p:cNvSpPr/>
-          <p:nvPr/>
-        </p:nvSpPr>
-        <p:spPr>
-          <a:xfrm>
-            <a:off x="932688" y="7178040"/>
-            <a:ext cx="82296" cy="82296"/>
-          </a:xfrm>
-          <a:prstGeom prst="ellipse">
-            <a:avLst/>
-          </a:prstGeom>
-          <a:solidFill>
-            <a:srgbClr val="C96F4A"/>
-          </a:solidFill>
-          <a:ln>
-            <a:noFill/>
-          </a:ln>
-        </p:spPr>
-        <p:style>
-          <a:lnRef idx="1">
-            <a:schemeClr val="accent1"/>
-          </a:lnRef>
-          <a:fillRef idx="3">
-            <a:schemeClr val="accent1"/>
-          </a:fillRef>
-          <a:effectRef idx="2">
-            <a:schemeClr val="accent1"/>
-          </a:effectRef>
-          <a:fontRef idx="minor">
-            <a:schemeClr val="lt1"/>
-          </a:fontRef>
-        </p:style>
-        <p:txBody>
-          <a:bodyPr rtlCol="0" anchor="ctr"/>
-          <a:lstStyle/>
-          <a:p>
-            <a:pPr algn="ctr"/>
-          </a:p>
-        </p:txBody>
-      </p:sp>
-      <p:sp>
-        <p:nvSpPr>
-          <p:cNvPr id="41" name="TextBox 40"/>
-          <p:cNvSpPr txBox="1"/>
-          <p:nvPr/>
-        </p:nvSpPr>
-        <p:spPr>
-          <a:xfrm>
-            <a:off x="1078992" y="7086600"/>
-            <a:ext cx="9555480" cy="274320"/>
-          </a:xfrm>
-          <a:prstGeom prst="rect">
-            <a:avLst/>
-          </a:prstGeom>
-          <a:noFill/>
-        </p:spPr>
-        <p:txBody>
-          <a:bodyPr wrap="square" anchor="t">
-            <a:spAutoFit/>
-          </a:bodyPr>
-          <a:lstStyle/>
-          <a:p>
-            <a:pPr algn="l"/>
-            <a:r>
-              <a:rPr sz="1500" b="0" i="0" lang="en-US" altLang="en-US">
-                <a:solidFill>
-                  <a:srgbClr val="24333D"/>
-                </a:solidFill>
-                <a:latin typeface="Sarabun"/>
-                <a:ea typeface="Sarabun"/>
-                <a:cs typeface="Sarabun"/>
-              </a:rPr>
-              <a:t>Pause-and-produce: I say a number in English. Say the Thai before I show it. Two. Four. Zero. Five.</a:t>
-            </a:r>
-          </a:p>
-        </p:txBody>
-      </p:sp>
-      <p:sp>
-        <p:nvSpPr>
-          <p:cNvPr id="42" name="Oval 41"/>
-          <p:cNvSpPr/>
-          <p:nvPr/>
-        </p:nvSpPr>
-        <p:spPr>
-          <a:xfrm>
-            <a:off x="932688" y="7488936"/>
-            <a:ext cx="82296" cy="82296"/>
-          </a:xfrm>
-          <a:prstGeom prst="ellipse">
-            <a:avLst/>
-          </a:prstGeom>
-          <a:solidFill>
-            <a:srgbClr val="C96F4A"/>
-          </a:solidFill>
-          <a:ln>
-            <a:noFill/>
-          </a:ln>
-        </p:spPr>
-        <p:style>
-          <a:lnRef idx="1">
-            <a:schemeClr val="accent1"/>
-          </a:lnRef>
-          <a:fillRef idx="3">
-            <a:schemeClr val="accent1"/>
-          </a:fillRef>
-          <a:effectRef idx="2">
-            <a:schemeClr val="accent1"/>
-          </a:effectRef>
-          <a:fontRef idx="minor">
-            <a:schemeClr val="lt1"/>
-          </a:fontRef>
-        </p:style>
-        <p:txBody>
-          <a:bodyPr rtlCol="0" anchor="ctr"/>
-          <a:lstStyle/>
-          <a:p>
-            <a:pPr algn="ctr"/>
-          </a:p>
-        </p:txBody>
-      </p:sp>
-      <p:sp>
-        <p:nvSpPr>
-          <p:cNvPr id="43" name="TextBox 42"/>
-          <p:cNvSpPr txBox="1"/>
-          <p:nvPr/>
-        </p:nvSpPr>
-        <p:spPr>
-          <a:xfrm>
-            <a:off x="1078992" y="7397496"/>
-            <a:ext cx="9555480" cy="274320"/>
-          </a:xfrm>
-          <a:prstGeom prst="rect">
-            <a:avLst/>
-          </a:prstGeom>
-          <a:noFill/>
-        </p:spPr>
-        <p:txBody>
-          <a:bodyPr wrap="square" anchor="t">
-            <a:spAutoFit/>
-          </a:bodyPr>
-          <a:lstStyle/>
-          <a:p>
-            <a:pPr algn="l"/>
-            <a:r>
-              <a:rPr sz="1500" b="0" i="0" lang="en-US" altLang="en-US">
-                <a:solidFill>
-                  <a:srgbClr val="24333D"/>
-                </a:solidFill>
-                <a:latin typeface="Sarabun"/>
-                <a:ea typeface="Sarabun"/>
-                <a:cs typeface="Sarabun"/>
-              </a:rPr>
-              <a:t>Room number drill: room 301? </a:t>
-            </a:r>
-            <a:r>
-              <a:rPr sz="1500" b="0" i="0" lang="th-TH" altLang="en-US">
-                <a:solidFill>
-                  <a:srgbClr val="24333D"/>
-                </a:solidFill>
-                <a:latin typeface="Sarabun"/>
-                <a:ea typeface="Sarabun"/>
-                <a:cs typeface="Sarabun"/>
-              </a:rPr>
-              <a:t>สาม</a:t>
-            </a:r>
-            <a:r>
-              <a:rPr sz="1500" b="0" i="1" lang="en-US" altLang="en-US">
-                <a:solidFill>
-                  <a:srgbClr val="566873"/>
-                </a:solidFill>
-                <a:latin typeface="Sarabun"/>
-                <a:ea typeface="Sarabun"/>
-                <a:cs typeface="Sarabun"/>
-              </a:rPr>
-              <a:t> (sǎam)</a:t>
-            </a:r>
-            <a:r>
-              <a:rPr sz="1500" b="0" i="0" lang="en-US" altLang="en-US">
-                <a:solidFill>
-                  <a:srgbClr val="24333D"/>
-                </a:solidFill>
-                <a:latin typeface="Sarabun"/>
-                <a:ea typeface="Sarabun"/>
-                <a:cs typeface="Sarabun"/>
-              </a:rPr>
-              <a:t>-</a:t>
-            </a:r>
-            <a:r>
-              <a:rPr sz="1500" b="0" i="0" lang="th-TH" altLang="en-US">
-                <a:solidFill>
-                  <a:srgbClr val="24333D"/>
-                </a:solidFill>
-                <a:latin typeface="Sarabun"/>
-                <a:ea typeface="Sarabun"/>
-                <a:cs typeface="Sarabun"/>
-              </a:rPr>
-              <a:t>ศูนย์</a:t>
-            </a:r>
-            <a:r>
-              <a:rPr sz="1500" b="0" i="1" lang="en-US" altLang="en-US">
-                <a:solidFill>
-                  <a:srgbClr val="566873"/>
-                </a:solidFill>
-                <a:latin typeface="Sarabun"/>
-                <a:ea typeface="Sarabun"/>
-                <a:cs typeface="Sarabun"/>
-              </a:rPr>
-              <a:t> (sǔun)</a:t>
-            </a:r>
-            <a:r>
-              <a:rPr sz="1500" b="0" i="0" lang="en-US" altLang="en-US">
-                <a:solidFill>
-                  <a:srgbClr val="24333D"/>
-                </a:solidFill>
-                <a:latin typeface="Sarabun"/>
-                <a:ea typeface="Sarabun"/>
-                <a:cs typeface="Sarabun"/>
-              </a:rPr>
-              <a:t>-</a:t>
-            </a:r>
-            <a:r>
-              <a:rPr sz="1500" b="0" i="0" lang="th-TH" altLang="en-US">
-                <a:solidFill>
-                  <a:srgbClr val="24333D"/>
-                </a:solidFill>
-                <a:latin typeface="Sarabun"/>
-                <a:ea typeface="Sarabun"/>
-                <a:cs typeface="Sarabun"/>
-              </a:rPr>
-              <a:t>หนึ่ง</a:t>
-            </a:r>
-            <a:r>
-              <a:rPr sz="1500" b="0" i="1" lang="en-US" altLang="en-US">
-                <a:solidFill>
-                  <a:srgbClr val="566873"/>
-                </a:solidFill>
-                <a:latin typeface="Sarabun"/>
-                <a:ea typeface="Sarabun"/>
-                <a:cs typeface="Sarabun"/>
-              </a:rPr>
-              <a:t> (nùeng)</a:t>
-            </a:r>
-            <a:r>
-              <a:rPr sz="1500" b="0" i="0" lang="en-US" altLang="en-US">
-                <a:solidFill>
-                  <a:srgbClr val="24333D"/>
-                </a:solidFill>
-                <a:latin typeface="Sarabun"/>
-                <a:ea typeface="Sarabun"/>
-                <a:cs typeface="Sarabun"/>
-              </a:rPr>
-              <a:t>. Room 205? </a:t>
-            </a:r>
-            <a:r>
-              <a:rPr sz="1500" b="0" i="0" lang="th-TH" altLang="en-US">
-                <a:solidFill>
-                  <a:srgbClr val="24333D"/>
-                </a:solidFill>
-                <a:latin typeface="Sarabun"/>
-                <a:ea typeface="Sarabun"/>
-                <a:cs typeface="Sarabun"/>
-              </a:rPr>
-              <a:t>สอง</a:t>
-            </a:r>
-            <a:r>
-              <a:rPr sz="1500" b="0" i="1" lang="en-US" altLang="en-US">
-                <a:solidFill>
-                  <a:srgbClr val="566873"/>
-                </a:solidFill>
-                <a:latin typeface="Sarabun"/>
-                <a:ea typeface="Sarabun"/>
-                <a:cs typeface="Sarabun"/>
-              </a:rPr>
-              <a:t> (sǎawng)</a:t>
-            </a:r>
-            <a:r>
-              <a:rPr sz="1500" b="0" i="0" lang="en-US" altLang="en-US">
-                <a:solidFill>
-                  <a:srgbClr val="24333D"/>
-                </a:solidFill>
-                <a:latin typeface="Sarabun"/>
-                <a:ea typeface="Sarabun"/>
-                <a:cs typeface="Sarabun"/>
-              </a:rPr>
-              <a:t>-</a:t>
-            </a:r>
-            <a:r>
-              <a:rPr sz="1500" b="0" i="0" lang="th-TH" altLang="en-US">
-                <a:solidFill>
-                  <a:srgbClr val="24333D"/>
-                </a:solidFill>
-                <a:latin typeface="Sarabun"/>
-                <a:ea typeface="Sarabun"/>
-                <a:cs typeface="Sarabun"/>
-              </a:rPr>
-              <a:t>ศูนย์</a:t>
-            </a:r>
-            <a:r>
-              <a:rPr sz="1500" b="0" i="1" lang="en-US" altLang="en-US">
-                <a:solidFill>
-                  <a:srgbClr val="566873"/>
-                </a:solidFill>
-                <a:latin typeface="Sarabun"/>
-                <a:ea typeface="Sarabun"/>
-                <a:cs typeface="Sarabun"/>
-              </a:rPr>
-              <a:t> (sǔun)</a:t>
-            </a:r>
-            <a:r>
-              <a:rPr sz="1500" b="0" i="0" lang="en-US" altLang="en-US">
-                <a:solidFill>
-                  <a:srgbClr val="24333D"/>
-                </a:solidFill>
-                <a:latin typeface="Sarabun"/>
-                <a:ea typeface="Sarabun"/>
-                <a:cs typeface="Sarabun"/>
-              </a:rPr>
-              <a:t>-</a:t>
-            </a:r>
-            <a:r>
-              <a:rPr sz="1500" b="0" i="0" lang="th-TH" altLang="en-US">
-                <a:solidFill>
-                  <a:srgbClr val="24333D"/>
-                </a:solidFill>
-                <a:latin typeface="Sarabun"/>
-                <a:ea typeface="Sarabun"/>
-                <a:cs typeface="Sarabun"/>
-              </a:rPr>
-              <a:t>ห้า</a:t>
-            </a:r>
-            <a:r>
-              <a:rPr sz="1500" b="0" i="1" lang="en-US" altLang="en-US">
-                <a:solidFill>
-                  <a:srgbClr val="566873"/>
-                </a:solidFill>
-                <a:latin typeface="Sarabun"/>
-                <a:ea typeface="Sarabun"/>
-                <a:cs typeface="Sarabun"/>
-              </a:rPr>
-              <a:t> (hâa)</a:t>
-            </a:r>
-            <a:r>
-              <a:rPr sz="1500" b="0" i="0" lang="en-US" altLang="en-US">
-                <a:solidFill>
-                  <a:srgbClr val="24333D"/>
-                </a:solidFill>
-                <a:latin typeface="Sarabun"/>
-                <a:ea typeface="Sarabun"/>
-                <a:cs typeface="Sarabun"/>
-              </a:rPr>
-              <a:t>. Your turn.</a:t>
             </a:r>
           </a:p>
         </p:txBody>
@@ -6697,17 +6132,11 @@
             <a:ext cx="3889080" cy="685800"/>
           </a:xfrm>
           <a:prstGeom prst="roundRect">
-            <a:avLst>
-              <a:gd name="adj" fmla="val 6000"/>
-            </a:avLst>
-          </a:prstGeom>
-          <a:solidFill>
-            <a:srgbClr val="FFFFFF"/>
-          </a:solidFill>
+            <a:avLst/>
+          </a:prstGeom>
+          <a:noFill/>
           <a:ln>
-            <a:solidFill>
-              <a:srgbClr val="D7DEE3"/>
-            </a:solidFill>
+            <a:noFill/>
           </a:ln>
         </p:spPr>
         <p:style>
@@ -6799,7 +6228,7 @@
           <a:p>
             <a:pPr algn="l"/>
             <a:r>
-              <a:rPr sz="2200" b="1" i="0" lang="th-TH" altLang="en-US">
+              <a:rPr sz="2600" b="1" i="0" lang="th-TH" altLang="en-US">
                 <a:solidFill>
                   <a:srgbClr val="24333D"/>
                 </a:solidFill>
@@ -6810,7 +6239,7 @@
               <a:t>หก</a:t>
             </a:r>
             <a:r>
-              <a:rPr sz="1500" b="0" i="1" lang="en-US" altLang="en-US">
+              <a:rPr sz="1700" b="0" i="1" lang="en-US" altLang="en-US">
                 <a:solidFill>
                   <a:srgbClr val="566873"/>
                 </a:solidFill>
@@ -6872,17 +6301,11 @@
             <a:ext cx="3889080" cy="685800"/>
           </a:xfrm>
           <a:prstGeom prst="roundRect">
-            <a:avLst>
-              <a:gd name="adj" fmla="val 6000"/>
-            </a:avLst>
-          </a:prstGeom>
-          <a:solidFill>
-            <a:srgbClr val="FFFFFF"/>
-          </a:solidFill>
+            <a:avLst/>
+          </a:prstGeom>
+          <a:noFill/>
           <a:ln>
-            <a:solidFill>
-              <a:srgbClr val="D7DEE3"/>
-            </a:solidFill>
+            <a:noFill/>
           </a:ln>
         </p:spPr>
         <p:style>
@@ -6974,7 +6397,7 @@
           <a:p>
             <a:pPr algn="l"/>
             <a:r>
-              <a:rPr sz="2200" b="1" i="0" lang="th-TH" altLang="en-US">
+              <a:rPr sz="2600" b="1" i="0" lang="th-TH" altLang="en-US">
                 <a:solidFill>
                   <a:srgbClr val="24333D"/>
                 </a:solidFill>
@@ -6985,7 +6408,7 @@
               <a:t>เจ็ด</a:t>
             </a:r>
             <a:r>
-              <a:rPr sz="1500" b="0" i="1" lang="en-US" altLang="en-US">
+              <a:rPr sz="1700" b="0" i="1" lang="en-US" altLang="en-US">
                 <a:solidFill>
                   <a:srgbClr val="566873"/>
                 </a:solidFill>
@@ -7047,17 +6470,11 @@
             <a:ext cx="3889080" cy="685800"/>
           </a:xfrm>
           <a:prstGeom prst="roundRect">
-            <a:avLst>
-              <a:gd name="adj" fmla="val 6000"/>
-            </a:avLst>
-          </a:prstGeom>
-          <a:solidFill>
-            <a:srgbClr val="FFFFFF"/>
-          </a:solidFill>
+            <a:avLst/>
+          </a:prstGeom>
+          <a:noFill/>
           <a:ln>
-            <a:solidFill>
-              <a:srgbClr val="D7DEE3"/>
-            </a:solidFill>
+            <a:noFill/>
           </a:ln>
         </p:spPr>
         <p:style>
@@ -7149,7 +6566,7 @@
           <a:p>
             <a:pPr algn="l"/>
             <a:r>
-              <a:rPr sz="2200" b="1" i="0" lang="th-TH" altLang="en-US">
+              <a:rPr sz="2600" b="1" i="0" lang="th-TH" altLang="en-US">
                 <a:solidFill>
                   <a:srgbClr val="24333D"/>
                 </a:solidFill>
@@ -7160,7 +6577,7 @@
               <a:t>แปด</a:t>
             </a:r>
             <a:r>
-              <a:rPr sz="1500" b="0" i="1" lang="en-US" altLang="en-US">
+              <a:rPr sz="1700" b="0" i="1" lang="en-US" altLang="en-US">
                 <a:solidFill>
                   <a:srgbClr val="566873"/>
                 </a:solidFill>
@@ -7222,17 +6639,11 @@
             <a:ext cx="3889080" cy="685800"/>
           </a:xfrm>
           <a:prstGeom prst="roundRect">
-            <a:avLst>
-              <a:gd name="adj" fmla="val 6000"/>
-            </a:avLst>
-          </a:prstGeom>
-          <a:solidFill>
-            <a:srgbClr val="FFFFFF"/>
-          </a:solidFill>
+            <a:avLst/>
+          </a:prstGeom>
+          <a:noFill/>
           <a:ln>
-            <a:solidFill>
-              <a:srgbClr val="D7DEE3"/>
-            </a:solidFill>
+            <a:noFill/>
           </a:ln>
         </p:spPr>
         <p:style>
@@ -7324,7 +6735,7 @@
           <a:p>
             <a:pPr algn="l"/>
             <a:r>
-              <a:rPr sz="2200" b="1" i="0" lang="th-TH" altLang="en-US">
+              <a:rPr sz="2600" b="1" i="0" lang="th-TH" altLang="en-US">
                 <a:solidFill>
                   <a:srgbClr val="24333D"/>
                 </a:solidFill>
@@ -7335,7 +6746,7 @@
               <a:t>เก้า</a:t>
             </a:r>
             <a:r>
-              <a:rPr sz="1500" b="0" i="1" lang="en-US" altLang="en-US">
+              <a:rPr sz="1700" b="0" i="1" lang="en-US" altLang="en-US">
                 <a:solidFill>
                   <a:srgbClr val="566873"/>
                 </a:solidFill>
@@ -7397,17 +6808,11 @@
             <a:ext cx="3889080" cy="685800"/>
           </a:xfrm>
           <a:prstGeom prst="roundRect">
-            <a:avLst>
-              <a:gd name="adj" fmla="val 6000"/>
-            </a:avLst>
-          </a:prstGeom>
-          <a:solidFill>
-            <a:srgbClr val="FFFFFF"/>
-          </a:solidFill>
+            <a:avLst/>
+          </a:prstGeom>
+          <a:noFill/>
           <a:ln>
-            <a:solidFill>
-              <a:srgbClr val="D7DEE3"/>
-            </a:solidFill>
+            <a:noFill/>
           </a:ln>
         </p:spPr>
         <p:style>
@@ -7499,7 +6904,7 @@
           <a:p>
             <a:pPr algn="l"/>
             <a:r>
-              <a:rPr sz="2200" b="1" i="0" lang="th-TH" altLang="en-US">
+              <a:rPr sz="2600" b="1" i="0" lang="th-TH" altLang="en-US">
                 <a:solidFill>
                   <a:srgbClr val="24333D"/>
                 </a:solidFill>
@@ -7510,7 +6915,7 @@
               <a:t>สิบ</a:t>
             </a:r>
             <a:r>
-              <a:rPr sz="1500" b="0" i="1" lang="en-US" altLang="en-US">
+              <a:rPr sz="1700" b="0" i="1" lang="en-US" altLang="en-US">
                 <a:solidFill>
                   <a:srgbClr val="566873"/>
                 </a:solidFill>
@@ -7562,54 +6967,7 @@
       </p:sp>
       <p:sp>
         <p:nvSpPr>
-          <p:cNvPr id="26" name="Rounded Rectangle 25"/>
-          <p:cNvSpPr/>
-          <p:nvPr/>
-        </p:nvSpPr>
-        <p:spPr>
-          <a:xfrm>
-            <a:off x="731520" y="5532120"/>
-            <a:ext cx="10058400" cy="1636776"/>
-          </a:xfrm>
-          <a:prstGeom prst="roundRect">
-            <a:avLst>
-              <a:gd name="adj" fmla="val 6000"/>
-            </a:avLst>
-          </a:prstGeom>
-          <a:solidFill>
-            <a:srgbClr val="FFFFFF"/>
-          </a:solidFill>
-          <a:ln>
-            <a:solidFill>
-              <a:srgbClr val="D7DEE3"/>
-            </a:solidFill>
-          </a:ln>
-        </p:spPr>
-        <p:style>
-          <a:lnRef idx="1">
-            <a:schemeClr val="accent1"/>
-          </a:lnRef>
-          <a:fillRef idx="3">
-            <a:schemeClr val="accent1"/>
-          </a:fillRef>
-          <a:effectRef idx="2">
-            <a:schemeClr val="accent1"/>
-          </a:effectRef>
-          <a:fontRef idx="minor">
-            <a:schemeClr val="lt1"/>
-          </a:fontRef>
-        </p:style>
-        <p:txBody>
-          <a:bodyPr rtlCol="0" anchor="ctr"/>
-          <a:lstStyle/>
-          <a:p>
-            <a:pPr algn="ctr"/>
-          </a:p>
-        </p:txBody>
-      </p:sp>
-      <p:sp>
-        <p:nvSpPr>
-          <p:cNvPr id="27" name="TextBox 26"/>
+          <p:cNvPr id="26" name="TextBox 25"/>
           <p:cNvSpPr txBox="1"/>
           <p:nvPr/>
         </p:nvSpPr>
@@ -7631,7 +6989,7 @@
           <a:p>
             <a:pPr algn="l"/>
             <a:r>
-              <a:rPr sz="1500" b="1" i="0" lang="en-US" altLang="en-US">
+              <a:rPr sz="1700" b="1" i="0" lang="en-US" altLang="en-US">
                 <a:solidFill>
                   <a:srgbClr val="C96F4A"/>
                 </a:solidFill>
@@ -7646,7 +7004,7 @@
       </p:sp>
       <p:sp>
         <p:nvSpPr>
-          <p:cNvPr id="28" name="Oval 27"/>
+          <p:cNvPr id="27" name="Oval 26"/>
           <p:cNvSpPr/>
           <p:nvPr/>
         </p:nvSpPr>
@@ -7689,7 +7047,7 @@
       </p:sp>
       <p:sp>
         <p:nvSpPr>
-          <p:cNvPr id="29" name="TextBox 28"/>
+          <p:cNvPr id="28" name="TextBox 27"/>
           <p:cNvSpPr txBox="1"/>
           <p:nvPr/>
         </p:nvSpPr>
@@ -7711,7 +7069,7 @@
           <a:p>
             <a:pPr algn="l"/>
             <a:r>
-              <a:rPr sz="1500" b="0" i="0" lang="en-US" altLang="en-US">
+              <a:rPr sz="1700" b="0" i="0" lang="en-US" altLang="en-US">
                 <a:solidFill>
                   <a:srgbClr val="24333D"/>
                 </a:solidFill>
@@ -7722,7 +7080,7 @@
               <a:t>Listen and repeat: </a:t>
             </a:r>
             <a:r>
-              <a:rPr sz="1500" b="0" i="0" lang="th-TH" altLang="en-US">
+              <a:rPr sz="1700" b="0" i="0" lang="th-TH" altLang="en-US">
                 <a:solidFill>
                   <a:srgbClr val="24333D"/>
                 </a:solidFill>
@@ -7733,7 +7091,7 @@
               <a:t>หก</a:t>
             </a:r>
             <a:r>
-              <a:rPr sz="1500" b="0" i="1" lang="en-US" altLang="en-US">
+              <a:rPr sz="1700" b="0" i="1" lang="en-US" altLang="en-US">
                 <a:solidFill>
                   <a:srgbClr val="566873"/>
                 </a:solidFill>
@@ -7744,7 +7102,7 @@
               <a:t> (hòk)</a:t>
             </a:r>
             <a:r>
-              <a:rPr sz="1500" b="0" i="0" lang="en-US" altLang="en-US">
+              <a:rPr sz="1700" b="0" i="0" lang="en-US" altLang="en-US">
                 <a:solidFill>
                   <a:srgbClr val="24333D"/>
                 </a:solidFill>
@@ -7755,7 +7113,7 @@
               <a:t>, </a:t>
             </a:r>
             <a:r>
-              <a:rPr sz="1500" b="0" i="0" lang="th-TH" altLang="en-US">
+              <a:rPr sz="1700" b="0" i="0" lang="th-TH" altLang="en-US">
                 <a:solidFill>
                   <a:srgbClr val="24333D"/>
                 </a:solidFill>
@@ -7766,7 +7124,7 @@
               <a:t>เจ็ด</a:t>
             </a:r>
             <a:r>
-              <a:rPr sz="1500" b="0" i="1" lang="en-US" altLang="en-US">
+              <a:rPr sz="1700" b="0" i="1" lang="en-US" altLang="en-US">
                 <a:solidFill>
                   <a:srgbClr val="566873"/>
                 </a:solidFill>
@@ -7777,7 +7135,7 @@
               <a:t> (jèt)</a:t>
             </a:r>
             <a:r>
-              <a:rPr sz="1500" b="0" i="0" lang="en-US" altLang="en-US">
+              <a:rPr sz="1700" b="0" i="0" lang="en-US" altLang="en-US">
                 <a:solidFill>
                   <a:srgbClr val="24333D"/>
                 </a:solidFill>
@@ -7788,7 +7146,7 @@
               <a:t>, </a:t>
             </a:r>
             <a:r>
-              <a:rPr sz="1500" b="0" i="0" lang="th-TH" altLang="en-US">
+              <a:rPr sz="1700" b="0" i="0" lang="th-TH" altLang="en-US">
                 <a:solidFill>
                   <a:srgbClr val="24333D"/>
                 </a:solidFill>
@@ -7799,7 +7157,7 @@
               <a:t>แปด</a:t>
             </a:r>
             <a:r>
-              <a:rPr sz="1500" b="0" i="1" lang="en-US" altLang="en-US">
+              <a:rPr sz="1700" b="0" i="1" lang="en-US" altLang="en-US">
                 <a:solidFill>
                   <a:srgbClr val="566873"/>
                 </a:solidFill>
@@ -7810,7 +7168,7 @@
               <a:t> (bpàet)</a:t>
             </a:r>
             <a:r>
-              <a:rPr sz="1500" b="0" i="0" lang="en-US" altLang="en-US">
+              <a:rPr sz="1700" b="0" i="0" lang="en-US" altLang="en-US">
                 <a:solidFill>
                   <a:srgbClr val="24333D"/>
                 </a:solidFill>
@@ -7821,7 +7179,7 @@
               <a:t>, </a:t>
             </a:r>
             <a:r>
-              <a:rPr sz="1500" b="0" i="0" lang="th-TH" altLang="en-US">
+              <a:rPr sz="1700" b="0" i="0" lang="th-TH" altLang="en-US">
                 <a:solidFill>
                   <a:srgbClr val="24333D"/>
                 </a:solidFill>
@@ -7832,7 +7190,7 @@
               <a:t>เก้า</a:t>
             </a:r>
             <a:r>
-              <a:rPr sz="1500" b="0" i="1" lang="en-US" altLang="en-US">
+              <a:rPr sz="1700" b="0" i="1" lang="en-US" altLang="en-US">
                 <a:solidFill>
                   <a:srgbClr val="566873"/>
                 </a:solidFill>
@@ -7843,7 +7201,7 @@
               <a:t> (gâo)</a:t>
             </a:r>
             <a:r>
-              <a:rPr sz="1500" b="0" i="0" lang="en-US" altLang="en-US">
+              <a:rPr sz="1700" b="0" i="0" lang="en-US" altLang="en-US">
                 <a:solidFill>
                   <a:srgbClr val="24333D"/>
                 </a:solidFill>
@@ -7854,7 +7212,7 @@
               <a:t>, </a:t>
             </a:r>
             <a:r>
-              <a:rPr sz="1500" b="0" i="0" lang="th-TH" altLang="en-US">
+              <a:rPr sz="1700" b="0" i="0" lang="th-TH" altLang="en-US">
                 <a:solidFill>
                   <a:srgbClr val="24333D"/>
                 </a:solidFill>
@@ -7865,7 +7223,7 @@
               <a:t>สิบ</a:t>
             </a:r>
             <a:r>
-              <a:rPr sz="1500" b="0" i="1" lang="en-US" altLang="en-US">
+              <a:rPr sz="1700" b="0" i="1" lang="en-US" altLang="en-US">
                 <a:solidFill>
                   <a:srgbClr val="566873"/>
                 </a:solidFill>
@@ -7876,7 +7234,7 @@
               <a:t> (sìp)</a:t>
             </a:r>
             <a:r>
-              <a:rPr sz="1500" b="0" i="0" lang="en-US" altLang="en-US">
+              <a:rPr sz="1700" b="0" i="0" lang="en-US" altLang="en-US">
                 <a:solidFill>
                   <a:srgbClr val="24333D"/>
                 </a:solidFill>
@@ -7885,430 +7243,6 @@
                 <a:cs typeface="Sarabun"/>
               </a:rPr>
               <a:t>. Now count 0 to 10 from memory.</a:t>
-            </a:r>
-          </a:p>
-        </p:txBody>
-      </p:sp>
-      <p:sp>
-        <p:nvSpPr>
-          <p:cNvPr id="30" name="Oval 29"/>
-          <p:cNvSpPr/>
-          <p:nvPr/>
-        </p:nvSpPr>
-        <p:spPr>
-          <a:xfrm>
-            <a:off x="932688" y="6373368"/>
-            <a:ext cx="82296" cy="82296"/>
-          </a:xfrm>
-          <a:prstGeom prst="ellipse">
-            <a:avLst/>
-          </a:prstGeom>
-          <a:solidFill>
-            <a:srgbClr val="C96F4A"/>
-          </a:solidFill>
-          <a:ln>
-            <a:noFill/>
-          </a:ln>
-        </p:spPr>
-        <p:style>
-          <a:lnRef idx="1">
-            <a:schemeClr val="accent1"/>
-          </a:lnRef>
-          <a:fillRef idx="3">
-            <a:schemeClr val="accent1"/>
-          </a:fillRef>
-          <a:effectRef idx="2">
-            <a:schemeClr val="accent1"/>
-          </a:effectRef>
-          <a:fontRef idx="minor">
-            <a:schemeClr val="lt1"/>
-          </a:fontRef>
-        </p:style>
-        <p:txBody>
-          <a:bodyPr rtlCol="0" anchor="ctr"/>
-          <a:lstStyle/>
-          <a:p>
-            <a:pPr algn="ctr"/>
-          </a:p>
-        </p:txBody>
-      </p:sp>
-      <p:sp>
-        <p:nvSpPr>
-          <p:cNvPr id="31" name="TextBox 30"/>
-          <p:cNvSpPr txBox="1"/>
-          <p:nvPr/>
-        </p:nvSpPr>
-        <p:spPr>
-          <a:xfrm>
-            <a:off x="1078992" y="6281928"/>
-            <a:ext cx="9555480" cy="274320"/>
-          </a:xfrm>
-          <a:prstGeom prst="rect">
-            <a:avLst/>
-          </a:prstGeom>
-          <a:noFill/>
-        </p:spPr>
-        <p:txBody>
-          <a:bodyPr wrap="square" anchor="t">
-            <a:spAutoFit/>
-          </a:bodyPr>
-          <a:lstStyle/>
-          <a:p>
-            <a:pPr algn="l"/>
-            <a:r>
-              <a:rPr sz="1500" b="0" i="0" lang="en-US" altLang="en-US">
-                <a:solidFill>
-                  <a:srgbClr val="24333D"/>
-                </a:solidFill>
-                <a:latin typeface="Sarabun"/>
-                <a:ea typeface="Sarabun"/>
-                <a:cs typeface="Sarabun"/>
-              </a:rPr>
-              <a:t>Pause-and-produce: Seven? </a:t>
-            </a:r>
-            <a:r>
-              <a:rPr sz="1500" b="0" i="0" lang="th-TH" altLang="en-US">
-                <a:solidFill>
-                  <a:srgbClr val="24333D"/>
-                </a:solidFill>
-                <a:latin typeface="Sarabun"/>
-                <a:ea typeface="Sarabun"/>
-                <a:cs typeface="Sarabun"/>
-              </a:rPr>
-              <a:t>เจ็ด</a:t>
-            </a:r>
-            <a:r>
-              <a:rPr sz="1500" b="0" i="1" lang="en-US" altLang="en-US">
-                <a:solidFill>
-                  <a:srgbClr val="566873"/>
-                </a:solidFill>
-                <a:latin typeface="Sarabun"/>
-                <a:ea typeface="Sarabun"/>
-                <a:cs typeface="Sarabun"/>
-              </a:rPr>
-              <a:t> (jèt)</a:t>
-            </a:r>
-            <a:r>
-              <a:rPr sz="1500" b="0" i="0" lang="en-US" altLang="en-US">
-                <a:solidFill>
-                  <a:srgbClr val="24333D"/>
-                </a:solidFill>
-                <a:latin typeface="Sarabun"/>
-                <a:ea typeface="Sarabun"/>
-                <a:cs typeface="Sarabun"/>
-              </a:rPr>
-              <a:t>. Ten? </a:t>
-            </a:r>
-            <a:r>
-              <a:rPr sz="1500" b="0" i="0" lang="th-TH" altLang="en-US">
-                <a:solidFill>
-                  <a:srgbClr val="24333D"/>
-                </a:solidFill>
-                <a:latin typeface="Sarabun"/>
-                <a:ea typeface="Sarabun"/>
-                <a:cs typeface="Sarabun"/>
-              </a:rPr>
-              <a:t>สิบ</a:t>
-            </a:r>
-            <a:r>
-              <a:rPr sz="1500" b="0" i="1" lang="en-US" altLang="en-US">
-                <a:solidFill>
-                  <a:srgbClr val="566873"/>
-                </a:solidFill>
-                <a:latin typeface="Sarabun"/>
-                <a:ea typeface="Sarabun"/>
-                <a:cs typeface="Sarabun"/>
-              </a:rPr>
-              <a:t> (sìp)</a:t>
-            </a:r>
-            <a:r>
-              <a:rPr sz="1500" b="0" i="0" lang="en-US" altLang="en-US">
-                <a:solidFill>
-                  <a:srgbClr val="24333D"/>
-                </a:solidFill>
-                <a:latin typeface="Sarabun"/>
-                <a:ea typeface="Sarabun"/>
-                <a:cs typeface="Sarabun"/>
-              </a:rPr>
-              <a:t>. Eight? </a:t>
-            </a:r>
-            <a:r>
-              <a:rPr sz="1500" b="0" i="0" lang="th-TH" altLang="en-US">
-                <a:solidFill>
-                  <a:srgbClr val="24333D"/>
-                </a:solidFill>
-                <a:latin typeface="Sarabun"/>
-                <a:ea typeface="Sarabun"/>
-                <a:cs typeface="Sarabun"/>
-              </a:rPr>
-              <a:t>แปด</a:t>
-            </a:r>
-            <a:r>
-              <a:rPr sz="1500" b="0" i="1" lang="en-US" altLang="en-US">
-                <a:solidFill>
-                  <a:srgbClr val="566873"/>
-                </a:solidFill>
-                <a:latin typeface="Sarabun"/>
-                <a:ea typeface="Sarabun"/>
-                <a:cs typeface="Sarabun"/>
-              </a:rPr>
-              <a:t> (bpàet)</a:t>
-            </a:r>
-            <a:r>
-              <a:rPr sz="1500" b="0" i="0" lang="en-US" altLang="en-US">
-                <a:solidFill>
-                  <a:srgbClr val="24333D"/>
-                </a:solidFill>
-                <a:latin typeface="Sarabun"/>
-                <a:ea typeface="Sarabun"/>
-                <a:cs typeface="Sarabun"/>
-              </a:rPr>
-              <a:t>. Six? </a:t>
-            </a:r>
-            <a:r>
-              <a:rPr sz="1500" b="0" i="0" lang="th-TH" altLang="en-US">
-                <a:solidFill>
-                  <a:srgbClr val="24333D"/>
-                </a:solidFill>
-                <a:latin typeface="Sarabun"/>
-                <a:ea typeface="Sarabun"/>
-                <a:cs typeface="Sarabun"/>
-              </a:rPr>
-              <a:t>หก</a:t>
-            </a:r>
-            <a:r>
-              <a:rPr sz="1500" b="0" i="1" lang="en-US" altLang="en-US">
-                <a:solidFill>
-                  <a:srgbClr val="566873"/>
-                </a:solidFill>
-                <a:latin typeface="Sarabun"/>
-                <a:ea typeface="Sarabun"/>
-                <a:cs typeface="Sarabun"/>
-              </a:rPr>
-              <a:t> (hòk)</a:t>
-            </a:r>
-            <a:r>
-              <a:rPr sz="1500" b="0" i="0" lang="en-US" altLang="en-US">
-                <a:solidFill>
-                  <a:srgbClr val="24333D"/>
-                </a:solidFill>
-                <a:latin typeface="Sarabun"/>
-                <a:ea typeface="Sarabun"/>
-                <a:cs typeface="Sarabun"/>
-              </a:rPr>
-              <a:t>. Nine? </a:t>
-            </a:r>
-            <a:r>
-              <a:rPr sz="1500" b="0" i="0" lang="th-TH" altLang="en-US">
-                <a:solidFill>
-                  <a:srgbClr val="24333D"/>
-                </a:solidFill>
-                <a:latin typeface="Sarabun"/>
-                <a:ea typeface="Sarabun"/>
-                <a:cs typeface="Sarabun"/>
-              </a:rPr>
-              <a:t>เก้า</a:t>
-            </a:r>
-            <a:r>
-              <a:rPr sz="1500" b="0" i="1" lang="en-US" altLang="en-US">
-                <a:solidFill>
-                  <a:srgbClr val="566873"/>
-                </a:solidFill>
-                <a:latin typeface="Sarabun"/>
-                <a:ea typeface="Sarabun"/>
-                <a:cs typeface="Sarabun"/>
-              </a:rPr>
-              <a:t> (gâo)</a:t>
-            </a:r>
-            <a:r>
-              <a:rPr sz="1500" b="0" i="0" lang="en-US" altLang="en-US">
-                <a:solidFill>
-                  <a:srgbClr val="24333D"/>
-                </a:solidFill>
-                <a:latin typeface="Sarabun"/>
-                <a:ea typeface="Sarabun"/>
-                <a:cs typeface="Sarabun"/>
-              </a:rPr>
-              <a:t>.</a:t>
-            </a:r>
-          </a:p>
-        </p:txBody>
-      </p:sp>
-      <p:sp>
-        <p:nvSpPr>
-          <p:cNvPr id="32" name="Oval 31"/>
-          <p:cNvSpPr/>
-          <p:nvPr/>
-        </p:nvSpPr>
-        <p:spPr>
-          <a:xfrm>
-            <a:off x="932688" y="6684264"/>
-            <a:ext cx="82296" cy="82296"/>
-          </a:xfrm>
-          <a:prstGeom prst="ellipse">
-            <a:avLst/>
-          </a:prstGeom>
-          <a:solidFill>
-            <a:srgbClr val="C96F4A"/>
-          </a:solidFill>
-          <a:ln>
-            <a:noFill/>
-          </a:ln>
-        </p:spPr>
-        <p:style>
-          <a:lnRef idx="1">
-            <a:schemeClr val="accent1"/>
-          </a:lnRef>
-          <a:fillRef idx="3">
-            <a:schemeClr val="accent1"/>
-          </a:fillRef>
-          <a:effectRef idx="2">
-            <a:schemeClr val="accent1"/>
-          </a:effectRef>
-          <a:fontRef idx="minor">
-            <a:schemeClr val="lt1"/>
-          </a:fontRef>
-        </p:style>
-        <p:txBody>
-          <a:bodyPr rtlCol="0" anchor="ctr"/>
-          <a:lstStyle/>
-          <a:p>
-            <a:pPr algn="ctr"/>
-          </a:p>
-        </p:txBody>
-      </p:sp>
-      <p:sp>
-        <p:nvSpPr>
-          <p:cNvPr id="33" name="TextBox 32"/>
-          <p:cNvSpPr txBox="1"/>
-          <p:nvPr/>
-        </p:nvSpPr>
-        <p:spPr>
-          <a:xfrm>
-            <a:off x="1078992" y="6592824"/>
-            <a:ext cx="9555480" cy="274320"/>
-          </a:xfrm>
-          <a:prstGeom prst="rect">
-            <a:avLst/>
-          </a:prstGeom>
-          <a:noFill/>
-        </p:spPr>
-        <p:txBody>
-          <a:bodyPr wrap="square" anchor="t">
-            <a:spAutoFit/>
-          </a:bodyPr>
-          <a:lstStyle/>
-          <a:p>
-            <a:pPr algn="l"/>
-            <a:r>
-              <a:rPr sz="1500" b="0" i="0" lang="en-US" altLang="en-US">
-                <a:solidFill>
-                  <a:srgbClr val="24333D"/>
-                </a:solidFill>
-                <a:latin typeface="Sarabun"/>
-                <a:ea typeface="Sarabun"/>
-                <a:cs typeface="Sarabun"/>
-              </a:rPr>
-              <a:t>Substitution: what floor? Floor 9? </a:t>
-            </a:r>
-            <a:r>
-              <a:rPr sz="1500" b="0" i="0" lang="th-TH" altLang="en-US">
-                <a:solidFill>
-                  <a:srgbClr val="24333D"/>
-                </a:solidFill>
-                <a:latin typeface="Sarabun"/>
-                <a:ea typeface="Sarabun"/>
-                <a:cs typeface="Sarabun"/>
-              </a:rPr>
-              <a:t>เก้า</a:t>
-            </a:r>
-            <a:r>
-              <a:rPr sz="1500" b="0" i="1" lang="en-US" altLang="en-US">
-                <a:solidFill>
-                  <a:srgbClr val="566873"/>
-                </a:solidFill>
-                <a:latin typeface="Sarabun"/>
-                <a:ea typeface="Sarabun"/>
-                <a:cs typeface="Sarabun"/>
-              </a:rPr>
-              <a:t> (gâo)</a:t>
-            </a:r>
-            <a:r>
-              <a:rPr sz="1500" b="0" i="0" lang="en-US" altLang="en-US">
-                <a:solidFill>
-                  <a:srgbClr val="24333D"/>
-                </a:solidFill>
-                <a:latin typeface="Sarabun"/>
-                <a:ea typeface="Sarabun"/>
-                <a:cs typeface="Sarabun"/>
-              </a:rPr>
-              <a:t>. Floor 6? </a:t>
-            </a:r>
-            <a:r>
-              <a:rPr sz="1500" b="0" i="0" lang="th-TH" altLang="en-US">
-                <a:solidFill>
-                  <a:srgbClr val="24333D"/>
-                </a:solidFill>
-                <a:latin typeface="Sarabun"/>
-                <a:ea typeface="Sarabun"/>
-                <a:cs typeface="Sarabun"/>
-              </a:rPr>
-              <a:t>หก</a:t>
-            </a:r>
-            <a:r>
-              <a:rPr sz="1500" b="0" i="1" lang="en-US" altLang="en-US">
-                <a:solidFill>
-                  <a:srgbClr val="566873"/>
-                </a:solidFill>
-                <a:latin typeface="Sarabun"/>
-                <a:ea typeface="Sarabun"/>
-                <a:cs typeface="Sarabun"/>
-              </a:rPr>
-              <a:t> (hòk)</a:t>
-            </a:r>
-            <a:r>
-              <a:rPr sz="1500" b="0" i="0" lang="en-US" altLang="en-US">
-                <a:solidFill>
-                  <a:srgbClr val="24333D"/>
-                </a:solidFill>
-                <a:latin typeface="Sarabun"/>
-                <a:ea typeface="Sarabun"/>
-                <a:cs typeface="Sarabun"/>
-              </a:rPr>
-              <a:t>. Floor 10? </a:t>
-            </a:r>
-            <a:r>
-              <a:rPr sz="1500" b="0" i="0" lang="th-TH" altLang="en-US">
-                <a:solidFill>
-                  <a:srgbClr val="24333D"/>
-                </a:solidFill>
-                <a:latin typeface="Sarabun"/>
-                <a:ea typeface="Sarabun"/>
-                <a:cs typeface="Sarabun"/>
-              </a:rPr>
-              <a:t>สิบ</a:t>
-            </a:r>
-            <a:r>
-              <a:rPr sz="1500" b="0" i="1" lang="en-US" altLang="en-US">
-                <a:solidFill>
-                  <a:srgbClr val="566873"/>
-                </a:solidFill>
-                <a:latin typeface="Sarabun"/>
-                <a:ea typeface="Sarabun"/>
-                <a:cs typeface="Sarabun"/>
-              </a:rPr>
-              <a:t> (sìp)</a:t>
-            </a:r>
-            <a:r>
-              <a:rPr sz="1500" b="0" i="0" lang="en-US" altLang="en-US">
-                <a:solidFill>
-                  <a:srgbClr val="24333D"/>
-                </a:solidFill>
-                <a:latin typeface="Sarabun"/>
-                <a:ea typeface="Sarabun"/>
-                <a:cs typeface="Sarabun"/>
-              </a:rPr>
-              <a:t>.</a:t>
             </a:r>
           </a:p>
         </p:txBody>
@@ -8525,17 +7459,11 @@
             <a:ext cx="3889080" cy="1572768"/>
           </a:xfrm>
           <a:prstGeom prst="roundRect">
-            <a:avLst>
-              <a:gd name="adj" fmla="val 6000"/>
-            </a:avLst>
-          </a:prstGeom>
-          <a:solidFill>
-            <a:srgbClr val="FFFFFF"/>
-          </a:solidFill>
+            <a:avLst/>
+          </a:prstGeom>
+          <a:noFill/>
           <a:ln>
-            <a:solidFill>
-              <a:srgbClr val="D7DEE3"/>
-            </a:solidFill>
+            <a:noFill/>
           </a:ln>
         </p:spPr>
         <p:style>
@@ -8627,7 +7555,7 @@
           <a:p>
             <a:pPr algn="l"/>
             <a:r>
-              <a:rPr sz="3200" b="1" i="0" lang="th-TH" altLang="en-US">
+              <a:rPr sz="3600" b="1" i="0" lang="th-TH" altLang="en-US">
                 <a:solidFill>
                   <a:srgbClr val="24333D"/>
                 </a:solidFill>
@@ -8638,7 +7566,7 @@
               <a:t>เบอร์อะไร</a:t>
             </a:r>
             <a:r>
-              <a:rPr sz="1980" b="0" i="1" lang="en-US" altLang="en-US">
+              <a:rPr sz="2230" b="0" i="1" lang="en-US" altLang="en-US">
                 <a:solidFill>
                   <a:srgbClr val="566873"/>
                 </a:solidFill>
@@ -8675,7 +7603,7 @@
           <a:p>
             <a:pPr algn="l"/>
             <a:r>
-              <a:rPr sz="1500" b="0" i="0" lang="en-US" altLang="en-US">
+              <a:rPr sz="1700" b="0" i="0" lang="en-US" altLang="en-US">
                 <a:solidFill>
                   <a:srgbClr val="82909A"/>
                 </a:solidFill>
@@ -8700,17 +7628,11 @@
             <a:ext cx="3889080" cy="1572768"/>
           </a:xfrm>
           <a:prstGeom prst="roundRect">
-            <a:avLst>
-              <a:gd name="adj" fmla="val 6000"/>
-            </a:avLst>
-          </a:prstGeom>
-          <a:solidFill>
-            <a:srgbClr val="FFFFFF"/>
-          </a:solidFill>
+            <a:avLst/>
+          </a:prstGeom>
+          <a:noFill/>
           <a:ln>
-            <a:solidFill>
-              <a:srgbClr val="D7DEE3"/>
-            </a:solidFill>
+            <a:noFill/>
           </a:ln>
         </p:spPr>
         <p:style>
@@ -8802,7 +7724,7 @@
           <a:p>
             <a:pPr algn="l"/>
             <a:r>
-              <a:rPr sz="3200" b="1" i="0" lang="th-TH" altLang="en-US">
+              <a:rPr sz="3600" b="1" i="0" lang="th-TH" altLang="en-US">
                 <a:solidFill>
                   <a:srgbClr val="24333D"/>
                 </a:solidFill>
@@ -8813,7 +7735,7 @@
               <a:t>อายุ...ปี</a:t>
             </a:r>
             <a:r>
-              <a:rPr sz="1980" b="0" i="1" lang="en-US" altLang="en-US">
+              <a:rPr sz="2230" b="0" i="1" lang="en-US" altLang="en-US">
                 <a:solidFill>
                   <a:srgbClr val="566873"/>
                 </a:solidFill>
@@ -8850,7 +7772,7 @@
           <a:p>
             <a:pPr algn="l"/>
             <a:r>
-              <a:rPr sz="1500" b="0" i="0" lang="en-US" altLang="en-US">
+              <a:rPr sz="1700" b="0" i="0" lang="en-US" altLang="en-US">
                 <a:solidFill>
                   <a:srgbClr val="82909A"/>
                 </a:solidFill>
@@ -8875,17 +7797,11 @@
             <a:ext cx="3889080" cy="1572768"/>
           </a:xfrm>
           <a:prstGeom prst="roundRect">
-            <a:avLst>
-              <a:gd name="adj" fmla="val 6000"/>
-            </a:avLst>
-          </a:prstGeom>
-          <a:solidFill>
-            <a:srgbClr val="FFFFFF"/>
-          </a:solidFill>
+            <a:avLst/>
+          </a:prstGeom>
+          <a:noFill/>
           <a:ln>
-            <a:solidFill>
-              <a:srgbClr val="D7DEE3"/>
-            </a:solidFill>
+            <a:noFill/>
           </a:ln>
         </p:spPr>
         <p:style>
@@ -8977,7 +7893,7 @@
           <a:p>
             <a:pPr algn="l"/>
             <a:r>
-              <a:rPr sz="3200" b="1" i="0" lang="th-TH" altLang="en-US">
+              <a:rPr sz="3600" b="1" i="0" lang="th-TH" altLang="en-US">
                 <a:solidFill>
                   <a:srgbClr val="24333D"/>
                 </a:solidFill>
@@ -8988,7 +7904,7 @@
               <a:t>ผมอายุ...ปี</a:t>
             </a:r>
             <a:r>
-              <a:rPr sz="1980" b="0" i="1" lang="en-US" altLang="en-US">
+              <a:rPr sz="2230" b="0" i="1" lang="en-US" altLang="en-US">
                 <a:solidFill>
                   <a:srgbClr val="566873"/>
                 </a:solidFill>
@@ -9025,7 +7941,7 @@
           <a:p>
             <a:pPr algn="l"/>
             <a:r>
-              <a:rPr sz="1500" b="0" i="0" lang="en-US" altLang="en-US">
+              <a:rPr sz="1700" b="0" i="0" lang="en-US" altLang="en-US">
                 <a:solidFill>
                   <a:srgbClr val="82909A"/>
                 </a:solidFill>
@@ -9050,17 +7966,11 @@
             <a:ext cx="3889080" cy="1572768"/>
           </a:xfrm>
           <a:prstGeom prst="roundRect">
-            <a:avLst>
-              <a:gd name="adj" fmla="val 6000"/>
-            </a:avLst>
-          </a:prstGeom>
-          <a:solidFill>
-            <a:srgbClr val="FFFFFF"/>
-          </a:solidFill>
+            <a:avLst/>
+          </a:prstGeom>
+          <a:noFill/>
           <a:ln>
-            <a:solidFill>
-              <a:srgbClr val="D7DEE3"/>
-            </a:solidFill>
+            <a:noFill/>
           </a:ln>
         </p:spPr>
         <p:style>
@@ -9152,7 +8062,7 @@
           <a:p>
             <a:pPr algn="l"/>
             <a:r>
-              <a:rPr sz="3200" b="1" i="0" lang="th-TH" altLang="en-US">
+              <a:rPr sz="3600" b="1" i="0" lang="th-TH" altLang="en-US">
                 <a:solidFill>
                   <a:srgbClr val="24333D"/>
                 </a:solidFill>
@@ -9163,7 +8073,7 @@
               <a:t>ฉันอายุ...ปี</a:t>
             </a:r>
             <a:r>
-              <a:rPr sz="1980" b="0" i="1" lang="en-US" altLang="en-US">
+              <a:rPr sz="2230" b="0" i="1" lang="en-US" altLang="en-US">
                 <a:solidFill>
                   <a:srgbClr val="566873"/>
                 </a:solidFill>
@@ -9200,7 +8110,7 @@
           <a:p>
             <a:pPr algn="l"/>
             <a:r>
-              <a:rPr sz="1500" b="0" i="0" lang="en-US" altLang="en-US">
+              <a:rPr sz="1700" b="0" i="0" lang="en-US" altLang="en-US">
                 <a:solidFill>
                   <a:srgbClr val="82909A"/>
                 </a:solidFill>
@@ -9215,54 +8125,7 @@
       </p:sp>
       <p:sp>
         <p:nvSpPr>
-          <p:cNvPr id="22" name="Rounded Rectangle 21"/>
-          <p:cNvSpPr/>
-          <p:nvPr/>
-        </p:nvSpPr>
-        <p:spPr>
-          <a:xfrm>
-            <a:off x="731520" y="6629400"/>
-            <a:ext cx="10058400" cy="1636776"/>
-          </a:xfrm>
-          <a:prstGeom prst="roundRect">
-            <a:avLst>
-              <a:gd name="adj" fmla="val 6000"/>
-            </a:avLst>
-          </a:prstGeom>
-          <a:solidFill>
-            <a:srgbClr val="FFFFFF"/>
-          </a:solidFill>
-          <a:ln>
-            <a:solidFill>
-              <a:srgbClr val="D7DEE3"/>
-            </a:solidFill>
-          </a:ln>
-        </p:spPr>
-        <p:style>
-          <a:lnRef idx="1">
-            <a:schemeClr val="accent1"/>
-          </a:lnRef>
-          <a:fillRef idx="3">
-            <a:schemeClr val="accent1"/>
-          </a:fillRef>
-          <a:effectRef idx="2">
-            <a:schemeClr val="accent1"/>
-          </a:effectRef>
-          <a:fontRef idx="minor">
-            <a:schemeClr val="lt1"/>
-          </a:fontRef>
-        </p:style>
-        <p:txBody>
-          <a:bodyPr rtlCol="0" anchor="ctr"/>
-          <a:lstStyle/>
-          <a:p>
-            <a:pPr algn="ctr"/>
-          </a:p>
-        </p:txBody>
-      </p:sp>
-      <p:sp>
-        <p:nvSpPr>
-          <p:cNvPr id="23" name="TextBox 22"/>
+          <p:cNvPr id="22" name="TextBox 21"/>
           <p:cNvSpPr txBox="1"/>
           <p:nvPr/>
         </p:nvSpPr>
@@ -9284,7 +8147,7 @@
           <a:p>
             <a:pPr algn="l"/>
             <a:r>
-              <a:rPr sz="1500" b="1" i="0" lang="en-US" altLang="en-US">
+              <a:rPr sz="1700" b="1" i="0" lang="en-US" altLang="en-US">
                 <a:solidFill>
                   <a:srgbClr val="C96F4A"/>
                 </a:solidFill>
@@ -9299,7 +8162,7 @@
       </p:sp>
       <p:sp>
         <p:nvSpPr>
-          <p:cNvPr id="24" name="Oval 23"/>
+          <p:cNvPr id="23" name="Oval 22"/>
           <p:cNvSpPr/>
           <p:nvPr/>
         </p:nvSpPr>
@@ -9342,7 +8205,7 @@
       </p:sp>
       <p:sp>
         <p:nvSpPr>
-          <p:cNvPr id="25" name="TextBox 24"/>
+          <p:cNvPr id="24" name="TextBox 23"/>
           <p:cNvSpPr txBox="1"/>
           <p:nvPr/>
         </p:nvSpPr>
@@ -9364,7 +8227,7 @@
           <a:p>
             <a:pPr algn="l"/>
             <a:r>
-              <a:rPr sz="1500" b="0" i="0" lang="en-US" altLang="en-US">
+              <a:rPr sz="1700" b="0" i="0" lang="en-US" altLang="en-US">
                 <a:solidFill>
                   <a:srgbClr val="24333D"/>
                 </a:solidFill>
@@ -9375,7 +8238,7 @@
               <a:t>Response-building: I ask </a:t>
             </a:r>
             <a:r>
-              <a:rPr sz="1500" b="0" i="0" lang="th-TH" altLang="en-US">
+              <a:rPr sz="1700" b="0" i="0" lang="th-TH" altLang="en-US">
                 <a:solidFill>
                   <a:srgbClr val="24333D"/>
                 </a:solidFill>
@@ -9386,7 +8249,7 @@
               <a:t>เบอร์อะไร</a:t>
             </a:r>
             <a:r>
-              <a:rPr sz="1500" b="0" i="1" lang="en-US" altLang="en-US">
+              <a:rPr sz="1700" b="0" i="1" lang="en-US" altLang="en-US">
                 <a:solidFill>
                   <a:srgbClr val="566873"/>
                 </a:solidFill>
@@ -9397,7 +8260,7 @@
               <a:t> (ber à-rai)</a:t>
             </a:r>
             <a:r>
-              <a:rPr sz="1500" b="0" i="0" lang="en-US" altLang="en-US">
+              <a:rPr sz="1700" b="0" i="0" lang="en-US" altLang="en-US">
                 <a:solidFill>
                   <a:srgbClr val="24333D"/>
                 </a:solidFill>
@@ -9408,7 +8271,7 @@
               <a:t>. Room 409? </a:t>
             </a:r>
             <a:r>
-              <a:rPr sz="1500" b="0" i="0" lang="th-TH" altLang="en-US">
+              <a:rPr sz="1700" b="0" i="0" lang="th-TH" altLang="en-US">
                 <a:solidFill>
                   <a:srgbClr val="24333D"/>
                 </a:solidFill>
@@ -9419,7 +8282,7 @@
               <a:t>สี่</a:t>
             </a:r>
             <a:r>
-              <a:rPr sz="1500" b="0" i="1" lang="en-US" altLang="en-US">
+              <a:rPr sz="1700" b="0" i="1" lang="en-US" altLang="en-US">
                 <a:solidFill>
                   <a:srgbClr val="566873"/>
                 </a:solidFill>
@@ -9430,7 +8293,7 @@
               <a:t> (sìi)</a:t>
             </a:r>
             <a:r>
-              <a:rPr sz="1500" b="0" i="0" lang="en-US" altLang="en-US">
+              <a:rPr sz="1700" b="0" i="0" lang="en-US" altLang="en-US">
                 <a:solidFill>
                   <a:srgbClr val="24333D"/>
                 </a:solidFill>
@@ -9441,7 +8304,7 @@
               <a:t>-</a:t>
             </a:r>
             <a:r>
-              <a:rPr sz="1500" b="0" i="0" lang="th-TH" altLang="en-US">
+              <a:rPr sz="1700" b="0" i="0" lang="th-TH" altLang="en-US">
                 <a:solidFill>
                   <a:srgbClr val="24333D"/>
                 </a:solidFill>
@@ -9452,7 +8315,7 @@
               <a:t>ศูนย์</a:t>
             </a:r>
             <a:r>
-              <a:rPr sz="1500" b="0" i="1" lang="en-US" altLang="en-US">
+              <a:rPr sz="1700" b="0" i="1" lang="en-US" altLang="en-US">
                 <a:solidFill>
                   <a:srgbClr val="566873"/>
                 </a:solidFill>
@@ -9463,7 +8326,7 @@
               <a:t> (sǔun)</a:t>
             </a:r>
             <a:r>
-              <a:rPr sz="1500" b="0" i="0" lang="en-US" altLang="en-US">
+              <a:rPr sz="1700" b="0" i="0" lang="en-US" altLang="en-US">
                 <a:solidFill>
                   <a:srgbClr val="24333D"/>
                 </a:solidFill>
@@ -9474,7 +8337,7 @@
               <a:t>-</a:t>
             </a:r>
             <a:r>
-              <a:rPr sz="1500" b="0" i="0" lang="th-TH" altLang="en-US">
+              <a:rPr sz="1700" b="0" i="0" lang="th-TH" altLang="en-US">
                 <a:solidFill>
                   <a:srgbClr val="24333D"/>
                 </a:solidFill>
@@ -9485,7 +8348,7 @@
               <a:t>เก้า</a:t>
             </a:r>
             <a:r>
-              <a:rPr sz="1500" b="0" i="1" lang="en-US" altLang="en-US">
+              <a:rPr sz="1700" b="0" i="1" lang="en-US" altLang="en-US">
                 <a:solidFill>
                   <a:srgbClr val="566873"/>
                 </a:solidFill>
@@ -9496,7 +8359,7 @@
               <a:t> (gâo)</a:t>
             </a:r>
             <a:r>
-              <a:rPr sz="1500" b="0" i="0" lang="en-US" altLang="en-US">
+              <a:rPr sz="1700" b="0" i="0" lang="en-US" altLang="en-US">
                 <a:solidFill>
                   <a:srgbClr val="24333D"/>
                 </a:solidFill>
@@ -9507,7 +8370,7 @@
               <a:t>. Room 108? </a:t>
             </a:r>
             <a:r>
-              <a:rPr sz="1500" b="0" i="0" lang="th-TH" altLang="en-US">
+              <a:rPr sz="1700" b="0" i="0" lang="th-TH" altLang="en-US">
                 <a:solidFill>
                   <a:srgbClr val="24333D"/>
                 </a:solidFill>
@@ -9518,7 +8381,7 @@
               <a:t>หนึ่ง</a:t>
             </a:r>
             <a:r>
-              <a:rPr sz="1500" b="0" i="1" lang="en-US" altLang="en-US">
+              <a:rPr sz="1700" b="0" i="1" lang="en-US" altLang="en-US">
                 <a:solidFill>
                   <a:srgbClr val="566873"/>
                 </a:solidFill>
@@ -9529,7 +8392,7 @@
               <a:t> (nùeng)</a:t>
             </a:r>
             <a:r>
-              <a:rPr sz="1500" b="0" i="0" lang="en-US" altLang="en-US">
+              <a:rPr sz="1700" b="0" i="0" lang="en-US" altLang="en-US">
                 <a:solidFill>
                   <a:srgbClr val="24333D"/>
                 </a:solidFill>
@@ -9540,7 +8403,7 @@
               <a:t>-</a:t>
             </a:r>
             <a:r>
-              <a:rPr sz="1500" b="0" i="0" lang="th-TH" altLang="en-US">
+              <a:rPr sz="1700" b="0" i="0" lang="th-TH" altLang="en-US">
                 <a:solidFill>
                   <a:srgbClr val="24333D"/>
                 </a:solidFill>
@@ -9551,7 +8414,7 @@
               <a:t>ศูนย์</a:t>
             </a:r>
             <a:r>
-              <a:rPr sz="1500" b="0" i="1" lang="en-US" altLang="en-US">
+              <a:rPr sz="1700" b="0" i="1" lang="en-US" altLang="en-US">
                 <a:solidFill>
                   <a:srgbClr val="566873"/>
                 </a:solidFill>
@@ -9562,7 +8425,7 @@
               <a:t> (sǔun)</a:t>
             </a:r>
             <a:r>
-              <a:rPr sz="1500" b="0" i="0" lang="en-US" altLang="en-US">
+              <a:rPr sz="1700" b="0" i="0" lang="en-US" altLang="en-US">
                 <a:solidFill>
                   <a:srgbClr val="24333D"/>
                 </a:solidFill>
@@ -9573,7 +8436,7 @@
               <a:t>-</a:t>
             </a:r>
             <a:r>
-              <a:rPr sz="1500" b="0" i="0" lang="th-TH" altLang="en-US">
+              <a:rPr sz="1700" b="0" i="0" lang="th-TH" altLang="en-US">
                 <a:solidFill>
                   <a:srgbClr val="24333D"/>
                 </a:solidFill>
@@ -9584,7 +8447,7 @@
               <a:t>แปด</a:t>
             </a:r>
             <a:r>
-              <a:rPr sz="1500" b="0" i="1" lang="en-US" altLang="en-US">
+              <a:rPr sz="1700" b="0" i="1" lang="en-US" altLang="en-US">
                 <a:solidFill>
                   <a:srgbClr val="566873"/>
                 </a:solidFill>
@@ -9595,7 +8458,7 @@
               <a:t> (bpàet)</a:t>
             </a:r>
             <a:r>
-              <a:rPr sz="1500" b="0" i="0" lang="en-US" altLang="en-US">
+              <a:rPr sz="1700" b="0" i="0" lang="en-US" altLang="en-US">
                 <a:solidFill>
                   <a:srgbClr val="24333D"/>
                 </a:solidFill>
@@ -9604,364 +8467,6 @@
                 <a:cs typeface="Sarabun"/>
               </a:rPr>
               <a:t>.</a:t>
-            </a:r>
-          </a:p>
-        </p:txBody>
-      </p:sp>
-      <p:sp>
-        <p:nvSpPr>
-          <p:cNvPr id="26" name="Oval 25"/>
-          <p:cNvSpPr/>
-          <p:nvPr/>
-        </p:nvSpPr>
-        <p:spPr>
-          <a:xfrm>
-            <a:off x="932688" y="7470648"/>
-            <a:ext cx="82296" cy="82296"/>
-          </a:xfrm>
-          <a:prstGeom prst="ellipse">
-            <a:avLst/>
-          </a:prstGeom>
-          <a:solidFill>
-            <a:srgbClr val="C96F4A"/>
-          </a:solidFill>
-          <a:ln>
-            <a:noFill/>
-          </a:ln>
-        </p:spPr>
-        <p:style>
-          <a:lnRef idx="1">
-            <a:schemeClr val="accent1"/>
-          </a:lnRef>
-          <a:fillRef idx="3">
-            <a:schemeClr val="accent1"/>
-          </a:fillRef>
-          <a:effectRef idx="2">
-            <a:schemeClr val="accent1"/>
-          </a:effectRef>
-          <a:fontRef idx="minor">
-            <a:schemeClr val="lt1"/>
-          </a:fontRef>
-        </p:style>
-        <p:txBody>
-          <a:bodyPr rtlCol="0" anchor="ctr"/>
-          <a:lstStyle/>
-          <a:p>
-            <a:pPr algn="ctr"/>
-          </a:p>
-        </p:txBody>
-      </p:sp>
-      <p:sp>
-        <p:nvSpPr>
-          <p:cNvPr id="27" name="TextBox 26"/>
-          <p:cNvSpPr txBox="1"/>
-          <p:nvPr/>
-        </p:nvSpPr>
-        <p:spPr>
-          <a:xfrm>
-            <a:off x="1078992" y="7379208"/>
-            <a:ext cx="9555480" cy="274320"/>
-          </a:xfrm>
-          <a:prstGeom prst="rect">
-            <a:avLst/>
-          </a:prstGeom>
-          <a:noFill/>
-        </p:spPr>
-        <p:txBody>
-          <a:bodyPr wrap="square" anchor="t">
-            <a:spAutoFit/>
-          </a:bodyPr>
-          <a:lstStyle/>
-          <a:p>
-            <a:pPr algn="l"/>
-            <a:r>
-              <a:rPr sz="1500" b="0" i="0" lang="en-US" altLang="en-US">
-                <a:solidFill>
-                  <a:srgbClr val="24333D"/>
-                </a:solidFill>
-                <a:latin typeface="Sarabun"/>
-                <a:ea typeface="Sarabun"/>
-                <a:cs typeface="Sarabun"/>
-              </a:rPr>
-              <a:t>Substitution: build your age sentence. Thirty? </a:t>
-            </a:r>
-            <a:r>
-              <a:rPr sz="1500" b="0" i="0" lang="th-TH" altLang="en-US">
-                <a:solidFill>
-                  <a:srgbClr val="24333D"/>
-                </a:solidFill>
-                <a:latin typeface="Sarabun"/>
-                <a:ea typeface="Sarabun"/>
-                <a:cs typeface="Sarabun"/>
-              </a:rPr>
-              <a:t>ผมอายุสามสิบปีครับ</a:t>
-            </a:r>
-            <a:r>
-              <a:rPr sz="1500" b="0" i="1" lang="en-US" altLang="en-US">
-                <a:solidFill>
-                  <a:srgbClr val="566873"/>
-                </a:solidFill>
-                <a:latin typeface="Sarabun"/>
-                <a:ea typeface="Sarabun"/>
-                <a:cs typeface="Sarabun"/>
-              </a:rPr>
-              <a:t> (phǒm aa-yú sǎam-sìp bpii khráp)</a:t>
-            </a:r>
-            <a:r>
-              <a:rPr sz="1500" b="0" i="0" lang="en-US" altLang="en-US">
-                <a:solidFill>
-                  <a:srgbClr val="24333D"/>
-                </a:solidFill>
-                <a:latin typeface="Sarabun"/>
-                <a:ea typeface="Sarabun"/>
-                <a:cs typeface="Sarabun"/>
-              </a:rPr>
-              <a:t>. Twenty-five? </a:t>
-            </a:r>
-            <a:r>
-              <a:rPr sz="1500" b="0" i="0" lang="th-TH" altLang="en-US">
-                <a:solidFill>
-                  <a:srgbClr val="24333D"/>
-                </a:solidFill>
-                <a:latin typeface="Sarabun"/>
-                <a:ea typeface="Sarabun"/>
-                <a:cs typeface="Sarabun"/>
-              </a:rPr>
-              <a:t>ฉัน</a:t>
-            </a:r>
-            <a:r>
-              <a:rPr sz="1500" b="0" i="1" lang="en-US" altLang="en-US">
-                <a:solidFill>
-                  <a:srgbClr val="566873"/>
-                </a:solidFill>
-                <a:latin typeface="Sarabun"/>
-                <a:ea typeface="Sarabun"/>
-                <a:cs typeface="Sarabun"/>
-              </a:rPr>
-              <a:t> (chǎn)</a:t>
-            </a:r>
-            <a:r>
-              <a:rPr sz="1500" b="0" i="0" lang="th-TH" altLang="en-US">
-                <a:solidFill>
-                  <a:srgbClr val="24333D"/>
-                </a:solidFill>
-                <a:latin typeface="Sarabun"/>
-                <a:ea typeface="Sarabun"/>
-                <a:cs typeface="Sarabun"/>
-              </a:rPr>
-              <a:t>อายุ</a:t>
-            </a:r>
-            <a:r>
-              <a:rPr sz="1500" b="0" i="1" lang="en-US" altLang="en-US">
-                <a:solidFill>
-                  <a:srgbClr val="566873"/>
-                </a:solidFill>
-                <a:latin typeface="Sarabun"/>
-                <a:ea typeface="Sarabun"/>
-                <a:cs typeface="Sarabun"/>
-              </a:rPr>
-              <a:t> (aa-yú)</a:t>
-            </a:r>
-            <a:r>
-              <a:rPr sz="1500" b="0" i="0" lang="th-TH" altLang="en-US">
-                <a:solidFill>
-                  <a:srgbClr val="24333D"/>
-                </a:solidFill>
-                <a:latin typeface="Sarabun"/>
-                <a:ea typeface="Sarabun"/>
-                <a:cs typeface="Sarabun"/>
-              </a:rPr>
-              <a:t>ยี่</a:t>
-            </a:r>
-            <a:r>
-              <a:rPr sz="1500" b="0" i="0" lang="th-TH" altLang="en-US">
-                <a:solidFill>
-                  <a:srgbClr val="24333D"/>
-                </a:solidFill>
-                <a:latin typeface="Sarabun"/>
-                <a:ea typeface="Sarabun"/>
-                <a:cs typeface="Sarabun"/>
-              </a:rPr>
-              <a:t>สิบ</a:t>
-            </a:r>
-            <a:r>
-              <a:rPr sz="1500" b="0" i="1" lang="en-US" altLang="en-US">
-                <a:solidFill>
-                  <a:srgbClr val="566873"/>
-                </a:solidFill>
-                <a:latin typeface="Sarabun"/>
-                <a:ea typeface="Sarabun"/>
-                <a:cs typeface="Sarabun"/>
-              </a:rPr>
-              <a:t> (sìp)</a:t>
-            </a:r>
-            <a:r>
-              <a:rPr sz="1500" b="0" i="0" lang="th-TH" altLang="en-US">
-                <a:solidFill>
-                  <a:srgbClr val="24333D"/>
-                </a:solidFill>
-                <a:latin typeface="Sarabun"/>
-                <a:ea typeface="Sarabun"/>
-                <a:cs typeface="Sarabun"/>
-              </a:rPr>
-              <a:t>ห้า</a:t>
-            </a:r>
-            <a:r>
-              <a:rPr sz="1500" b="0" i="1" lang="en-US" altLang="en-US">
-                <a:solidFill>
-                  <a:srgbClr val="566873"/>
-                </a:solidFill>
-                <a:latin typeface="Sarabun"/>
-                <a:ea typeface="Sarabun"/>
-                <a:cs typeface="Sarabun"/>
-              </a:rPr>
-              <a:t> (hâa)</a:t>
-            </a:r>
-            <a:r>
-              <a:rPr sz="1500" b="0" i="0" lang="th-TH" altLang="en-US">
-                <a:solidFill>
-                  <a:srgbClr val="24333D"/>
-                </a:solidFill>
-                <a:latin typeface="Sarabun"/>
-                <a:ea typeface="Sarabun"/>
-                <a:cs typeface="Sarabun"/>
-              </a:rPr>
-              <a:t>ปี</a:t>
-            </a:r>
-            <a:r>
-              <a:rPr sz="1500" b="0" i="1" lang="en-US" altLang="en-US">
-                <a:solidFill>
-                  <a:srgbClr val="566873"/>
-                </a:solidFill>
-                <a:latin typeface="Sarabun"/>
-                <a:ea typeface="Sarabun"/>
-                <a:cs typeface="Sarabun"/>
-              </a:rPr>
-              <a:t> (bpii)</a:t>
-            </a:r>
-            <a:r>
-              <a:rPr sz="1500" b="0" i="0" lang="th-TH" altLang="en-US">
-                <a:solidFill>
-                  <a:srgbClr val="24333D"/>
-                </a:solidFill>
-                <a:latin typeface="Sarabun"/>
-                <a:ea typeface="Sarabun"/>
-                <a:cs typeface="Sarabun"/>
-              </a:rPr>
-              <a:t>ค่ะ.</a:t>
-            </a:r>
-          </a:p>
-        </p:txBody>
-      </p:sp>
-      <p:sp>
-        <p:nvSpPr>
-          <p:cNvPr id="28" name="Oval 27"/>
-          <p:cNvSpPr/>
-          <p:nvPr/>
-        </p:nvSpPr>
-        <p:spPr>
-          <a:xfrm>
-            <a:off x="932688" y="7781544"/>
-            <a:ext cx="82296" cy="82296"/>
-          </a:xfrm>
-          <a:prstGeom prst="ellipse">
-            <a:avLst/>
-          </a:prstGeom>
-          <a:solidFill>
-            <a:srgbClr val="C96F4A"/>
-          </a:solidFill>
-          <a:ln>
-            <a:noFill/>
-          </a:ln>
-        </p:spPr>
-        <p:style>
-          <a:lnRef idx="1">
-            <a:schemeClr val="accent1"/>
-          </a:lnRef>
-          <a:fillRef idx="3">
-            <a:schemeClr val="accent1"/>
-          </a:fillRef>
-          <a:effectRef idx="2">
-            <a:schemeClr val="accent1"/>
-          </a:effectRef>
-          <a:fontRef idx="minor">
-            <a:schemeClr val="lt1"/>
-          </a:fontRef>
-        </p:style>
-        <p:txBody>
-          <a:bodyPr rtlCol="0" anchor="ctr"/>
-          <a:lstStyle/>
-          <a:p>
-            <a:pPr algn="ctr"/>
-          </a:p>
-        </p:txBody>
-      </p:sp>
-      <p:sp>
-        <p:nvSpPr>
-          <p:cNvPr id="29" name="TextBox 28"/>
-          <p:cNvSpPr txBox="1"/>
-          <p:nvPr/>
-        </p:nvSpPr>
-        <p:spPr>
-          <a:xfrm>
-            <a:off x="1078992" y="7690104"/>
-            <a:ext cx="9555480" cy="274320"/>
-          </a:xfrm>
-          <a:prstGeom prst="rect">
-            <a:avLst/>
-          </a:prstGeom>
-          <a:noFill/>
-        </p:spPr>
-        <p:txBody>
-          <a:bodyPr wrap="square" anchor="t">
-            <a:spAutoFit/>
-          </a:bodyPr>
-          <a:lstStyle/>
-          <a:p>
-            <a:pPr algn="l"/>
-            <a:r>
-              <a:rPr sz="1500" b="0" i="0" lang="th-TH" altLang="en-US">
-                <a:solidFill>
-                  <a:srgbClr val="24333D"/>
-                </a:solidFill>
-                <a:latin typeface="Sarabun"/>
-                <a:ea typeface="Sarabun"/>
-                <a:cs typeface="Sarabun"/>
-              </a:rPr>
-              <a:t>Pause-and-produce: someone asks คุณ</a:t>
-            </a:r>
-            <a:r>
-              <a:rPr sz="1500" b="0" i="0" lang="th-TH" altLang="en-US">
-                <a:solidFill>
-                  <a:srgbClr val="24333D"/>
-                </a:solidFill>
-                <a:latin typeface="Sarabun"/>
-                <a:ea typeface="Sarabun"/>
-                <a:cs typeface="Sarabun"/>
-              </a:rPr>
-              <a:t>อายุ</a:t>
-            </a:r>
-            <a:r>
-              <a:rPr sz="1500" b="0" i="1" lang="en-US" altLang="en-US">
-                <a:solidFill>
-                  <a:srgbClr val="566873"/>
-                </a:solidFill>
-                <a:latin typeface="Sarabun"/>
-                <a:ea typeface="Sarabun"/>
-                <a:cs typeface="Sarabun"/>
-              </a:rPr>
-              <a:t> (aa-yú)</a:t>
-            </a:r>
-            <a:r>
-              <a:rPr sz="1500" b="0" i="0" lang="th-TH" altLang="en-US">
-                <a:solidFill>
-                  <a:srgbClr val="24333D"/>
-                </a:solidFill>
-                <a:latin typeface="Sarabun"/>
-                <a:ea typeface="Sarabun"/>
-                <a:cs typeface="Sarabun"/>
-              </a:rPr>
-              <a:t>เท่าไหร่. Say your real age in Thai.</a:t>
             </a:r>
           </a:p>
         </p:txBody>
@@ -10233,17 +8738,11 @@
             <a:ext cx="3889080" cy="1572768"/>
           </a:xfrm>
           <a:prstGeom prst="roundRect">
-            <a:avLst>
-              <a:gd name="adj" fmla="val 6000"/>
-            </a:avLst>
-          </a:prstGeom>
-          <a:solidFill>
-            <a:srgbClr val="FFFFFF"/>
-          </a:solidFill>
+            <a:avLst/>
+          </a:prstGeom>
+          <a:noFill/>
           <a:ln>
-            <a:solidFill>
-              <a:srgbClr val="D7DEE3"/>
-            </a:solidFill>
+            <a:noFill/>
           </a:ln>
         </p:spPr>
         <p:style>
@@ -10335,7 +8834,7 @@
           <a:p>
             <a:pPr algn="l"/>
             <a:r>
-              <a:rPr sz="3200" b="1" i="0" lang="th-TH" altLang="en-US">
+              <a:rPr sz="3600" b="1" i="0" lang="th-TH" altLang="en-US">
                 <a:solidFill>
                   <a:srgbClr val="24333D"/>
                 </a:solidFill>
@@ -10346,7 +8845,7 @@
               <a:t>สี่</a:t>
             </a:r>
             <a:r>
-              <a:rPr sz="1980" b="0" i="1" lang="en-US" altLang="en-US">
+              <a:rPr sz="2230" b="0" i="1" lang="en-US" altLang="en-US">
                 <a:solidFill>
                   <a:srgbClr val="566873"/>
                 </a:solidFill>
@@ -10383,7 +8882,7 @@
           <a:p>
             <a:pPr algn="l"/>
             <a:r>
-              <a:rPr sz="1500" b="0" i="0" lang="en-US" altLang="en-US">
+              <a:rPr sz="1700" b="0" i="0" lang="en-US" altLang="en-US">
                 <a:solidFill>
                   <a:srgbClr val="82909A"/>
                 </a:solidFill>
@@ -10408,17 +8907,11 @@
             <a:ext cx="3889080" cy="1572768"/>
           </a:xfrm>
           <a:prstGeom prst="roundRect">
-            <a:avLst>
-              <a:gd name="adj" fmla="val 6000"/>
-            </a:avLst>
-          </a:prstGeom>
-          <a:solidFill>
-            <a:srgbClr val="FFFFFF"/>
-          </a:solidFill>
+            <a:avLst/>
+          </a:prstGeom>
+          <a:noFill/>
           <a:ln>
-            <a:solidFill>
-              <a:srgbClr val="D7DEE3"/>
-            </a:solidFill>
+            <a:noFill/>
           </a:ln>
         </p:spPr>
         <p:style>
@@ -10510,7 +9003,7 @@
           <a:p>
             <a:pPr algn="l"/>
             <a:r>
-              <a:rPr sz="3200" b="1" i="0" lang="th-TH" altLang="en-US">
+              <a:rPr sz="3600" b="1" i="0" lang="th-TH" altLang="en-US">
                 <a:solidFill>
                   <a:srgbClr val="24333D"/>
                 </a:solidFill>
@@ -10521,7 +9014,7 @@
               <a:t>สี</a:t>
             </a:r>
             <a:r>
-              <a:rPr sz="1980" b="0" i="1" lang="en-US" altLang="en-US">
+              <a:rPr sz="2230" b="0" i="1" lang="en-US" altLang="en-US">
                 <a:solidFill>
                   <a:srgbClr val="566873"/>
                 </a:solidFill>
@@ -10558,7 +9051,7 @@
           <a:p>
             <a:pPr algn="l"/>
             <a:r>
-              <a:rPr sz="1500" b="0" i="0" lang="en-US" altLang="en-US">
+              <a:rPr sz="1700" b="0" i="0" lang="en-US" altLang="en-US">
                 <a:solidFill>
                   <a:srgbClr val="82909A"/>
                 </a:solidFill>
@@ -10583,17 +9076,11 @@
             <a:ext cx="3889080" cy="1572768"/>
           </a:xfrm>
           <a:prstGeom prst="roundRect">
-            <a:avLst>
-              <a:gd name="adj" fmla="val 6000"/>
-            </a:avLst>
-          </a:prstGeom>
-          <a:solidFill>
-            <a:srgbClr val="FFFFFF"/>
-          </a:solidFill>
+            <a:avLst/>
+          </a:prstGeom>
+          <a:noFill/>
           <a:ln>
-            <a:solidFill>
-              <a:srgbClr val="D7DEE3"/>
-            </a:solidFill>
+            <a:noFill/>
           </a:ln>
         </p:spPr>
         <p:style>
@@ -10685,7 +9172,7 @@
           <a:p>
             <a:pPr algn="l"/>
             <a:r>
-              <a:rPr sz="3200" b="1" i="0" lang="th-TH" altLang="en-US">
+              <a:rPr sz="3600" b="1" i="0" lang="th-TH" altLang="en-US">
                 <a:solidFill>
                   <a:srgbClr val="24333D"/>
                 </a:solidFill>
@@ -10696,7 +9183,7 @@
               <a:t>เก้า</a:t>
             </a:r>
             <a:r>
-              <a:rPr sz="1980" b="0" i="1" lang="en-US" altLang="en-US">
+              <a:rPr sz="2230" b="0" i="1" lang="en-US" altLang="en-US">
                 <a:solidFill>
                   <a:srgbClr val="566873"/>
                 </a:solidFill>
@@ -10733,7 +9220,7 @@
           <a:p>
             <a:pPr algn="l"/>
             <a:r>
-              <a:rPr sz="1500" b="0" i="0" lang="en-US" altLang="en-US">
+              <a:rPr sz="1700" b="0" i="0" lang="en-US" altLang="en-US">
                 <a:solidFill>
                   <a:srgbClr val="82909A"/>
                 </a:solidFill>
@@ -10748,54 +9235,7 @@
       </p:sp>
       <p:sp>
         <p:nvSpPr>
-          <p:cNvPr id="18" name="Rounded Rectangle 17"/>
-          <p:cNvSpPr/>
-          <p:nvPr/>
-        </p:nvSpPr>
-        <p:spPr>
-          <a:xfrm>
-            <a:off x="731520" y="6775704"/>
-            <a:ext cx="10058400" cy="1289304"/>
-          </a:xfrm>
-          <a:prstGeom prst="roundRect">
-            <a:avLst>
-              <a:gd name="adj" fmla="val 6000"/>
-            </a:avLst>
-          </a:prstGeom>
-          <a:solidFill>
-            <a:srgbClr val="FFFFFF"/>
-          </a:solidFill>
-          <a:ln>
-            <a:solidFill>
-              <a:srgbClr val="D7DEE3"/>
-            </a:solidFill>
-          </a:ln>
-        </p:spPr>
-        <p:style>
-          <a:lnRef idx="1">
-            <a:schemeClr val="accent1"/>
-          </a:lnRef>
-          <a:fillRef idx="3">
-            <a:schemeClr val="accent1"/>
-          </a:fillRef>
-          <a:effectRef idx="2">
-            <a:schemeClr val="accent1"/>
-          </a:effectRef>
-          <a:fontRef idx="minor">
-            <a:schemeClr val="lt1"/>
-          </a:fontRef>
-        </p:style>
-        <p:txBody>
-          <a:bodyPr rtlCol="0" anchor="ctr"/>
-          <a:lstStyle/>
-          <a:p>
-            <a:pPr algn="ctr"/>
-          </a:p>
-        </p:txBody>
-      </p:sp>
-      <p:sp>
-        <p:nvSpPr>
-          <p:cNvPr id="19" name="TextBox 18"/>
+          <p:cNvPr id="18" name="TextBox 17"/>
           <p:cNvSpPr txBox="1"/>
           <p:nvPr/>
         </p:nvSpPr>
@@ -10817,7 +9257,7 @@
           <a:p>
             <a:pPr algn="l"/>
             <a:r>
-              <a:rPr sz="1500" b="1" i="0" lang="en-US" altLang="en-US">
+              <a:rPr sz="1700" b="1" i="0" lang="en-US" altLang="en-US">
                 <a:solidFill>
                   <a:srgbClr val="C96F4A"/>
                 </a:solidFill>
@@ -10832,7 +9272,7 @@
       </p:sp>
       <p:sp>
         <p:nvSpPr>
-          <p:cNvPr id="20" name="Oval 19"/>
+          <p:cNvPr id="19" name="Oval 18"/>
           <p:cNvSpPr/>
           <p:nvPr/>
         </p:nvSpPr>
@@ -10875,7 +9315,7 @@
       </p:sp>
       <p:sp>
         <p:nvSpPr>
-          <p:cNvPr id="21" name="TextBox 20"/>
+          <p:cNvPr id="20" name="TextBox 19"/>
           <p:cNvSpPr txBox="1"/>
           <p:nvPr/>
         </p:nvSpPr>
@@ -10897,7 +9337,7 @@
           <a:p>
             <a:pPr algn="l"/>
             <a:r>
-              <a:rPr sz="1500" b="0" i="0" lang="en-US" altLang="en-US">
+              <a:rPr sz="1700" b="0" i="0" lang="en-US" altLang="en-US">
                 <a:solidFill>
                   <a:srgbClr val="24333D"/>
                 </a:solidFill>
@@ -10908,7 +9348,7 @@
               <a:t>Tone echo: </a:t>
             </a:r>
             <a:r>
-              <a:rPr sz="1500" b="0" i="0" lang="th-TH" altLang="en-US">
+              <a:rPr sz="1700" b="0" i="0" lang="th-TH" altLang="en-US">
                 <a:solidFill>
                   <a:srgbClr val="24333D"/>
                 </a:solidFill>
@@ -10919,7 +9359,7 @@
               <a:t>สี่</a:t>
             </a:r>
             <a:r>
-              <a:rPr sz="1500" b="0" i="1" lang="en-US" altLang="en-US">
+              <a:rPr sz="1700" b="0" i="1" lang="en-US" altLang="en-US">
                 <a:solidFill>
                   <a:srgbClr val="566873"/>
                 </a:solidFill>
@@ -10930,7 +9370,7 @@
               <a:t> (sìi)</a:t>
             </a:r>
             <a:r>
-              <a:rPr sz="1500" b="0" i="0" lang="en-US" altLang="en-US">
+              <a:rPr sz="1700" b="0" i="0" lang="en-US" altLang="en-US">
                 <a:solidFill>
                   <a:srgbClr val="24333D"/>
                 </a:solidFill>
@@ -10941,7 +9381,7 @@
               <a:t> sìi — repeat low. </a:t>
             </a:r>
             <a:r>
-              <a:rPr sz="1500" b="0" i="0" lang="th-TH" altLang="en-US">
+              <a:rPr sz="1700" b="0" i="0" lang="th-TH" altLang="en-US">
                 <a:solidFill>
                   <a:srgbClr val="24333D"/>
                 </a:solidFill>
@@ -10952,7 +9392,7 @@
               <a:t>สี</a:t>
             </a:r>
             <a:r>
-              <a:rPr sz="1500" b="0" i="1" lang="en-US" altLang="en-US">
+              <a:rPr sz="1700" b="0" i="1" lang="en-US" altLang="en-US">
                 <a:solidFill>
                   <a:srgbClr val="566873"/>
                 </a:solidFill>
@@ -10963,7 +9403,7 @@
               <a:t> (sǐi)</a:t>
             </a:r>
             <a:r>
-              <a:rPr sz="1500" b="0" i="0" lang="en-US" altLang="en-US">
+              <a:rPr sz="1700" b="0" i="0" lang="en-US" altLang="en-US">
                 <a:solidFill>
                   <a:srgbClr val="24333D"/>
                 </a:solidFill>
@@ -10972,86 +9412,6 @@
                 <a:cs typeface="Sarabun"/>
               </a:rPr>
               <a:t> sǐi — repeat rising.</a:t>
-            </a:r>
-          </a:p>
-        </p:txBody>
-      </p:sp>
-      <p:sp>
-        <p:nvSpPr>
-          <p:cNvPr id="22" name="Oval 21"/>
-          <p:cNvSpPr/>
-          <p:nvPr/>
-        </p:nvSpPr>
-        <p:spPr>
-          <a:xfrm>
-            <a:off x="932688" y="7616952"/>
-            <a:ext cx="82296" cy="82296"/>
-          </a:xfrm>
-          <a:prstGeom prst="ellipse">
-            <a:avLst/>
-          </a:prstGeom>
-          <a:solidFill>
-            <a:srgbClr val="C96F4A"/>
-          </a:solidFill>
-          <a:ln>
-            <a:noFill/>
-          </a:ln>
-        </p:spPr>
-        <p:style>
-          <a:lnRef idx="1">
-            <a:schemeClr val="accent1"/>
-          </a:lnRef>
-          <a:fillRef idx="3">
-            <a:schemeClr val="accent1"/>
-          </a:fillRef>
-          <a:effectRef idx="2">
-            <a:schemeClr val="accent1"/>
-          </a:effectRef>
-          <a:fontRef idx="minor">
-            <a:schemeClr val="lt1"/>
-          </a:fontRef>
-        </p:style>
-        <p:txBody>
-          <a:bodyPr rtlCol="0" anchor="ctr"/>
-          <a:lstStyle/>
-          <a:p>
-            <a:pPr algn="ctr"/>
-          </a:p>
-        </p:txBody>
-      </p:sp>
-      <p:sp>
-        <p:nvSpPr>
-          <p:cNvPr id="23" name="TextBox 22"/>
-          <p:cNvSpPr txBox="1"/>
-          <p:nvPr/>
-        </p:nvSpPr>
-        <p:spPr>
-          <a:xfrm>
-            <a:off x="1078992" y="7525512"/>
-            <a:ext cx="9555480" cy="274320"/>
-          </a:xfrm>
-          <a:prstGeom prst="rect">
-            <a:avLst/>
-          </a:prstGeom>
-          <a:noFill/>
-        </p:spPr>
-        <p:txBody>
-          <a:bodyPr wrap="square" anchor="t">
-            <a:spAutoFit/>
-          </a:bodyPr>
-          <a:lstStyle/>
-          <a:p>
-            <a:pPr algn="l"/>
-            <a:r>
-              <a:rPr sz="1500" b="0" i="0" lang="en-US" altLang="en-US">
-                <a:solidFill>
-                  <a:srgbClr val="24333D"/>
-                </a:solidFill>
-                <a:latin typeface="Sarabun"/>
-                <a:ea typeface="Sarabun"/>
-                <a:cs typeface="Sarabun"/>
-              </a:rPr>
-              <a:t>Minimal pair: I say one. Is it four or colour? Answer before I show it.</a:t>
             </a:r>
           </a:p>
         </p:txBody>
@@ -11336,7 +9696,7 @@
           <a:p>
             <a:pPr algn="l"/>
             <a:r>
-              <a:rPr sz="2200" b="1" i="0" lang="th-TH" altLang="en-US">
+              <a:rPr sz="2600" b="1" i="0" lang="th-TH" altLang="en-US">
                 <a:solidFill>
                   <a:srgbClr val="24333D"/>
                 </a:solidFill>
@@ -11347,7 +9707,7 @@
               <a:t>สวัสดีครับ</a:t>
             </a:r>
             <a:r>
-              <a:rPr sz="1500" b="0" i="1" lang="en-US" altLang="en-US">
+              <a:rPr sz="1700" b="0" i="1" lang="en-US" altLang="en-US">
                 <a:solidFill>
                   <a:srgbClr val="566873"/>
                 </a:solidFill>
@@ -11477,7 +9837,7 @@
           <a:p>
             <a:pPr algn="l"/>
             <a:r>
-              <a:rPr sz="2200" b="1" i="0" lang="th-TH" altLang="en-US">
+              <a:rPr sz="2600" b="1" i="0" lang="th-TH" altLang="en-US">
                 <a:solidFill>
                   <a:srgbClr val="24333D"/>
                 </a:solidFill>
@@ -11488,7 +9848,7 @@
               <a:t>สวัสดีค่ะ เบอร์ห้องอะไรคะ</a:t>
             </a:r>
             <a:r>
-              <a:rPr sz="1500" b="0" i="1" lang="en-US" altLang="en-US">
+              <a:rPr sz="1700" b="0" i="1" lang="en-US" altLang="en-US">
                 <a:solidFill>
                   <a:srgbClr val="566873"/>
                 </a:solidFill>
@@ -11618,7 +9978,7 @@
           <a:p>
             <a:pPr algn="l"/>
             <a:r>
-              <a:rPr sz="2200" b="1" i="0" lang="th-TH" altLang="en-US">
+              <a:rPr sz="2600" b="1" i="0" lang="th-TH" altLang="en-US">
                 <a:solidFill>
                   <a:srgbClr val="24333D"/>
                 </a:solidFill>
@@ -11629,7 +9989,7 @@
               <a:t>ห้า-ศูนย์-สองครับ</a:t>
             </a:r>
             <a:r>
-              <a:rPr sz="1500" b="0" i="1" lang="en-US" altLang="en-US">
+              <a:rPr sz="1700" b="0" i="1" lang="en-US" altLang="en-US">
                 <a:solidFill>
                   <a:srgbClr val="566873"/>
                 </a:solidFill>
@@ -11759,7 +10119,7 @@
           <a:p>
             <a:pPr algn="l"/>
             <a:r>
-              <a:rPr sz="2200" b="1" i="0" lang="th-TH" altLang="en-US">
+              <a:rPr sz="2600" b="1" i="0" lang="th-TH" altLang="en-US">
                 <a:solidFill>
                   <a:srgbClr val="24333D"/>
                 </a:solidFill>
@@ -11770,7 +10130,7 @@
               <a:t>ค่ะ คุณอายุเท่าไหร่คะ</a:t>
             </a:r>
             <a:r>
-              <a:rPr sz="1500" b="0" i="1" lang="en-US" altLang="en-US">
+              <a:rPr sz="1700" b="0" i="1" lang="en-US" altLang="en-US">
                 <a:solidFill>
                   <a:srgbClr val="566873"/>
                 </a:solidFill>
@@ -11900,7 +10260,7 @@
           <a:p>
             <a:pPr algn="l"/>
             <a:r>
-              <a:rPr sz="2200" b="1" i="0" lang="th-TH" altLang="en-US">
+              <a:rPr sz="2600" b="1" i="0" lang="th-TH" altLang="en-US">
                 <a:solidFill>
                   <a:srgbClr val="24333D"/>
                 </a:solidFill>
@@ -11911,7 +10271,7 @@
               <a:t>ผมอายุสามสิบปีครับ</a:t>
             </a:r>
             <a:r>
-              <a:rPr sz="1500" b="0" i="1" lang="en-US" altLang="en-US">
+              <a:rPr sz="1700" b="0" i="1" lang="en-US" altLang="en-US">
                 <a:solidFill>
                   <a:srgbClr val="566873"/>
                 </a:solidFill>
@@ -12041,7 +10401,7 @@
           <a:p>
             <a:pPr algn="l"/>
             <a:r>
-              <a:rPr sz="2200" b="1" i="0" lang="th-TH" altLang="en-US">
+              <a:rPr sz="2600" b="1" i="0" lang="th-TH" altLang="en-US">
                 <a:solidFill>
                   <a:srgbClr val="24333D"/>
                 </a:solidFill>
@@ -12052,7 +10412,7 @@
               <a:t>ขอบคุณค่ะ</a:t>
             </a:r>
             <a:r>
-              <a:rPr sz="1500" b="0" i="1" lang="en-US" altLang="en-US">
+              <a:rPr sz="1700" b="0" i="1" lang="en-US" altLang="en-US">
                 <a:solidFill>
                   <a:srgbClr val="566873"/>
                 </a:solidFill>
@@ -12304,54 +10664,7 @@
       </p:sp>
       <p:sp>
         <p:nvSpPr>
-          <p:cNvPr id="6" name="Rounded Rectangle 5"/>
-          <p:cNvSpPr/>
-          <p:nvPr/>
-        </p:nvSpPr>
-        <p:spPr>
-          <a:xfrm>
-            <a:off x="731520" y="1417320"/>
-            <a:ext cx="7071055" cy="2331720"/>
-          </a:xfrm>
-          <a:prstGeom prst="roundRect">
-            <a:avLst>
-              <a:gd name="adj" fmla="val 6000"/>
-            </a:avLst>
-          </a:prstGeom>
-          <a:solidFill>
-            <a:srgbClr val="FFFFFF"/>
-          </a:solidFill>
-          <a:ln>
-            <a:solidFill>
-              <a:srgbClr val="D7DEE3"/>
-            </a:solidFill>
-          </a:ln>
-        </p:spPr>
-        <p:style>
-          <a:lnRef idx="1">
-            <a:schemeClr val="accent1"/>
-          </a:lnRef>
-          <a:fillRef idx="3">
-            <a:schemeClr val="accent1"/>
-          </a:fillRef>
-          <a:effectRef idx="2">
-            <a:schemeClr val="accent1"/>
-          </a:effectRef>
-          <a:fontRef idx="minor">
-            <a:schemeClr val="lt1"/>
-          </a:fontRef>
-        </p:style>
-        <p:txBody>
-          <a:bodyPr rtlCol="0" anchor="ctr"/>
-          <a:lstStyle/>
-          <a:p>
-            <a:pPr algn="ctr"/>
-          </a:p>
-        </p:txBody>
-      </p:sp>
-      <p:sp>
-        <p:nvSpPr>
-          <p:cNvPr id="7" name="TextBox 6"/>
+          <p:cNvPr id="6" name="TextBox 5"/>
           <p:cNvSpPr txBox="1"/>
           <p:nvPr/>
         </p:nvSpPr>
@@ -12373,7 +10686,7 @@
           <a:p>
             <a:pPr algn="l"/>
             <a:r>
-              <a:rPr sz="1500" b="1" i="0" lang="en-US" altLang="en-US">
+              <a:rPr sz="1700" b="1" i="0" lang="en-US" altLang="en-US">
                 <a:solidFill>
                   <a:srgbClr val="355C7D"/>
                 </a:solidFill>
@@ -12388,7 +10701,7 @@
       </p:sp>
       <p:sp>
         <p:nvSpPr>
-          <p:cNvPr id="8" name="Oval 7"/>
+          <p:cNvPr id="7" name="Oval 6"/>
           <p:cNvSpPr/>
           <p:nvPr/>
         </p:nvSpPr>
@@ -12431,7 +10744,7 @@
       </p:sp>
       <p:sp>
         <p:nvSpPr>
-          <p:cNvPr id="9" name="TextBox 8"/>
+          <p:cNvPr id="8" name="TextBox 7"/>
           <p:cNvSpPr txBox="1"/>
           <p:nvPr/>
         </p:nvSpPr>
@@ -12453,7 +10766,7 @@
           <a:p>
             <a:pPr algn="l"/>
             <a:r>
-              <a:rPr sz="1500" b="0" i="0" lang="en-US" altLang="en-US">
+              <a:rPr sz="1700" b="0" i="0" lang="en-US" altLang="en-US">
                 <a:solidFill>
                   <a:srgbClr val="24333D"/>
                 </a:solidFill>
@@ -12468,7 +10781,7 @@
       </p:sp>
       <p:sp>
         <p:nvSpPr>
-          <p:cNvPr id="10" name="Oval 9"/>
+          <p:cNvPr id="9" name="Oval 8"/>
           <p:cNvSpPr/>
           <p:nvPr/>
         </p:nvSpPr>
@@ -12511,7 +10824,7 @@
       </p:sp>
       <p:sp>
         <p:nvSpPr>
-          <p:cNvPr id="11" name="TextBox 10"/>
+          <p:cNvPr id="10" name="TextBox 9"/>
           <p:cNvSpPr txBox="1"/>
           <p:nvPr/>
         </p:nvSpPr>
@@ -12533,7 +10846,7 @@
           <a:p>
             <a:pPr algn="l"/>
             <a:r>
-              <a:rPr sz="1500" b="0" i="0" lang="en-US" altLang="en-US">
+              <a:rPr sz="1700" b="0" i="0" lang="en-US" altLang="en-US">
                 <a:solidFill>
                   <a:srgbClr val="24333D"/>
                 </a:solidFill>
@@ -12548,7 +10861,7 @@
       </p:sp>
       <p:sp>
         <p:nvSpPr>
-          <p:cNvPr id="12" name="Oval 11"/>
+          <p:cNvPr id="11" name="Oval 10"/>
           <p:cNvSpPr/>
           <p:nvPr/>
         </p:nvSpPr>
@@ -12591,7 +10904,7 @@
       </p:sp>
       <p:sp>
         <p:nvSpPr>
-          <p:cNvPr id="13" name="TextBox 12"/>
+          <p:cNvPr id="12" name="TextBox 11"/>
           <p:cNvSpPr txBox="1"/>
           <p:nvPr/>
         </p:nvSpPr>
@@ -12613,7 +10926,7 @@
           <a:p>
             <a:pPr algn="l"/>
             <a:r>
-              <a:rPr sz="1500" b="0" i="0" lang="en-US" altLang="en-US">
+              <a:rPr sz="1700" b="0" i="0" lang="en-US" altLang="en-US">
                 <a:solidFill>
                   <a:srgbClr val="24333D"/>
                 </a:solidFill>
@@ -12624,7 +10937,7 @@
               <a:t>Ask 'what number?' </a:t>
             </a:r>
             <a:r>
-              <a:rPr sz="1500" b="0" i="0" lang="th-TH" altLang="en-US">
+              <a:rPr sz="1700" b="0" i="0" lang="th-TH" altLang="en-US">
                 <a:solidFill>
                   <a:srgbClr val="24333D"/>
                 </a:solidFill>
@@ -12635,7 +10948,7 @@
               <a:t>เบอร์อะไร</a:t>
             </a:r>
             <a:r>
-              <a:rPr sz="1500" b="0" i="1" lang="en-US" altLang="en-US">
+              <a:rPr sz="1700" b="0" i="1" lang="en-US" altLang="en-US">
                 <a:solidFill>
                   <a:srgbClr val="566873"/>
                 </a:solidFill>
@@ -12646,7 +10959,7 @@
               <a:t> (ber à-rai)</a:t>
             </a:r>
             <a:r>
-              <a:rPr sz="1500" b="0" i="0" lang="en-US" altLang="en-US">
+              <a:rPr sz="1700" b="0" i="0" lang="en-US" altLang="en-US">
                 <a:solidFill>
                   <a:srgbClr val="24333D"/>
                 </a:solidFill>
@@ -12661,7 +10974,7 @@
       </p:sp>
       <p:sp>
         <p:nvSpPr>
-          <p:cNvPr id="14" name="Oval 13"/>
+          <p:cNvPr id="13" name="Oval 12"/>
           <p:cNvSpPr/>
           <p:nvPr/>
         </p:nvSpPr>
@@ -12704,7 +11017,7 @@
       </p:sp>
       <p:sp>
         <p:nvSpPr>
-          <p:cNvPr id="15" name="TextBox 14"/>
+          <p:cNvPr id="14" name="TextBox 13"/>
           <p:cNvSpPr txBox="1"/>
           <p:nvPr/>
         </p:nvSpPr>
@@ -12726,7 +11039,7 @@
           <a:p>
             <a:pPr algn="l"/>
             <a:r>
-              <a:rPr sz="1500" b="0" i="0" lang="en-US" altLang="en-US">
+              <a:rPr sz="1700" b="0" i="0" lang="en-US" altLang="en-US">
                 <a:solidFill>
                   <a:srgbClr val="24333D"/>
                 </a:solidFill>
@@ -12741,7 +11054,7 @@
       </p:sp>
       <p:sp>
         <p:nvSpPr>
-          <p:cNvPr id="16" name="Oval 15"/>
+          <p:cNvPr id="15" name="Oval 14"/>
           <p:cNvSpPr/>
           <p:nvPr/>
         </p:nvSpPr>
@@ -12784,7 +11097,7 @@
       </p:sp>
       <p:sp>
         <p:nvSpPr>
-          <p:cNvPr id="17" name="TextBox 16"/>
+          <p:cNvPr id="16" name="TextBox 15"/>
           <p:cNvSpPr txBox="1"/>
           <p:nvPr/>
         </p:nvSpPr>
@@ -12806,7 +11119,7 @@
           <a:p>
             <a:pPr algn="l"/>
             <a:r>
-              <a:rPr sz="1500" b="0" i="0" lang="th-TH" altLang="en-US">
+              <a:rPr sz="1700" b="0" i="0" lang="th-TH" altLang="en-US">
                 <a:solidFill>
                   <a:srgbClr val="24333D"/>
                 </a:solidFill>
@@ -12817,7 +11130,7 @@
               <a:t>สี่</a:t>
             </a:r>
             <a:r>
-              <a:rPr sz="1500" b="0" i="1" lang="en-US" altLang="en-US">
+              <a:rPr sz="1700" b="0" i="1" lang="en-US" altLang="en-US">
                 <a:solidFill>
                   <a:srgbClr val="566873"/>
                 </a:solidFill>
@@ -12828,7 +11141,7 @@
               <a:t> (sìi)</a:t>
             </a:r>
             <a:r>
-              <a:rPr sz="1500" b="0" i="0" lang="en-US" altLang="en-US">
+              <a:rPr sz="1700" b="0" i="0" lang="en-US" altLang="en-US">
                 <a:solidFill>
                   <a:srgbClr val="24333D"/>
                 </a:solidFill>
@@ -12843,54 +11156,7 @@
       </p:sp>
       <p:sp>
         <p:nvSpPr>
-          <p:cNvPr id="18" name="Rounded Rectangle 17"/>
-          <p:cNvSpPr/>
-          <p:nvPr/>
-        </p:nvSpPr>
-        <p:spPr>
-          <a:xfrm>
-            <a:off x="731520" y="4160520"/>
-            <a:ext cx="10058400" cy="1289304"/>
-          </a:xfrm>
-          <a:prstGeom prst="roundRect">
-            <a:avLst>
-              <a:gd name="adj" fmla="val 6000"/>
-            </a:avLst>
-          </a:prstGeom>
-          <a:solidFill>
-            <a:srgbClr val="FFFFFF"/>
-          </a:solidFill>
-          <a:ln>
-            <a:solidFill>
-              <a:srgbClr val="D7DEE3"/>
-            </a:solidFill>
-          </a:ln>
-        </p:spPr>
-        <p:style>
-          <a:lnRef idx="1">
-            <a:schemeClr val="accent1"/>
-          </a:lnRef>
-          <a:fillRef idx="3">
-            <a:schemeClr val="accent1"/>
-          </a:fillRef>
-          <a:effectRef idx="2">
-            <a:schemeClr val="accent1"/>
-          </a:effectRef>
-          <a:fontRef idx="minor">
-            <a:schemeClr val="lt1"/>
-          </a:fontRef>
-        </p:style>
-        <p:txBody>
-          <a:bodyPr rtlCol="0" anchor="ctr"/>
-          <a:lstStyle/>
-          <a:p>
-            <a:pPr algn="ctr"/>
-          </a:p>
-        </p:txBody>
-      </p:sp>
-      <p:sp>
-        <p:nvSpPr>
-          <p:cNvPr id="19" name="TextBox 18"/>
+          <p:cNvPr id="17" name="TextBox 16"/>
           <p:cNvSpPr txBox="1"/>
           <p:nvPr/>
         </p:nvSpPr>
@@ -12912,7 +11178,7 @@
           <a:p>
             <a:pPr algn="l"/>
             <a:r>
-              <a:rPr sz="1500" b="1" i="0" lang="en-US" altLang="en-US">
+              <a:rPr sz="1700" b="1" i="0" lang="en-US" altLang="en-US">
                 <a:solidFill>
                   <a:srgbClr val="7A8F54"/>
                 </a:solidFill>
@@ -12927,7 +11193,7 @@
       </p:sp>
       <p:sp>
         <p:nvSpPr>
-          <p:cNvPr id="20" name="Oval 19"/>
+          <p:cNvPr id="18" name="Oval 17"/>
           <p:cNvSpPr/>
           <p:nvPr/>
         </p:nvSpPr>
@@ -12970,7 +11236,7 @@
       </p:sp>
       <p:sp>
         <p:nvSpPr>
-          <p:cNvPr id="21" name="TextBox 20"/>
+          <p:cNvPr id="19" name="TextBox 18"/>
           <p:cNvSpPr txBox="1"/>
           <p:nvPr/>
         </p:nvSpPr>
@@ -12992,7 +11258,7 @@
           <a:p>
             <a:pPr algn="l"/>
             <a:r>
-              <a:rPr sz="1500" b="0" i="0" lang="th-TH" altLang="en-US">
+              <a:rPr sz="1700" b="0" i="0" lang="th-TH" altLang="en-US">
                 <a:solidFill>
                   <a:srgbClr val="24333D"/>
                 </a:solidFill>
@@ -13003,7 +11269,7 @@
               <a:t>สี่</a:t>
             </a:r>
             <a:r>
-              <a:rPr sz="1500" b="0" i="1" lang="en-US" altLang="en-US">
+              <a:rPr sz="1700" b="0" i="1" lang="en-US" altLang="en-US">
                 <a:solidFill>
                   <a:srgbClr val="566873"/>
                 </a:solidFill>
@@ -13014,7 +11280,7 @@
               <a:t> (sìi)</a:t>
             </a:r>
             <a:r>
-              <a:rPr sz="1500" b="0" i="0" lang="en-US" altLang="en-US">
+              <a:rPr sz="1700" b="0" i="0" lang="en-US" altLang="en-US">
                 <a:solidFill>
                   <a:srgbClr val="24333D"/>
                 </a:solidFill>
@@ -13229,54 +11495,7 @@
       </p:sp>
       <p:sp>
         <p:nvSpPr>
-          <p:cNvPr id="6" name="Rounded Rectangle 5"/>
-          <p:cNvSpPr/>
-          <p:nvPr/>
-        </p:nvSpPr>
-        <p:spPr>
-          <a:xfrm>
-            <a:off x="731520" y="1600200"/>
-            <a:ext cx="7071055" cy="1289304"/>
-          </a:xfrm>
-          <a:prstGeom prst="roundRect">
-            <a:avLst>
-              <a:gd name="adj" fmla="val 6000"/>
-            </a:avLst>
-          </a:prstGeom>
-          <a:solidFill>
-            <a:srgbClr val="FFFFFF"/>
-          </a:solidFill>
-          <a:ln>
-            <a:solidFill>
-              <a:srgbClr val="D7DEE3"/>
-            </a:solidFill>
-          </a:ln>
-        </p:spPr>
-        <p:style>
-          <a:lnRef idx="1">
-            <a:schemeClr val="accent1"/>
-          </a:lnRef>
-          <a:fillRef idx="3">
-            <a:schemeClr val="accent1"/>
-          </a:fillRef>
-          <a:effectRef idx="2">
-            <a:schemeClr val="accent1"/>
-          </a:effectRef>
-          <a:fontRef idx="minor">
-            <a:schemeClr val="lt1"/>
-          </a:fontRef>
-        </p:style>
-        <p:txBody>
-          <a:bodyPr rtlCol="0" anchor="ctr"/>
-          <a:lstStyle/>
-          <a:p>
-            <a:pPr algn="ctr"/>
-          </a:p>
-        </p:txBody>
-      </p:sp>
-      <p:sp>
-        <p:nvSpPr>
-          <p:cNvPr id="7" name="TextBox 6"/>
+          <p:cNvPr id="6" name="TextBox 5"/>
           <p:cNvSpPr txBox="1"/>
           <p:nvPr/>
         </p:nvSpPr>
@@ -13298,7 +11517,7 @@
           <a:p>
             <a:pPr algn="l"/>
             <a:r>
-              <a:rPr sz="1500" b="1" i="0" lang="en-US" altLang="en-US">
+              <a:rPr sz="1700" b="1" i="0" lang="en-US" altLang="en-US">
                 <a:solidFill>
                   <a:srgbClr val="C96F4A"/>
                 </a:solidFill>
@@ -13313,7 +11532,7 @@
       </p:sp>
       <p:sp>
         <p:nvSpPr>
-          <p:cNvPr id="8" name="Oval 7"/>
+          <p:cNvPr id="7" name="Oval 6"/>
           <p:cNvSpPr/>
           <p:nvPr/>
         </p:nvSpPr>
@@ -13356,7 +11575,7 @@
       </p:sp>
       <p:sp>
         <p:nvSpPr>
-          <p:cNvPr id="9" name="TextBox 8"/>
+          <p:cNvPr id="8" name="TextBox 7"/>
           <p:cNvSpPr txBox="1"/>
           <p:nvPr/>
         </p:nvSpPr>
@@ -13378,7 +11597,7 @@
           <a:p>
             <a:pPr algn="l"/>
             <a:r>
-              <a:rPr sz="1500" b="0" i="0" lang="en-US" altLang="en-US">
+              <a:rPr sz="1700" b="0" i="0" lang="en-US" altLang="en-US">
                 <a:solidFill>
                   <a:srgbClr val="24333D"/>
                 </a:solidFill>
@@ -13393,7 +11612,7 @@
       </p:sp>
       <p:sp>
         <p:nvSpPr>
-          <p:cNvPr id="10" name="Oval 9"/>
+          <p:cNvPr id="9" name="Oval 8"/>
           <p:cNvSpPr/>
           <p:nvPr/>
         </p:nvSpPr>
@@ -13436,7 +11655,7 @@
       </p:sp>
       <p:sp>
         <p:nvSpPr>
-          <p:cNvPr id="11" name="TextBox 10"/>
+          <p:cNvPr id="10" name="TextBox 9"/>
           <p:cNvSpPr txBox="1"/>
           <p:nvPr/>
         </p:nvSpPr>
@@ -13458,7 +11677,7 @@
           <a:p>
             <a:pPr algn="l"/>
             <a:r>
-              <a:rPr sz="1500" b="0" i="0" lang="en-US" altLang="en-US">
+              <a:rPr sz="1700" b="0" i="0" lang="en-US" altLang="en-US">
                 <a:solidFill>
                   <a:srgbClr val="24333D"/>
                 </a:solidFill>

</xml_diff>